<commit_message>
Report deck: real fire stats, region=Changwon, red inaccessible routes
Rework PART 1 of the light report deck around the uploaded National Fire Data
Platform stats (last 12 months, Gyeongnam by district):
- STEP 02 region selection: Changwon = 563 fires (highest in Gyeongnam,
  15.8% of total) -> chosen as target region; chart highlights Changwon in red
- STEP 03 new map slide: plot fire points, trace routes, and draw fire-truck
  -inaccessible (<4m) segments as red lines
- STEP 04 uses real Changwon by-district counts (Uichang 126 / Jinhae 117 /
  Masanhappo 116 / Seongsan 116 / Masanhoewon 88); composite risk keeps the
  old-town ranking consistent with the Masan station choice

Co-Authored-By: Claude Opus 4.8 <noreply@anthropic.com>
Claude-Session: https://claude.ai/code/session_01TYua8MWbjkcnNvFDubmny6
</commit_message>
<xml_diff>
--- a/presentation/화재빅데이터_드론배치_분석리포트.pptx
+++ b/presentation/화재빅데이터_드론배치_분석리포트.pptx
@@ -160,6 +160,337 @@
               <a:lstStyle/>
               <a:p>
                 <a:pPr>
+                  <a:defRPr b="1" i="0" strike="noStrike" sz="1150" u="none">
+                    <a:solidFill>
+                      <a:srgbClr val="0F172A"/>
+                    </a:solidFill>
+                    <a:latin typeface="Consolas"/>
+                  </a:defRPr>
+                </a:pPr>
+              </a:p>
+            </c:txPr>
+            <c:showLegendKey val="0"/>
+            <c:showVal val="1"/>
+            <c:showCatName val="0"/>
+            <c:showSerName val="0"/>
+            <c:showPercent val="0"/>
+            <c:showBubbleSize val="0"/>
+            <c:showLeaderLines val="0"/>
+          </c:dLbls>
+          <c:dPt>
+            <c:idx val="0"/>
+            <c:invertIfNegative val="0"/>
+            <c:bubble3D val="0"/>
+            <c:spPr>
+              <a:solidFill>
+                <a:srgbClr val="DC2626"/>
+              </a:solidFill>
+              <a:effectLst/>
+            </c:spPr>
+          </c:dPt>
+          <c:dPt>
+            <c:idx val="1"/>
+            <c:invertIfNegative val="0"/>
+            <c:bubble3D val="0"/>
+            <c:spPr>
+              <a:solidFill>
+                <a:srgbClr val="93C5FD"/>
+              </a:solidFill>
+              <a:effectLst/>
+            </c:spPr>
+          </c:dPt>
+          <c:dPt>
+            <c:idx val="2"/>
+            <c:invertIfNegative val="0"/>
+            <c:bubble3D val="0"/>
+            <c:spPr>
+              <a:solidFill>
+                <a:srgbClr val="93C5FD"/>
+              </a:solidFill>
+              <a:effectLst/>
+            </c:spPr>
+          </c:dPt>
+          <c:dPt>
+            <c:idx val="3"/>
+            <c:invertIfNegative val="0"/>
+            <c:bubble3D val="0"/>
+            <c:spPr>
+              <a:solidFill>
+                <a:srgbClr val="93C5FD"/>
+              </a:solidFill>
+              <a:effectLst/>
+            </c:spPr>
+          </c:dPt>
+          <c:dPt>
+            <c:idx val="4"/>
+            <c:invertIfNegative val="0"/>
+            <c:bubble3D val="0"/>
+            <c:spPr>
+              <a:solidFill>
+                <a:srgbClr val="93C5FD"/>
+              </a:solidFill>
+              <a:effectLst/>
+            </c:spPr>
+          </c:dPt>
+          <c:dPt>
+            <c:idx val="5"/>
+            <c:invertIfNegative val="0"/>
+            <c:bubble3D val="0"/>
+            <c:spPr>
+              <a:solidFill>
+                <a:srgbClr val="93C5FD"/>
+              </a:solidFill>
+              <a:effectLst/>
+            </c:spPr>
+          </c:dPt>
+          <c:dPt>
+            <c:idx val="6"/>
+            <c:invertIfNegative val="0"/>
+            <c:bubble3D val="0"/>
+            <c:spPr>
+              <a:solidFill>
+                <a:srgbClr val="93C5FD"/>
+              </a:solidFill>
+              <a:effectLst/>
+            </c:spPr>
+          </c:dPt>
+          <c:cat>
+            <c:multiLvlStrRef>
+              <c:f>Sheet1!$A$2:$A$8</c:f>
+              <c:multiLvlStrCache>
+                <c:ptCount val="7"/>
+                <c:lvl>
+                  <c:pt idx="0">
+                    <c:v>창원시</c:v>
+                  </c:pt>
+                  <c:pt idx="1">
+                    <c:v>김해시</c:v>
+                  </c:pt>
+                  <c:pt idx="2">
+                    <c:v>진주시</c:v>
+                  </c:pt>
+                  <c:pt idx="3">
+                    <c:v>양산시</c:v>
+                  </c:pt>
+                  <c:pt idx="4">
+                    <c:v>밀양시</c:v>
+                  </c:pt>
+                  <c:pt idx="5">
+                    <c:v>함안군</c:v>
+                  </c:pt>
+                  <c:pt idx="6">
+                    <c:v>거제시</c:v>
+                  </c:pt>
+                </c:lvl>
+              </c:multiLvlStrCache>
+            </c:multiLvlStrRef>
+          </c:cat>
+          <c:val>
+            <c:numRef>
+              <c:f>Sheet1!$B$2:$B$8</c:f>
+              <c:numCache>
+                <c:formatCode>General</c:formatCode>
+                <c:ptCount val="7"/>
+                <c:pt idx="0">
+                  <c:v>563</c:v>
+                </c:pt>
+                <c:pt idx="1">
+                  <c:v>457</c:v>
+                </c:pt>
+                <c:pt idx="2">
+                  <c:v>318</c:v>
+                </c:pt>
+                <c:pt idx="3">
+                  <c:v>271</c:v>
+                </c:pt>
+                <c:pt idx="4">
+                  <c:v>239</c:v>
+                </c:pt>
+                <c:pt idx="5">
+                  <c:v>193</c:v>
+                </c:pt>
+                <c:pt idx="6">
+                  <c:v>187</c:v>
+                </c:pt>
+              </c:numCache>
+            </c:numRef>
+          </c:val>
+        </c:ser>
+        <c:dLbls>
+          <c:numFmt formatCode="#,##0" sourceLinked="0"/>
+          <c:txPr>
+            <a:bodyPr/>
+            <a:lstStyle/>
+            <a:p>
+              <a:pPr>
+                <a:defRPr b="1" i="0" strike="noStrike" sz="1150" u="none">
+                  <a:solidFill>
+                    <a:srgbClr val="0F172A"/>
+                  </a:solidFill>
+                  <a:latin typeface="Consolas"/>
+                </a:defRPr>
+              </a:pPr>
+            </a:p>
+          </c:txPr>
+          <c:showLegendKey val="0"/>
+          <c:showVal val="1"/>
+          <c:showCatName val="0"/>
+          <c:showSerName val="0"/>
+          <c:showPercent val="0"/>
+          <c:showBubbleSize val="0"/>
+          <c:showLeaderLines val="0"/>
+        </c:dLbls>
+        <c:gapWidth val="45"/>
+        <c:overlap val="0"/>
+        <c:axId val="2094734554"/>
+        <c:axId val="2094734552"/>
+        <c:axId val="2094734556"/>
+      </c:barChart>
+      <c:catAx>
+        <c:axId val="2094734554"/>
+        <c:scaling>
+          <c:orientation val="minMax"/>
+        </c:scaling>
+        <c:delete val="0"/>
+        <c:axPos val="b"/>
+        <c:numFmt formatCode="General" sourceLinked="1"/>
+        <c:majorTickMark val="out"/>
+        <c:minorTickMark val="none"/>
+        <c:tickLblPos val="low"/>
+        <c:spPr>
+          <a:ln w="12700" cap="flat">
+            <a:solidFill>
+              <a:srgbClr val="CBD5E1"/>
+            </a:solidFill>
+            <a:prstDash val="solid"/>
+            <a:round/>
+          </a:ln>
+        </c:spPr>
+        <c:txPr>
+          <a:bodyPr/>
+          <a:lstStyle/>
+          <a:p>
+            <a:pPr>
+              <a:defRPr sz="1100" b="0" i="0" u="none" strike="noStrike">
+                <a:solidFill>
+                  <a:srgbClr val="334155"/>
+                </a:solidFill>
+                <a:latin typeface="Malgun Gothic"/>
+              </a:defRPr>
+            </a:pPr>
+            <a:endParaRPr lang="en-US"/>
+          </a:p>
+        </c:txPr>
+        <c:crossAx val="2094734552"/>
+        <c:crosses val="autoZero"/>
+        <c:auto val="1"/>
+        <c:lblAlgn val="ctr"/>
+        <c:noMultiLvlLbl val="1"/>
+      </c:catAx>
+      <c:valAx>
+        <c:axId val="2094734552"/>
+        <c:scaling>
+          <c:orientation val="minMax"/>
+          <c:max val="640"/>
+        </c:scaling>
+        <c:delete val="1"/>
+        <c:axPos val="l"/>
+        <c:numFmt formatCode="General" sourceLinked="0"/>
+        <c:majorTickMark val="out"/>
+        <c:minorTickMark val="none"/>
+        <c:tickLblPos val="nextTo"/>
+        <c:spPr>
+          <a:ln w="12700" cap="flat">
+            <a:solidFill>
+              <a:srgbClr val="888888"/>
+            </a:solidFill>
+            <a:prstDash val="solid"/>
+            <a:round/>
+          </a:ln>
+        </c:spPr>
+        <c:txPr>
+          <a:bodyPr/>
+          <a:lstStyle/>
+          <a:p>
+            <a:pPr>
+              <a:defRPr sz="1200" b="0" i="0" u="none" strike="noStrike">
+                <a:solidFill>
+                  <a:srgbClr val="000000"/>
+                </a:solidFill>
+                <a:latin typeface="Arial"/>
+              </a:defRPr>
+            </a:pPr>
+            <a:endParaRPr lang="en-US"/>
+          </a:p>
+        </c:txPr>
+        <c:crossAx val="2094734554"/>
+        <c:crosses val="autoZero"/>
+        <c:crossBetween val="between"/>
+      </c:valAx>
+      <c:spPr>
+        <a:noFill/>
+        <a:ln>
+          <a:noFill/>
+        </a:ln>
+        <a:effectLst/>
+      </c:spPr>
+    </c:plotArea>
+    <c:plotVisOnly val="1"/>
+    <c:dispBlanksAs val="span"/>
+  </c:chart>
+  <c:spPr>
+    <a:noFill/>
+    <a:ln>
+      <a:noFill/>
+    </a:ln>
+    <a:effectLst/>
+  </c:spPr>
+  <c:externalData r:id="rId1">
+    <c:autoUpdate val="0"/>
+  </c:externalData>
+</c:chartSpace>
+</file>
+
+<file path=ppt/charts/chart2.xml><?xml version="1.0" encoding="utf-8"?>
+<c:chartSpace xmlns:c="http://schemas.openxmlformats.org/drawingml/2006/chart" xmlns:a="http://schemas.openxmlformats.org/drawingml/2006/main" xmlns:r="http://schemas.openxmlformats.org/officeDocument/2006/relationships">
+  <c:date1904 val="0"/>
+  <c:roundedCorners val="1"/>
+  <c:chart>
+    <c:autoTitleDeleted val="1"/>
+    <c:plotArea>
+      <c:layout/>
+      <c:barChart>
+        <c:barDir val="col"/>
+        <c:grouping val="clustered"/>
+        <c:varyColors val="0"/>
+        <c:ser>
+          <c:idx val="0"/>
+          <c:order val="0"/>
+          <c:tx>
+            <c:strRef>
+              <c:f>Sheet1!$B$1</c:f>
+              <c:strCache>
+                <c:ptCount val="1"/>
+                <c:pt idx="0">
+                  <c:v>화재건수</c:v>
+                </c:pt>
+              </c:strCache>
+            </c:strRef>
+          </c:tx>
+          <c:spPr>
+            <a:solidFill>
+              <a:srgbClr val="EA580C"/>
+            </a:solidFill>
+            <a:effectLst/>
+          </c:spPr>
+          <c:invertIfNegative val="0"/>
+          <c:dLbls>
+            <c:numFmt formatCode="#,##0" sourceLinked="0"/>
+            <c:txPr>
+              <a:bodyPr/>
+              <a:lstStyle/>
+              <a:p>
+                <a:pPr>
                   <a:defRPr b="1" i="0" strike="noStrike" sz="1200" u="none">
                     <a:solidFill>
                       <a:srgbClr val="0F172A"/>
@@ -184,19 +515,19 @@
                 <c:ptCount val="5"/>
                 <c:lvl>
                   <c:pt idx="0">
-                    <c:v>마산합포구</c:v>
+                    <c:v>의창구</c:v>
                   </c:pt>
                   <c:pt idx="1">
                     <c:v>진해구</c:v>
                   </c:pt>
                   <c:pt idx="2">
-                    <c:v>마산회원구</c:v>
+                    <c:v>마산합포구</c:v>
                   </c:pt>
                   <c:pt idx="3">
                     <c:v>성산구</c:v>
                   </c:pt>
                   <c:pt idx="4">
-                    <c:v>의창구</c:v>
+                    <c:v>마산회원구</c:v>
                   </c:pt>
                 </c:lvl>
               </c:multiLvlStrCache>
@@ -209,19 +540,19 @@
                 <c:formatCode>General</c:formatCode>
                 <c:ptCount val="5"/>
                 <c:pt idx="0">
-                  <c:v>128</c:v>
+                  <c:v>126</c:v>
                 </c:pt>
                 <c:pt idx="1">
-                  <c:v>96</c:v>
+                  <c:v>117</c:v>
                 </c:pt>
                 <c:pt idx="2">
-                  <c:v>84</c:v>
+                  <c:v>116</c:v>
                 </c:pt>
                 <c:pt idx="3">
-                  <c:v>61</c:v>
+                  <c:v>116</c:v>
                 </c:pt>
                 <c:pt idx="4">
-                  <c:v>47</c:v>
+                  <c:v>88</c:v>
                 </c:pt>
               </c:numCache>
             </c:numRef>
@@ -302,249 +633,7 @@
         <c:axId val="2094734552"/>
         <c:scaling>
           <c:orientation val="minMax"/>
-          <c:max val="150"/>
-        </c:scaling>
-        <c:delete val="1"/>
-        <c:axPos val="l"/>
-        <c:numFmt formatCode="General" sourceLinked="0"/>
-        <c:majorTickMark val="out"/>
-        <c:minorTickMark val="none"/>
-        <c:tickLblPos val="nextTo"/>
-        <c:spPr>
-          <a:ln w="12700" cap="flat">
-            <a:solidFill>
-              <a:srgbClr val="888888"/>
-            </a:solidFill>
-            <a:prstDash val="solid"/>
-            <a:round/>
-          </a:ln>
-        </c:spPr>
-        <c:txPr>
-          <a:bodyPr/>
-          <a:lstStyle/>
-          <a:p>
-            <a:pPr>
-              <a:defRPr sz="1200" b="0" i="0" u="none" strike="noStrike">
-                <a:solidFill>
-                  <a:srgbClr val="000000"/>
-                </a:solidFill>
-                <a:latin typeface="Arial"/>
-              </a:defRPr>
-            </a:pPr>
-            <a:endParaRPr lang="en-US"/>
-          </a:p>
-        </c:txPr>
-        <c:crossAx val="2094734554"/>
-        <c:crosses val="autoZero"/>
-        <c:crossBetween val="between"/>
-      </c:valAx>
-      <c:spPr>
-        <a:noFill/>
-        <a:ln>
-          <a:noFill/>
-        </a:ln>
-        <a:effectLst/>
-      </c:spPr>
-    </c:plotArea>
-    <c:plotVisOnly val="1"/>
-    <c:dispBlanksAs val="span"/>
-  </c:chart>
-  <c:spPr>
-    <a:noFill/>
-    <a:ln>
-      <a:noFill/>
-    </a:ln>
-    <a:effectLst/>
-  </c:spPr>
-  <c:externalData r:id="rId1">
-    <c:autoUpdate val="0"/>
-  </c:externalData>
-</c:chartSpace>
-</file>
-
-<file path=ppt/charts/chart2.xml><?xml version="1.0" encoding="utf-8"?>
-<c:chartSpace xmlns:c="http://schemas.openxmlformats.org/drawingml/2006/chart" xmlns:a="http://schemas.openxmlformats.org/drawingml/2006/main" xmlns:r="http://schemas.openxmlformats.org/officeDocument/2006/relationships">
-  <c:date1904 val="0"/>
-  <c:roundedCorners val="1"/>
-  <c:chart>
-    <c:autoTitleDeleted val="1"/>
-    <c:plotArea>
-      <c:layout/>
-      <c:barChart>
-        <c:barDir val="col"/>
-        <c:grouping val="clustered"/>
-        <c:varyColors val="0"/>
-        <c:ser>
-          <c:idx val="0"/>
-          <c:order val="0"/>
-          <c:tx>
-            <c:strRef>
-              <c:f>Sheet1!$B$1</c:f>
-              <c:strCache>
-                <c:ptCount val="1"/>
-                <c:pt idx="0">
-                  <c:v>진입불가 비율</c:v>
-                </c:pt>
-              </c:strCache>
-            </c:strRef>
-          </c:tx>
-          <c:spPr>
-            <a:solidFill>
-              <a:srgbClr val="EA580C"/>
-            </a:solidFill>
-            <a:effectLst/>
-          </c:spPr>
-          <c:invertIfNegative val="0"/>
-          <c:dLbls>
-            <c:numFmt formatCode="0&quot;%&quot;" sourceLinked="0"/>
-            <c:txPr>
-              <a:bodyPr/>
-              <a:lstStyle/>
-              <a:p>
-                <a:pPr>
-                  <a:defRPr b="1" i="0" strike="noStrike" sz="1200" u="none">
-                    <a:solidFill>
-                      <a:srgbClr val="0F172A"/>
-                    </a:solidFill>
-                    <a:latin typeface="Consolas"/>
-                  </a:defRPr>
-                </a:pPr>
-              </a:p>
-            </c:txPr>
-            <c:showLegendKey val="0"/>
-            <c:showVal val="1"/>
-            <c:showCatName val="0"/>
-            <c:showSerName val="0"/>
-            <c:showPercent val="0"/>
-            <c:showBubbleSize val="0"/>
-            <c:showLeaderLines val="0"/>
-          </c:dLbls>
-          <c:cat>
-            <c:multiLvlStrRef>
-              <c:f>Sheet1!$A$2:$A$6</c:f>
-              <c:multiLvlStrCache>
-                <c:ptCount val="5"/>
-                <c:lvl>
-                  <c:pt idx="0">
-                    <c:v>마산합포구</c:v>
-                  </c:pt>
-                  <c:pt idx="1">
-                    <c:v>진해구</c:v>
-                  </c:pt>
-                  <c:pt idx="2">
-                    <c:v>마산회원구</c:v>
-                  </c:pt>
-                  <c:pt idx="3">
-                    <c:v>성산구</c:v>
-                  </c:pt>
-                  <c:pt idx="4">
-                    <c:v>의창구</c:v>
-                  </c:pt>
-                </c:lvl>
-              </c:multiLvlStrCache>
-            </c:multiLvlStrRef>
-          </c:cat>
-          <c:val>
-            <c:numRef>
-              <c:f>Sheet1!$B$2:$B$6</c:f>
-              <c:numCache>
-                <c:formatCode>General</c:formatCode>
-                <c:ptCount val="5"/>
-                <c:pt idx="0">
-                  <c:v>38</c:v>
-                </c:pt>
-                <c:pt idx="1">
-                  <c:v>34</c:v>
-                </c:pt>
-                <c:pt idx="2">
-                  <c:v>29</c:v>
-                </c:pt>
-                <c:pt idx="3">
-                  <c:v>18</c:v>
-                </c:pt>
-                <c:pt idx="4">
-                  <c:v>14</c:v>
-                </c:pt>
-              </c:numCache>
-            </c:numRef>
-          </c:val>
-        </c:ser>
-        <c:dLbls>
-          <c:numFmt formatCode="0&quot;%&quot;" sourceLinked="0"/>
-          <c:txPr>
-            <a:bodyPr/>
-            <a:lstStyle/>
-            <a:p>
-              <a:pPr>
-                <a:defRPr b="1" i="0" strike="noStrike" sz="1200" u="none">
-                  <a:solidFill>
-                    <a:srgbClr val="0F172A"/>
-                  </a:solidFill>
-                  <a:latin typeface="Consolas"/>
-                </a:defRPr>
-              </a:pPr>
-            </a:p>
-          </c:txPr>
-          <c:showLegendKey val="0"/>
-          <c:showVal val="1"/>
-          <c:showCatName val="0"/>
-          <c:showSerName val="0"/>
-          <c:showPercent val="0"/>
-          <c:showBubbleSize val="0"/>
-          <c:showLeaderLines val="0"/>
-        </c:dLbls>
-        <c:gapWidth val="55"/>
-        <c:overlap val="0"/>
-        <c:axId val="2094734554"/>
-        <c:axId val="2094734552"/>
-        <c:axId val="2094734556"/>
-      </c:barChart>
-      <c:catAx>
-        <c:axId val="2094734554"/>
-        <c:scaling>
-          <c:orientation val="minMax"/>
-        </c:scaling>
-        <c:delete val="0"/>
-        <c:axPos val="b"/>
-        <c:numFmt formatCode="General" sourceLinked="1"/>
-        <c:majorTickMark val="out"/>
-        <c:minorTickMark val="none"/>
-        <c:tickLblPos val="low"/>
-        <c:spPr>
-          <a:ln w="12700" cap="flat">
-            <a:solidFill>
-              <a:srgbClr val="CBD5E1"/>
-            </a:solidFill>
-            <a:prstDash val="solid"/>
-            <a:round/>
-          </a:ln>
-        </c:spPr>
-        <c:txPr>
-          <a:bodyPr/>
-          <a:lstStyle/>
-          <a:p>
-            <a:pPr>
-              <a:defRPr sz="1100" b="0" i="0" u="none" strike="noStrike">
-                <a:solidFill>
-                  <a:srgbClr val="334155"/>
-                </a:solidFill>
-                <a:latin typeface="Malgun Gothic"/>
-              </a:defRPr>
-            </a:pPr>
-            <a:endParaRPr lang="en-US"/>
-          </a:p>
-        </c:txPr>
-        <c:crossAx val="2094734552"/>
-        <c:crosses val="autoZero"/>
-        <c:auto val="1"/>
-        <c:lblAlgn val="ctr"/>
-        <c:noMultiLvlLbl val="1"/>
-      </c:catAx>
-      <c:valAx>
-        <c:axId val="2094734552"/>
-        <c:scaling>
-          <c:orientation val="minMax"/>
-          <c:max val="46"/>
+          <c:max val="145"/>
         </c:scaling>
         <c:delete val="1"/>
         <c:axPos val="l"/>
@@ -674,7 +763,7 @@
                     <c:v>진해구</c:v>
                   </c:pt>
                   <c:pt idx="2">
-                    <c:v>마산회원구</c:v>
+                    <c:v>의창구</c:v>
                   </c:pt>
                   <c:pt idx="3">
                     <c:v>성산구</c:v>
@@ -690,16 +779,16 @@
                 <c:formatCode>General</c:formatCode>
                 <c:ptCount val="4"/>
                 <c:pt idx="0">
-                  <c:v>34</c:v>
+                  <c:v>30</c:v>
                 </c:pt>
                 <c:pt idx="1">
-                  <c:v>28</c:v>
+                  <c:v>29</c:v>
                 </c:pt>
                 <c:pt idx="2">
-                  <c:v>24</c:v>
+                  <c:v>33</c:v>
                 </c:pt>
                 <c:pt idx="3">
-                  <c:v>15</c:v>
+                  <c:v>30</c:v>
                 </c:pt>
               </c:numCache>
             </c:numRef>
@@ -763,7 +852,7 @@
                     <c:v>진해구</c:v>
                   </c:pt>
                   <c:pt idx="2">
-                    <c:v>마산회원구</c:v>
+                    <c:v>의창구</c:v>
                   </c:pt>
                   <c:pt idx="3">
                     <c:v>성산구</c:v>
@@ -779,13 +868,13 @@
                 <c:formatCode>General</c:formatCode>
                 <c:ptCount val="4"/>
                 <c:pt idx="0">
-                  <c:v>30</c:v>
+                  <c:v>31</c:v>
                 </c:pt>
                 <c:pt idx="1">
-                  <c:v>27</c:v>
+                  <c:v>28</c:v>
                 </c:pt>
                 <c:pt idx="2">
-                  <c:v>22</c:v>
+                  <c:v>14</c:v>
                 </c:pt>
                 <c:pt idx="3">
                   <c:v>13</c:v>
@@ -852,7 +941,7 @@
                     <c:v>진해구</c:v>
                   </c:pt>
                   <c:pt idx="2">
-                    <c:v>마산회원구</c:v>
+                    <c:v>의창구</c:v>
                   </c:pt>
                   <c:pt idx="3">
                     <c:v>성산구</c:v>
@@ -868,16 +957,16 @@
                 <c:formatCode>General</c:formatCode>
                 <c:ptCount val="4"/>
                 <c:pt idx="0">
-                  <c:v>22</c:v>
+                  <c:v>24</c:v>
                 </c:pt>
                 <c:pt idx="1">
                   <c:v>20</c:v>
                 </c:pt>
                 <c:pt idx="2">
-                  <c:v>17</c:v>
+                  <c:v>12</c:v>
                 </c:pt>
                 <c:pt idx="3">
-                  <c:v>12</c:v>
+                  <c:v>13</c:v>
                 </c:pt>
               </c:numCache>
             </c:numRef>
@@ -941,7 +1030,7 @@
                     <c:v>진해구</c:v>
                   </c:pt>
                   <c:pt idx="2">
-                    <c:v>마산회원구</c:v>
+                    <c:v>의창구</c:v>
                   </c:pt>
                   <c:pt idx="3">
                     <c:v>성산구</c:v>
@@ -957,13 +1046,13 @@
                 <c:formatCode>General</c:formatCode>
                 <c:ptCount val="4"/>
                 <c:pt idx="0">
+                  <c:v>19</c:v>
+                </c:pt>
+                <c:pt idx="1">
                   <c:v>18</c:v>
                 </c:pt>
-                <c:pt idx="1">
-                  <c:v>19</c:v>
-                </c:pt>
                 <c:pt idx="2">
-                  <c:v>14</c:v>
+                  <c:v>11</c:v>
                 </c:pt>
                 <c:pt idx="3">
                   <c:v>11</c:v>
@@ -2225,7 +2314,7 @@
           <a:p>
             <a:r>
               <a:rPr lang="en-US" dirty="0"/>
-              <a:t/>
+              <a:t>소방안전 빅데이터 플랫폼 최근 1년 화재건수에서 창원시가 563건으로 경남 최다 → 대상 지역을 창원으로 확정.</a:t>
             </a:r>
             <a:endParaRPr lang="en-US" dirty="0"/>
           </a:p>
@@ -2313,7 +2402,7 @@
           <a:p>
             <a:r>
               <a:rPr lang="en-US" dirty="0"/>
-              <a:t/>
+              <a:t>화재 발생지점을 지도에 표시하고, 소방서에서 각 지점까지 경로를 탐색해 소방차가 못 가는 폭 4m 미만 구간을 빨간선으로 표시했다.</a:t>
             </a:r>
             <a:endParaRPr lang="en-US" dirty="0"/>
           </a:p>
@@ -2577,7 +2666,7 @@
           <a:p>
             <a:r>
               <a:rPr lang="en-US" dirty="0"/>
-              <a:t>위험지수 히트맵 위에 후보 소방서 커버리지를 겹쳐, 상위 취약지를 최단 거리에서 커버하는 마산소방서를 드론 거점으로 선정.</a:t>
+              <a:t>창원 원도심 위험지수 히트맵 위에서, 상위 취약지(마산합포·진해)를 최단 거리로 커버하는 마산소방서를 드론 거점으로 선정.</a:t>
             </a:r>
             <a:endParaRPr lang="en-US" dirty="0"/>
           </a:p>
@@ -3146,7 +3235,7 @@
         <p:spPr>
           <a:xfrm>
             <a:off x="685800" y="3429000"/>
-            <a:ext cx="10058400" cy="457200"/>
+            <a:ext cx="10515600" cy="457200"/>
           </a:xfrm>
           <a:prstGeom prst="rect">
             <a:avLst/>
@@ -3162,7 +3251,7 @@
               <a:buNone/>
             </a:pPr>
             <a:r>
-              <a:rPr lang="en-US" sz="1700" dirty="0">
+              <a:rPr lang="en-US" sz="1650" dirty="0">
                 <a:solidFill>
                   <a:srgbClr val="94A3B8"/>
                 </a:solidFill>
@@ -3170,9 +3259,9 @@
                 <a:ea typeface="Malgun Gothic" pitchFamily="34" charset="-122"/>
                 <a:cs typeface="Malgun Gothic" pitchFamily="34" charset="-120"/>
               </a:rPr>
-              <a:t>화재 빅데이터 · 지도 분석 기반 소방 드론 배치 → 현장 대응 로직</a:t>
-            </a:r>
-            <a:endParaRPr lang="en-US" sz="1700" dirty="0"/>
+              <a:t>최근 1년 화재 발생 빅데이터로 창원을 정하고, 지도 분석으로 거점을 정한다</a:t>
+            </a:r>
+            <a:endParaRPr lang="en-US" sz="1650" dirty="0"/>
           </a:p>
         </p:txBody>
       </p:sp>
@@ -3314,7 +3403,7 @@
                 <a:ea typeface="Malgun Gothic" pitchFamily="34" charset="-122"/>
                 <a:cs typeface="Malgun Gothic" pitchFamily="34" charset="-120"/>
               </a:rPr>
-              <a:t>화재·도로·취약 데이터 분석 → 거점 소방서 선정</a:t>
+              <a:t>화재 빅데이터 분석 → 창원 · 거점 소방서 선정</a:t>
             </a:r>
             <a:endParaRPr lang="en-US" sz="1100" dirty="0"/>
           </a:p>
@@ -8693,7 +8782,7 @@
                 <a:ea typeface="Malgun Gothic" pitchFamily="34" charset="-122"/>
                 <a:cs typeface="Malgun Gothic" pitchFamily="34" charset="-120"/>
               </a:rPr>
-              <a:t>데이터로 거점을 정하고, 편대가 골목을 먼저 지킨다</a:t>
+              <a:t>데이터로 창원·거점을 정하고, 편대가 골목을 먼저 지킨다</a:t>
             </a:r>
             <a:endParaRPr lang="en-US" sz="2000" dirty="0"/>
           </a:p>
@@ -8724,7 +8813,7 @@
               <a:buNone/>
             </a:pPr>
             <a:r>
-              <a:rPr lang="en-US" sz="1350" dirty="0">
+              <a:rPr lang="en-US" sz="1300" dirty="0">
                 <a:solidFill>
                   <a:srgbClr val="94A3B8"/>
                 </a:solidFill>
@@ -8732,9 +8821,9 @@
                 <a:ea typeface="Malgun Gothic" pitchFamily="34" charset="-122"/>
                 <a:cs typeface="Malgun Gothic" pitchFamily="34" charset="-120"/>
               </a:rPr>
-              <a:t>화재 빅데이터 분석 → 소방 드론 거점 선정 → SOP-D 현장 대응 → UGV 유무인 복합. 팀 군체 · 감사합니다. (Q&amp;A)</a:t>
-            </a:r>
-            <a:endParaRPr lang="en-US" sz="1350" dirty="0"/>
+              <a:t>최근 1년 화재 빅데이터 → 창원·거점 소방서 선정 → SOP-D 현장 대응 → UGV 유무인 복합. 팀 군체 · 감사합니다. (Q&amp;A)</a:t>
+            </a:r>
+            <a:endParaRPr lang="en-US" sz="1300" dirty="0"/>
           </a:p>
         </p:txBody>
       </p:sp>
@@ -8857,7 +8946,7 @@
         <p:spPr>
           <a:xfrm>
             <a:off x="685800" y="3703320"/>
-            <a:ext cx="10058400" cy="731520"/>
+            <a:ext cx="10424160" cy="731520"/>
           </a:xfrm>
           <a:prstGeom prst="rect">
             <a:avLst/>
@@ -8884,7 +8973,7 @@
                 <a:ea typeface="Malgun Gothic" pitchFamily="34" charset="-122"/>
                 <a:cs typeface="Malgun Gothic" pitchFamily="34" charset="-120"/>
               </a:rPr>
-              <a:t>불이 자주 나고, 소방차가 못 가는 곳은 어디인가? — 화재·도로·취약 데이터를 모아 드론을 배치할 소방서를 정한다.</a:t>
+              <a:t>최근 1년 화재 발생 빈도로 대상 지역을 창원으로 정하고 — 지도에서 소방차가 못 가는 경로를 찾아 드론 거점 소방서를 정한다.</a:t>
             </a:r>
             <a:endParaRPr lang="en-US" sz="1500" dirty="0"/>
           </a:p>
@@ -8942,7 +9031,7 @@
               <a:buNone/>
             </a:pPr>
             <a:r>
-              <a:rPr lang="en-US" sz="1250" b="1" dirty="0">
+              <a:rPr lang="en-US" sz="1200" b="1" dirty="0">
                 <a:solidFill>
                   <a:srgbClr val="DC2626"/>
                 </a:solidFill>
@@ -8956,7 +9045,7 @@
               <a:buNone/>
             </a:pPr>
             <a:r>
-              <a:rPr lang="en-US" sz="1250" b="1" dirty="0">
+              <a:rPr lang="en-US" sz="1200" b="1" dirty="0">
                 <a:solidFill>
                   <a:srgbClr val="E2E8F0"/>
                 </a:solidFill>
@@ -8966,7 +9055,7 @@
               </a:rPr>
               <a:t>데이터 수집</a:t>
             </a:r>
-            <a:endParaRPr lang="en-US" sz="1250" dirty="0"/>
+            <a:endParaRPr lang="en-US" sz="1200" dirty="0"/>
           </a:p>
         </p:txBody>
       </p:sp>
@@ -9061,7 +9150,7 @@
               <a:buNone/>
             </a:pPr>
             <a:r>
-              <a:rPr lang="en-US" sz="1250" b="1" dirty="0">
+              <a:rPr lang="en-US" sz="1200" b="1" dirty="0">
                 <a:solidFill>
                   <a:srgbClr val="DC2626"/>
                 </a:solidFill>
@@ -9075,7 +9164,7 @@
               <a:buNone/>
             </a:pPr>
             <a:r>
-              <a:rPr lang="en-US" sz="1250" b="1" dirty="0">
+              <a:rPr lang="en-US" sz="1200" b="1" dirty="0">
                 <a:solidFill>
                   <a:srgbClr val="E2E8F0"/>
                 </a:solidFill>
@@ -9083,9 +9172,9 @@
                 <a:ea typeface="Malgun Gothic" pitchFamily="34" charset="-122"/>
                 <a:cs typeface="Malgun Gothic" pitchFamily="34" charset="-120"/>
               </a:rPr>
-              <a:t>지도 API 연동</a:t>
-            </a:r>
-            <a:endParaRPr lang="en-US" sz="1250" dirty="0"/>
+              <a:t>지역 선정 · 창원</a:t>
+            </a:r>
+            <a:endParaRPr lang="en-US" sz="1200" dirty="0"/>
           </a:p>
         </p:txBody>
       </p:sp>
@@ -9180,7 +9269,7 @@
               <a:buNone/>
             </a:pPr>
             <a:r>
-              <a:rPr lang="en-US" sz="1250" b="1" dirty="0">
+              <a:rPr lang="en-US" sz="1200" b="1" dirty="0">
                 <a:solidFill>
                   <a:srgbClr val="DC2626"/>
                 </a:solidFill>
@@ -9194,7 +9283,7 @@
               <a:buNone/>
             </a:pPr>
             <a:r>
-              <a:rPr lang="en-US" sz="1250" b="1" dirty="0">
+              <a:rPr lang="en-US" sz="1200" b="1" dirty="0">
                 <a:solidFill>
                   <a:srgbClr val="E2E8F0"/>
                 </a:solidFill>
@@ -9202,9 +9291,9 @@
                 <a:ea typeface="Malgun Gothic" pitchFamily="34" charset="-122"/>
                 <a:cs typeface="Malgun Gothic" pitchFamily="34" charset="-120"/>
               </a:rPr>
-              <a:t>취약지 분석</a:t>
-            </a:r>
-            <a:endParaRPr lang="en-US" sz="1250" dirty="0"/>
+              <a:t>지도·경로 분석</a:t>
+            </a:r>
+            <a:endParaRPr lang="en-US" sz="1200" dirty="0"/>
           </a:p>
         </p:txBody>
       </p:sp>
@@ -9299,7 +9388,7 @@
               <a:buNone/>
             </a:pPr>
             <a:r>
-              <a:rPr lang="en-US" sz="1250" b="1" dirty="0">
+              <a:rPr lang="en-US" sz="1200" b="1" dirty="0">
                 <a:solidFill>
                   <a:srgbClr val="DC2626"/>
                 </a:solidFill>
@@ -9313,7 +9402,7 @@
               <a:buNone/>
             </a:pPr>
             <a:r>
-              <a:rPr lang="en-US" sz="1250" b="1" dirty="0">
+              <a:rPr lang="en-US" sz="1200" b="1" dirty="0">
                 <a:solidFill>
                   <a:srgbClr val="E2E8F0"/>
                 </a:solidFill>
@@ -9321,9 +9410,9 @@
                 <a:ea typeface="Malgun Gothic" pitchFamily="34" charset="-122"/>
                 <a:cs typeface="Malgun Gothic" pitchFamily="34" charset="-120"/>
               </a:rPr>
-              <a:t>거점 소방서 선정</a:t>
-            </a:r>
-            <a:endParaRPr lang="en-US" sz="1250" dirty="0"/>
+              <a:t>거점 선정</a:t>
+            </a:r>
+            <a:endParaRPr lang="en-US" sz="1200" dirty="0"/>
           </a:p>
         </p:txBody>
       </p:sp>
@@ -9529,7 +9618,7 @@
                 <a:ea typeface="Malgun Gothic" pitchFamily="34" charset="-122"/>
                 <a:cs typeface="Malgun Gothic" pitchFamily="34" charset="-120"/>
               </a:rPr>
-              <a:t>화재 발생 이력</a:t>
+              <a:t>화재 발생 빈도</a:t>
             </a:r>
             <a:endParaRPr lang="en-US" sz="1250" dirty="0"/>
           </a:p>
@@ -9543,20 +9632,23 @@
         </p:nvSpPr>
         <p:spPr>
           <a:xfrm>
-            <a:off x="749808" y="2651760"/>
-            <a:ext cx="1792224" cy="320040"/>
-          </a:xfrm>
-          <a:prstGeom prst="rect">
-            <a:avLst/>
-          </a:prstGeom>
-          <a:noFill/>
-          <a:ln/>
-        </p:spPr>
-        <p:txBody>
-          <a:bodyPr wrap="square" lIns="0" tIns="0" rIns="0" bIns="0" rtlCol="0" anchor="ctr"/>
+            <a:off x="749808" y="2624328"/>
+            <a:ext cx="1792224" cy="457200"/>
+          </a:xfrm>
+          <a:prstGeom prst="rect">
+            <a:avLst/>
+          </a:prstGeom>
+          <a:noFill/>
+          <a:ln/>
+        </p:spPr>
+        <p:txBody>
+          <a:bodyPr wrap="square" lIns="0" tIns="0" rIns="0" bIns="0" rtlCol="0" anchor="t"/>
           <a:lstStyle/>
           <a:p>
             <a:pPr indent="0" marL="0">
+              <a:lnSpc>
+                <a:spcPct val="105000"/>
+              </a:lnSpc>
               <a:buNone/>
             </a:pPr>
             <a:r>
@@ -9568,7 +9660,7 @@
                 <a:ea typeface="Malgun Gothic" pitchFamily="34" charset="-122"/>
                 <a:cs typeface="Malgun Gothic" pitchFamily="34" charset="-120"/>
               </a:rPr>
-              <a:t>경남소방본부</a:t>
+              <a:t>소방안전 빅데이터 플랫폼</a:t>
             </a:r>
             <a:endParaRPr lang="en-US" sz="1050" dirty="0"/>
           </a:p>
@@ -9582,8 +9674,8 @@
         </p:nvSpPr>
         <p:spPr>
           <a:xfrm>
-            <a:off x="749808" y="3063240"/>
-            <a:ext cx="1792224" cy="1188720"/>
+            <a:off x="749808" y="3154680"/>
+            <a:ext cx="1792224" cy="1097280"/>
           </a:xfrm>
           <a:prstGeom prst="rect">
             <a:avLst/>
@@ -9610,7 +9702,7 @@
                 <a:ea typeface="Malgun Gothic" pitchFamily="34" charset="-122"/>
                 <a:cs typeface="Malgun Gothic" pitchFamily="34" charset="-120"/>
               </a:rPr>
-              <a:t>최근 화재 발생 지점·건수·원인</a:t>
+              <a:t>최근 1년 시·군구별 화재 건수</a:t>
             </a:r>
             <a:endParaRPr lang="en-US" sz="1150" dirty="0"/>
           </a:p>
@@ -9722,20 +9814,23 @@
         </p:nvSpPr>
         <p:spPr>
           <a:xfrm>
-            <a:off x="3081528" y="2651760"/>
-            <a:ext cx="1792224" cy="320040"/>
-          </a:xfrm>
-          <a:prstGeom prst="rect">
-            <a:avLst/>
-          </a:prstGeom>
-          <a:noFill/>
-          <a:ln/>
-        </p:spPr>
-        <p:txBody>
-          <a:bodyPr wrap="square" lIns="0" tIns="0" rIns="0" bIns="0" rtlCol="0" anchor="ctr"/>
+            <a:off x="3081528" y="2624328"/>
+            <a:ext cx="1792224" cy="457200"/>
+          </a:xfrm>
+          <a:prstGeom prst="rect">
+            <a:avLst/>
+          </a:prstGeom>
+          <a:noFill/>
+          <a:ln/>
+        </p:spPr>
+        <p:txBody>
+          <a:bodyPr wrap="square" lIns="0" tIns="0" rIns="0" bIns="0" rtlCol="0" anchor="t"/>
           <a:lstStyle/>
           <a:p>
             <a:pPr indent="0" marL="0">
+              <a:lnSpc>
+                <a:spcPct val="105000"/>
+              </a:lnSpc>
               <a:buNone/>
             </a:pPr>
             <a:r>
@@ -9761,8 +9856,8 @@
         </p:nvSpPr>
         <p:spPr>
           <a:xfrm>
-            <a:off x="3081528" y="3063240"/>
-            <a:ext cx="1792224" cy="1188720"/>
+            <a:off x="3081528" y="3154680"/>
+            <a:ext cx="1792224" cy="1097280"/>
           </a:xfrm>
           <a:prstGeom prst="rect">
             <a:avLst/>
@@ -9901,20 +9996,23 @@
         </p:nvSpPr>
         <p:spPr>
           <a:xfrm>
-            <a:off x="5413248" y="2651760"/>
-            <a:ext cx="1792224" cy="320040"/>
-          </a:xfrm>
-          <a:prstGeom prst="rect">
-            <a:avLst/>
-          </a:prstGeom>
-          <a:noFill/>
-          <a:ln/>
-        </p:spPr>
-        <p:txBody>
-          <a:bodyPr wrap="square" lIns="0" tIns="0" rIns="0" bIns="0" rtlCol="0" anchor="ctr"/>
+            <a:off x="5413248" y="2624328"/>
+            <a:ext cx="1792224" cy="457200"/>
+          </a:xfrm>
+          <a:prstGeom prst="rect">
+            <a:avLst/>
+          </a:prstGeom>
+          <a:noFill/>
+          <a:ln/>
+        </p:spPr>
+        <p:txBody>
+          <a:bodyPr wrap="square" lIns="0" tIns="0" rIns="0" bIns="0" rtlCol="0" anchor="t"/>
           <a:lstStyle/>
           <a:p>
             <a:pPr indent="0" marL="0">
+              <a:lnSpc>
+                <a:spcPct val="105000"/>
+              </a:lnSpc>
               <a:buNone/>
             </a:pPr>
             <a:r>
@@ -9940,8 +10038,8 @@
         </p:nvSpPr>
         <p:spPr>
           <a:xfrm>
-            <a:off x="5413248" y="3063240"/>
-            <a:ext cx="1792224" cy="1188720"/>
+            <a:off x="5413248" y="3154680"/>
+            <a:ext cx="1792224" cy="1097280"/>
           </a:xfrm>
           <a:prstGeom prst="rect">
             <a:avLst/>
@@ -10080,20 +10178,23 @@
         </p:nvSpPr>
         <p:spPr>
           <a:xfrm>
-            <a:off x="7744968" y="2651760"/>
-            <a:ext cx="1792224" cy="320040"/>
-          </a:xfrm>
-          <a:prstGeom prst="rect">
-            <a:avLst/>
-          </a:prstGeom>
-          <a:noFill/>
-          <a:ln/>
-        </p:spPr>
-        <p:txBody>
-          <a:bodyPr wrap="square" lIns="0" tIns="0" rIns="0" bIns="0" rtlCol="0" anchor="ctr"/>
+            <a:off x="7744968" y="2624328"/>
+            <a:ext cx="1792224" cy="457200"/>
+          </a:xfrm>
+          <a:prstGeom prst="rect">
+            <a:avLst/>
+          </a:prstGeom>
+          <a:noFill/>
+          <a:ln/>
+        </p:spPr>
+        <p:txBody>
+          <a:bodyPr wrap="square" lIns="0" tIns="0" rIns="0" bIns="0" rtlCol="0" anchor="t"/>
           <a:lstStyle/>
           <a:p>
             <a:pPr indent="0" marL="0">
+              <a:lnSpc>
+                <a:spcPct val="105000"/>
+              </a:lnSpc>
               <a:buNone/>
             </a:pPr>
             <a:r>
@@ -10119,8 +10220,8 @@
         </p:nvSpPr>
         <p:spPr>
           <a:xfrm>
-            <a:off x="7744968" y="3063240"/>
-            <a:ext cx="1792224" cy="1188720"/>
+            <a:off x="7744968" y="3154680"/>
+            <a:ext cx="1792224" cy="1097280"/>
           </a:xfrm>
           <a:prstGeom prst="rect">
             <a:avLst/>
@@ -10259,20 +10360,23 @@
         </p:nvSpPr>
         <p:spPr>
           <a:xfrm>
-            <a:off x="10076688" y="2651760"/>
-            <a:ext cx="1792224" cy="320040"/>
-          </a:xfrm>
-          <a:prstGeom prst="rect">
-            <a:avLst/>
-          </a:prstGeom>
-          <a:noFill/>
-          <a:ln/>
-        </p:spPr>
-        <p:txBody>
-          <a:bodyPr wrap="square" lIns="0" tIns="0" rIns="0" bIns="0" rtlCol="0" anchor="ctr"/>
+            <a:off x="10076688" y="2624328"/>
+            <a:ext cx="1792224" cy="457200"/>
+          </a:xfrm>
+          <a:prstGeom prst="rect">
+            <a:avLst/>
+          </a:prstGeom>
+          <a:noFill/>
+          <a:ln/>
+        </p:spPr>
+        <p:txBody>
+          <a:bodyPr wrap="square" lIns="0" tIns="0" rIns="0" bIns="0" rtlCol="0" anchor="t"/>
           <a:lstStyle/>
           <a:p>
             <a:pPr indent="0" marL="0">
+              <a:lnSpc>
+                <a:spcPct val="105000"/>
+              </a:lnSpc>
               <a:buNone/>
             </a:pPr>
             <a:r>
@@ -10298,8 +10402,8 @@
         </p:nvSpPr>
         <p:spPr>
           <a:xfrm>
-            <a:off x="10076688" y="3063240"/>
-            <a:ext cx="1792224" cy="1188720"/>
+            <a:off x="10076688" y="3154680"/>
+            <a:ext cx="1792224" cy="1097280"/>
           </a:xfrm>
           <a:prstGeom prst="rect">
             <a:avLst/>
@@ -10395,7 +10499,7 @@
                 <a:ea typeface="Malgun Gothic" pitchFamily="34" charset="-122"/>
                 <a:cs typeface="Malgun Gothic" pitchFamily="34" charset="-120"/>
               </a:rPr>
-              <a:t>공공 빅데이터 5종을 파이썬으로 통합·정제  </a:t>
+              <a:t>핵심 = 소방안전 빅데이터 플랫폼의 최근 1년 화재 발생 빈도.  </a:t>
             </a:r>
             <a:pPr indent="0" marL="0">
               <a:lnSpc>
@@ -10412,7 +10516,7 @@
                 <a:ea typeface="Malgun Gothic" pitchFamily="34" charset="-122"/>
                 <a:cs typeface="Malgun Gothic" pitchFamily="34" charset="-120"/>
               </a:rPr>
-              <a:t>— Pandas · NumPy로 수집/전처리, Matplotlib · Seaborn으로 상관관계 시각화.</a:t>
+              <a:t>여기에 도로·건축·인구 데이터를 파이썬(Pandas·NumPy·Matplotlib)으로 통합·시각화한다.</a:t>
             </a:r>
             <a:endParaRPr lang="en-US" sz="1350" dirty="0"/>
           </a:p>
@@ -10522,7 +10626,7 @@
                 <a:ea typeface="Malgun Gothic" pitchFamily="34" charset="-122"/>
                 <a:cs typeface="Malgun Gothic" pitchFamily="34" charset="-120"/>
               </a:rPr>
-              <a:t>지도 API로 실제 도로 위에 올린다</a:t>
+              <a:t>대상 지역을 창원으로 정한다</a:t>
             </a:r>
             <a:endParaRPr lang="en-US" sz="2800" dirty="0"/>
           </a:p>
@@ -10530,22 +10634,77 @@
       </p:sp>
       <p:sp>
         <p:nvSpPr>
-          <p:cNvPr id="4" name="Shape 2"/>
-          <p:cNvSpPr/>
-          <p:nvPr/>
-        </p:nvSpPr>
-        <p:spPr>
-          <a:xfrm>
-            <a:off x="548640" y="1783080"/>
-            <a:ext cx="2615184" cy="1737360"/>
+          <p:cNvPr id="4" name="Text 2"/>
+          <p:cNvSpPr/>
+          <p:nvPr/>
+        </p:nvSpPr>
+        <p:spPr>
+          <a:xfrm>
+            <a:off x="548640" y="1371600"/>
+            <a:ext cx="10515600" cy="320040"/>
+          </a:xfrm>
+          <a:prstGeom prst="rect">
+            <a:avLst/>
+          </a:prstGeom>
+          <a:noFill/>
+          <a:ln/>
+        </p:spPr>
+        <p:txBody>
+          <a:bodyPr wrap="square" lIns="0" tIns="0" rIns="0" bIns="0" rtlCol="0" anchor="ctr"/>
+          <a:lstStyle/>
+          <a:p>
+            <a:pPr indent="0" marL="0">
+              <a:buNone/>
+            </a:pPr>
+            <a:r>
+              <a:rPr lang="en-US" sz="1250" dirty="0">
+                <a:solidFill>
+                  <a:srgbClr val="64748B"/>
+                </a:solidFill>
+                <a:latin typeface="Malgun Gothic" pitchFamily="34" charset="0"/>
+                <a:ea typeface="Malgun Gothic" pitchFamily="34" charset="-122"/>
+                <a:cs typeface="Malgun Gothic" pitchFamily="34" charset="-120"/>
+              </a:rPr>
+              <a:t>소방안전 빅데이터 플랫폼 · 최근 1년 · 경남 시·군별 화재 발생 건수 (창원시 = 5개 구 합산)</a:t>
+            </a:r>
+            <a:endParaRPr lang="en-US" sz="1250" dirty="0"/>
+          </a:p>
+        </p:txBody>
+      </p:sp>
+      <p:graphicFrame>
+        <p:nvGraphicFramePr>
+          <p:cNvPr id="5" name="Chart 0" descr=""/>
+          <p:cNvGraphicFramePr/>
+          <p:nvPr/>
+        </p:nvGraphicFramePr>
+        <p:xfrm>
+          <a:off x="548640" y="1783080"/>
+          <a:ext cx="7315200" cy="3977640"/>
+        </p:xfrm>
+        <a:graphic xmlns:a="http://schemas.openxmlformats.org/drawingml/2006/main">
+          <a:graphicData uri="http://schemas.openxmlformats.org/drawingml/2006/chart">
+            <c:chart xmlns:c="http://schemas.openxmlformats.org/drawingml/2006/chart" r:id="rId1"/>
+          </a:graphicData>
+        </a:graphic>
+      </p:graphicFrame>
+      <p:sp>
+        <p:nvSpPr>
+          <p:cNvPr id="6" name="Shape 3"/>
+          <p:cNvSpPr/>
+          <p:nvPr/>
+        </p:nvSpPr>
+        <p:spPr>
+          <a:xfrm>
+            <a:off x="8138160" y="1783080"/>
+            <a:ext cx="3474720" cy="3977640"/>
           </a:xfrm>
           <a:prstGeom prst="roundRect">
             <a:avLst>
-              <a:gd name="adj" fmla="val 4737"/>
+              <a:gd name="adj" fmla="val 2368"/>
             </a:avLst>
           </a:prstGeom>
           <a:solidFill>
-            <a:srgbClr val="FFFFFF"/>
+            <a:srgbClr val="F8FAFC"/>
           </a:solidFill>
           <a:ln w="12700">
             <a:solidFill>
@@ -10564,34 +10723,14 @@
       </p:sp>
       <p:sp>
         <p:nvSpPr>
-          <p:cNvPr id="5" name="Shape 3"/>
-          <p:cNvSpPr/>
-          <p:nvPr/>
-        </p:nvSpPr>
-        <p:spPr>
-          <a:xfrm>
-            <a:off x="777240" y="2039112"/>
-            <a:ext cx="548640" cy="548640"/>
-          </a:xfrm>
-          <a:prstGeom prst="ellipse">
-            <a:avLst/>
-          </a:prstGeom>
-          <a:solidFill>
-            <a:srgbClr val="2563EB"/>
-          </a:solidFill>
-          <a:ln/>
-        </p:spPr>
-      </p:sp>
-      <p:sp>
-        <p:nvSpPr>
-          <p:cNvPr id="6" name="Text 4"/>
-          <p:cNvSpPr/>
-          <p:nvPr/>
-        </p:nvSpPr>
-        <p:spPr>
-          <a:xfrm>
-            <a:off x="777240" y="2039112"/>
-            <a:ext cx="548640" cy="548640"/>
+          <p:cNvPr id="7" name="Text 4"/>
+          <p:cNvSpPr/>
+          <p:nvPr/>
+        </p:nvSpPr>
+        <p:spPr>
+          <a:xfrm>
+            <a:off x="8412480" y="2011680"/>
+            <a:ext cx="2926080" cy="320040"/>
           </a:xfrm>
           <a:prstGeom prst="rect">
             <a:avLst/>
@@ -10603,34 +10742,112 @@
           <a:bodyPr wrap="square" lIns="0" tIns="0" rIns="0" bIns="0" rtlCol="0" anchor="ctr"/>
           <a:lstStyle/>
           <a:p>
-            <a:pPr algn="ctr" indent="0" marL="0">
-              <a:buNone/>
-            </a:pPr>
-            <a:r>
-              <a:rPr lang="en-US" sz="2160" b="1" dirty="0">
-                <a:solidFill>
-                  <a:srgbClr val="FFFFFF"/>
+            <a:pPr indent="0" marL="0">
+              <a:buNone/>
+            </a:pPr>
+            <a:r>
+              <a:rPr lang="en-US" sz="1300" b="1" dirty="0">
+                <a:solidFill>
+                  <a:srgbClr val="64748B"/>
+                </a:solidFill>
+                <a:latin typeface="Malgun Gothic" pitchFamily="34" charset="0"/>
+                <a:ea typeface="Malgun Gothic" pitchFamily="34" charset="-122"/>
+                <a:cs typeface="Malgun Gothic" pitchFamily="34" charset="-120"/>
+              </a:rPr>
+              <a:t>대상 지역</a:t>
+            </a:r>
+            <a:endParaRPr lang="en-US" sz="1300" dirty="0"/>
+          </a:p>
+        </p:txBody>
+      </p:sp>
+      <p:sp>
+        <p:nvSpPr>
+          <p:cNvPr id="8" name="Text 5"/>
+          <p:cNvSpPr/>
+          <p:nvPr/>
+        </p:nvSpPr>
+        <p:spPr>
+          <a:xfrm>
+            <a:off x="8412480" y="2340864"/>
+            <a:ext cx="3017520" cy="548640"/>
+          </a:xfrm>
+          <a:prstGeom prst="rect">
+            <a:avLst/>
+          </a:prstGeom>
+          <a:noFill/>
+          <a:ln/>
+        </p:spPr>
+        <p:txBody>
+          <a:bodyPr wrap="square" lIns="0" tIns="0" rIns="0" bIns="0" rtlCol="0" anchor="ctr"/>
+          <a:lstStyle/>
+          <a:p>
+            <a:pPr indent="0" marL="0">
+              <a:buNone/>
+            </a:pPr>
+            <a:r>
+              <a:rPr lang="en-US" sz="2800" b="1" dirty="0">
+                <a:solidFill>
+                  <a:srgbClr val="DC2626"/>
+                </a:solidFill>
+                <a:latin typeface="Malgun Gothic" pitchFamily="34" charset="0"/>
+                <a:ea typeface="Malgun Gothic" pitchFamily="34" charset="-122"/>
+                <a:cs typeface="Malgun Gothic" pitchFamily="34" charset="-120"/>
+              </a:rPr>
+              <a:t>창원시</a:t>
+            </a:r>
+            <a:endParaRPr lang="en-US" sz="2800" dirty="0"/>
+          </a:p>
+        </p:txBody>
+      </p:sp>
+      <p:sp>
+        <p:nvSpPr>
+          <p:cNvPr id="9" name="Text 6"/>
+          <p:cNvSpPr/>
+          <p:nvPr/>
+        </p:nvSpPr>
+        <p:spPr>
+          <a:xfrm>
+            <a:off x="8412480" y="2971800"/>
+            <a:ext cx="2194560" cy="777240"/>
+          </a:xfrm>
+          <a:prstGeom prst="rect">
+            <a:avLst/>
+          </a:prstGeom>
+          <a:noFill/>
+          <a:ln/>
+        </p:spPr>
+        <p:txBody>
+          <a:bodyPr wrap="square" lIns="0" tIns="0" rIns="0" bIns="0" rtlCol="0" anchor="ctr"/>
+          <a:lstStyle/>
+          <a:p>
+            <a:pPr indent="0" marL="0">
+              <a:buNone/>
+            </a:pPr>
+            <a:r>
+              <a:rPr lang="en-US" sz="5000" b="1" dirty="0">
+                <a:solidFill>
+                  <a:srgbClr val="0F172A"/>
                 </a:solidFill>
                 <a:latin typeface="Consolas" pitchFamily="34" charset="0"/>
                 <a:ea typeface="Consolas" pitchFamily="34" charset="-122"/>
                 <a:cs typeface="Consolas" pitchFamily="34" charset="-120"/>
               </a:rPr>
-              <a:t>1</a:t>
-            </a:r>
-            <a:endParaRPr lang="en-US" sz="2160" dirty="0"/>
-          </a:p>
-        </p:txBody>
-      </p:sp>
-      <p:sp>
-        <p:nvSpPr>
-          <p:cNvPr id="7" name="Text 5"/>
-          <p:cNvSpPr/>
-          <p:nvPr/>
-        </p:nvSpPr>
-        <p:spPr>
-          <a:xfrm>
-            <a:off x="777240" y="2697480"/>
-            <a:ext cx="2157984" cy="365760"/>
+              <a:t>563</a:t>
+            </a:r>
+            <a:endParaRPr lang="en-US" sz="5000" dirty="0"/>
+          </a:p>
+        </p:txBody>
+      </p:sp>
+      <p:sp>
+        <p:nvSpPr>
+          <p:cNvPr id="10" name="Text 7"/>
+          <p:cNvSpPr/>
+          <p:nvPr/>
+        </p:nvSpPr>
+        <p:spPr>
+          <a:xfrm>
+            <a:off x="8412480" y="3767328"/>
+            <a:ext cx="3017520" cy="320040"/>
           </a:xfrm>
           <a:prstGeom prst="rect">
             <a:avLst/>
@@ -10646,1197 +10863,80 @@
               <a:buNone/>
             </a:pPr>
             <a:r>
-              <a:rPr lang="en-US" sz="1500" b="1" dirty="0">
-                <a:solidFill>
-                  <a:srgbClr val="0F172A"/>
+              <a:rPr lang="en-US" sz="1250" dirty="0">
+                <a:solidFill>
+                  <a:srgbClr val="64748B"/>
                 </a:solidFill>
                 <a:latin typeface="Malgun Gothic" pitchFamily="34" charset="0"/>
                 <a:ea typeface="Malgun Gothic" pitchFamily="34" charset="-122"/>
                 <a:cs typeface="Malgun Gothic" pitchFamily="34" charset="-120"/>
               </a:rPr>
-              <a:t>주소·지점</a:t>
-            </a:r>
-            <a:endParaRPr lang="en-US" sz="1500" dirty="0"/>
-          </a:p>
-        </p:txBody>
-      </p:sp>
-      <p:sp>
-        <p:nvSpPr>
-          <p:cNvPr id="8" name="Text 6"/>
-          <p:cNvSpPr/>
-          <p:nvPr/>
-        </p:nvSpPr>
-        <p:spPr>
-          <a:xfrm>
-            <a:off x="777240" y="3063240"/>
-            <a:ext cx="2157984" cy="411480"/>
-          </a:xfrm>
-          <a:prstGeom prst="rect">
-            <a:avLst/>
-          </a:prstGeom>
-          <a:noFill/>
-          <a:ln/>
-        </p:spPr>
-        <p:txBody>
-          <a:bodyPr wrap="square" lIns="0" tIns="0" rIns="0" bIns="0" rtlCol="0" anchor="t"/>
-          <a:lstStyle/>
-          <a:p>
-            <a:pPr indent="0" marL="0">
-              <a:lnSpc>
-                <a:spcPct val="110000"/>
-              </a:lnSpc>
-              <a:buNone/>
-            </a:pPr>
-            <a:r>
-              <a:rPr lang="en-US" sz="1100" dirty="0">
-                <a:solidFill>
-                  <a:srgbClr val="64748B"/>
-                </a:solidFill>
-                <a:latin typeface="Malgun Gothic" pitchFamily="34" charset="0"/>
-                <a:ea typeface="Malgun Gothic" pitchFamily="34" charset="-122"/>
-                <a:cs typeface="Malgun Gothic" pitchFamily="34" charset="-120"/>
-              </a:rPr>
-              <a:t>도로명주소 · 화재 발생지</a:t>
-            </a:r>
-            <a:endParaRPr lang="en-US" sz="1100" dirty="0"/>
-          </a:p>
-        </p:txBody>
-      </p:sp>
-      <p:sp>
-        <p:nvSpPr>
-          <p:cNvPr id="9" name="Text 7"/>
-          <p:cNvSpPr/>
-          <p:nvPr/>
-        </p:nvSpPr>
-        <p:spPr>
-          <a:xfrm>
-            <a:off x="3182112" y="1783080"/>
-            <a:ext cx="283464" cy="1737360"/>
-          </a:xfrm>
-          <a:prstGeom prst="rect">
-            <a:avLst/>
-          </a:prstGeom>
-          <a:noFill/>
-          <a:ln/>
-        </p:spPr>
-        <p:txBody>
-          <a:bodyPr wrap="square" lIns="0" tIns="0" rIns="0" bIns="0" rtlCol="0" anchor="ctr"/>
-          <a:lstStyle/>
-          <a:p>
-            <a:pPr algn="ctr" indent="0" marL="0">
-              <a:buNone/>
-            </a:pPr>
-            <a:r>
-              <a:rPr lang="en-US" sz="2600" b="1" dirty="0">
-                <a:solidFill>
-                  <a:srgbClr val="94A3B8"/>
-                </a:solidFill>
-                <a:latin typeface="Malgun Gothic" pitchFamily="34" charset="0"/>
-                <a:ea typeface="Malgun Gothic" pitchFamily="34" charset="-122"/>
-                <a:cs typeface="Malgun Gothic" pitchFamily="34" charset="-120"/>
-              </a:rPr>
-              <a:t>›</a:t>
-            </a:r>
-            <a:endParaRPr lang="en-US" sz="2600" dirty="0"/>
-          </a:p>
-        </p:txBody>
-      </p:sp>
-      <p:sp>
-        <p:nvSpPr>
-          <p:cNvPr id="10" name="Shape 8"/>
-          <p:cNvSpPr/>
-          <p:nvPr/>
-        </p:nvSpPr>
-        <p:spPr>
-          <a:xfrm>
-            <a:off x="3483864" y="1783080"/>
-            <a:ext cx="2615184" cy="1737360"/>
-          </a:xfrm>
-          <a:prstGeom prst="roundRect">
-            <a:avLst>
-              <a:gd name="adj" fmla="val 4737"/>
-            </a:avLst>
-          </a:prstGeom>
-          <a:solidFill>
-            <a:srgbClr val="FFFFFF"/>
-          </a:solidFill>
+              <a:t>건 · 경남 최다</a:t>
+            </a:r>
+            <a:endParaRPr lang="en-US" sz="1250" dirty="0"/>
+          </a:p>
+        </p:txBody>
+      </p:sp>
+      <p:sp>
+        <p:nvSpPr>
+          <p:cNvPr id="11" name="Shape 8"/>
+          <p:cNvSpPr/>
+          <p:nvPr/>
+        </p:nvSpPr>
+        <p:spPr>
+          <a:xfrm>
+            <a:off x="8412480" y="4160520"/>
+            <a:ext cx="2926080" cy="0"/>
+          </a:xfrm>
+          <a:prstGeom prst="line">
+            <a:avLst/>
+          </a:prstGeom>
+          <a:noFill/>
           <a:ln w="12700">
             <a:solidFill>
               <a:srgbClr val="E2E8F0"/>
             </a:solidFill>
             <a:prstDash val="solid"/>
           </a:ln>
-          <a:effectLst>
-            <a:outerShdw sx="100000" sy="100000" kx="0" ky="0" algn="bl" rotWithShape="0" blurRad="76200" dist="25400" dir="5400000">
-              <a:srgbClr val="334155">
-                <a:alpha val="12000"/>
-              </a:srgbClr>
-            </a:outerShdw>
-          </a:effectLst>
-        </p:spPr>
-      </p:sp>
-      <p:sp>
-        <p:nvSpPr>
-          <p:cNvPr id="11" name="Shape 9"/>
-          <p:cNvSpPr/>
-          <p:nvPr/>
-        </p:nvSpPr>
-        <p:spPr>
-          <a:xfrm>
-            <a:off x="3712464" y="2039112"/>
-            <a:ext cx="548640" cy="548640"/>
-          </a:xfrm>
-          <a:prstGeom prst="ellipse">
-            <a:avLst/>
-          </a:prstGeom>
-          <a:solidFill>
-            <a:srgbClr val="2563EB"/>
-          </a:solidFill>
-          <a:ln/>
-        </p:spPr>
-      </p:sp>
-      <p:sp>
-        <p:nvSpPr>
-          <p:cNvPr id="12" name="Text 10"/>
-          <p:cNvSpPr/>
-          <p:nvPr/>
-        </p:nvSpPr>
-        <p:spPr>
-          <a:xfrm>
-            <a:off x="3712464" y="2039112"/>
-            <a:ext cx="548640" cy="548640"/>
-          </a:xfrm>
-          <a:prstGeom prst="rect">
-            <a:avLst/>
-          </a:prstGeom>
-          <a:noFill/>
-          <a:ln/>
-        </p:spPr>
-        <p:txBody>
-          <a:bodyPr wrap="square" lIns="0" tIns="0" rIns="0" bIns="0" rtlCol="0" anchor="ctr"/>
-          <a:lstStyle/>
-          <a:p>
-            <a:pPr algn="ctr" indent="0" marL="0">
-              <a:buNone/>
-            </a:pPr>
-            <a:r>
-              <a:rPr lang="en-US" sz="2160" b="1" dirty="0">
-                <a:solidFill>
-                  <a:srgbClr val="FFFFFF"/>
-                </a:solidFill>
-                <a:latin typeface="Consolas" pitchFamily="34" charset="0"/>
-                <a:ea typeface="Consolas" pitchFamily="34" charset="-122"/>
-                <a:cs typeface="Consolas" pitchFamily="34" charset="-120"/>
-              </a:rPr>
-              <a:t>2</a:t>
-            </a:r>
-            <a:endParaRPr lang="en-US" sz="2160" dirty="0"/>
-          </a:p>
-        </p:txBody>
-      </p:sp>
-      <p:sp>
-        <p:nvSpPr>
-          <p:cNvPr id="13" name="Text 11"/>
-          <p:cNvSpPr/>
-          <p:nvPr/>
-        </p:nvSpPr>
-        <p:spPr>
-          <a:xfrm>
-            <a:off x="3712464" y="2697480"/>
-            <a:ext cx="2157984" cy="365760"/>
-          </a:xfrm>
-          <a:prstGeom prst="rect">
-            <a:avLst/>
-          </a:prstGeom>
-          <a:noFill/>
-          <a:ln/>
-        </p:spPr>
-        <p:txBody>
-          <a:bodyPr wrap="square" lIns="0" tIns="0" rIns="0" bIns="0" rtlCol="0" anchor="ctr"/>
+        </p:spPr>
+      </p:sp>
+      <p:sp>
+        <p:nvSpPr>
+          <p:cNvPr id="12" name="Text 9"/>
+          <p:cNvSpPr/>
+          <p:nvPr/>
+        </p:nvSpPr>
+        <p:spPr>
+          <a:xfrm>
+            <a:off x="8412480" y="4279392"/>
+            <a:ext cx="3017520" cy="1371600"/>
+          </a:xfrm>
+          <a:prstGeom prst="rect">
+            <a:avLst/>
+          </a:prstGeom>
+          <a:noFill/>
+          <a:ln/>
+        </p:spPr>
+        <p:txBody>
+          <a:bodyPr wrap="square" lIns="0" tIns="0" rIns="0" bIns="0" rtlCol="0" anchor="t"/>
           <a:lstStyle/>
           <a:p>
             <a:pPr indent="0" marL="0">
-              <a:buNone/>
-            </a:pPr>
-            <a:r>
-              <a:rPr lang="en-US" sz="1500" b="1" dirty="0">
-                <a:solidFill>
-                  <a:srgbClr val="0F172A"/>
+              <a:lnSpc>
+                <a:spcPct val="130000"/>
+              </a:lnSpc>
+              <a:buNone/>
+            </a:pPr>
+            <a:r>
+              <a:rPr lang="en-US" sz="1250" dirty="0">
+                <a:solidFill>
+                  <a:srgbClr val="334155"/>
                 </a:solidFill>
                 <a:latin typeface="Malgun Gothic" pitchFamily="34" charset="0"/>
                 <a:ea typeface="Malgun Gothic" pitchFamily="34" charset="-122"/>
                 <a:cs typeface="Malgun Gothic" pitchFamily="34" charset="-120"/>
               </a:rPr>
-              <a:t>좌표 변환</a:t>
-            </a:r>
-            <a:endParaRPr lang="en-US" sz="1500" dirty="0"/>
-          </a:p>
-        </p:txBody>
-      </p:sp>
-      <p:sp>
-        <p:nvSpPr>
-          <p:cNvPr id="14" name="Text 12"/>
-          <p:cNvSpPr/>
-          <p:nvPr/>
-        </p:nvSpPr>
-        <p:spPr>
-          <a:xfrm>
-            <a:off x="3712464" y="3063240"/>
-            <a:ext cx="2157984" cy="411480"/>
-          </a:xfrm>
-          <a:prstGeom prst="rect">
-            <a:avLst/>
-          </a:prstGeom>
-          <a:noFill/>
-          <a:ln/>
-        </p:spPr>
-        <p:txBody>
-          <a:bodyPr wrap="square" lIns="0" tIns="0" rIns="0" bIns="0" rtlCol="0" anchor="t"/>
-          <a:lstStyle/>
-          <a:p>
-            <a:pPr indent="0" marL="0">
-              <a:lnSpc>
-                <a:spcPct val="110000"/>
-              </a:lnSpc>
-              <a:buNone/>
-            </a:pPr>
-            <a:r>
-              <a:rPr lang="en-US" sz="1100" dirty="0">
-                <a:solidFill>
-                  <a:srgbClr val="64748B"/>
-                </a:solidFill>
-                <a:latin typeface="Malgun Gothic" pitchFamily="34" charset="0"/>
-                <a:ea typeface="Malgun Gothic" pitchFamily="34" charset="-122"/>
-                <a:cs typeface="Malgun Gothic" pitchFamily="34" charset="-120"/>
-              </a:rPr>
-              <a:t>지도 API → 위경도</a:t>
-            </a:r>
-            <a:endParaRPr lang="en-US" sz="1100" dirty="0"/>
-          </a:p>
-        </p:txBody>
-      </p:sp>
-      <p:sp>
-        <p:nvSpPr>
-          <p:cNvPr id="15" name="Text 13"/>
-          <p:cNvSpPr/>
-          <p:nvPr/>
-        </p:nvSpPr>
-        <p:spPr>
-          <a:xfrm>
-            <a:off x="6117336" y="1783080"/>
-            <a:ext cx="283464" cy="1737360"/>
-          </a:xfrm>
-          <a:prstGeom prst="rect">
-            <a:avLst/>
-          </a:prstGeom>
-          <a:noFill/>
-          <a:ln/>
-        </p:spPr>
-        <p:txBody>
-          <a:bodyPr wrap="square" lIns="0" tIns="0" rIns="0" bIns="0" rtlCol="0" anchor="ctr"/>
-          <a:lstStyle/>
-          <a:p>
-            <a:pPr algn="ctr" indent="0" marL="0">
-              <a:buNone/>
-            </a:pPr>
-            <a:r>
-              <a:rPr lang="en-US" sz="2600" b="1" dirty="0">
-                <a:solidFill>
-                  <a:srgbClr val="94A3B8"/>
-                </a:solidFill>
-                <a:latin typeface="Malgun Gothic" pitchFamily="34" charset="0"/>
-                <a:ea typeface="Malgun Gothic" pitchFamily="34" charset="-122"/>
-                <a:cs typeface="Malgun Gothic" pitchFamily="34" charset="-120"/>
-              </a:rPr>
-              <a:t>›</a:t>
-            </a:r>
-            <a:endParaRPr lang="en-US" sz="2600" dirty="0"/>
-          </a:p>
-        </p:txBody>
-      </p:sp>
-      <p:sp>
-        <p:nvSpPr>
-          <p:cNvPr id="16" name="Shape 14"/>
-          <p:cNvSpPr/>
-          <p:nvPr/>
-        </p:nvSpPr>
-        <p:spPr>
-          <a:xfrm>
-            <a:off x="6419088" y="1783080"/>
-            <a:ext cx="2615184" cy="1737360"/>
-          </a:xfrm>
-          <a:prstGeom prst="roundRect">
-            <a:avLst>
-              <a:gd name="adj" fmla="val 4737"/>
-            </a:avLst>
-          </a:prstGeom>
-          <a:solidFill>
-            <a:srgbClr val="FFFFFF"/>
-          </a:solidFill>
-          <a:ln w="12700">
-            <a:solidFill>
-              <a:srgbClr val="E2E8F0"/>
-            </a:solidFill>
-            <a:prstDash val="solid"/>
-          </a:ln>
-          <a:effectLst>
-            <a:outerShdw sx="100000" sy="100000" kx="0" ky="0" algn="bl" rotWithShape="0" blurRad="76200" dist="25400" dir="5400000">
-              <a:srgbClr val="334155">
-                <a:alpha val="12000"/>
-              </a:srgbClr>
-            </a:outerShdw>
-          </a:effectLst>
-        </p:spPr>
-      </p:sp>
-      <p:sp>
-        <p:nvSpPr>
-          <p:cNvPr id="17" name="Shape 15"/>
-          <p:cNvSpPr/>
-          <p:nvPr/>
-        </p:nvSpPr>
-        <p:spPr>
-          <a:xfrm>
-            <a:off x="6647688" y="2039112"/>
-            <a:ext cx="548640" cy="548640"/>
-          </a:xfrm>
-          <a:prstGeom prst="ellipse">
-            <a:avLst/>
-          </a:prstGeom>
-          <a:solidFill>
-            <a:srgbClr val="EA580C"/>
-          </a:solidFill>
-          <a:ln/>
-        </p:spPr>
-      </p:sp>
-      <p:sp>
-        <p:nvSpPr>
-          <p:cNvPr id="18" name="Text 16"/>
-          <p:cNvSpPr/>
-          <p:nvPr/>
-        </p:nvSpPr>
-        <p:spPr>
-          <a:xfrm>
-            <a:off x="6647688" y="2039112"/>
-            <a:ext cx="548640" cy="548640"/>
-          </a:xfrm>
-          <a:prstGeom prst="rect">
-            <a:avLst/>
-          </a:prstGeom>
-          <a:noFill/>
-          <a:ln/>
-        </p:spPr>
-        <p:txBody>
-          <a:bodyPr wrap="square" lIns="0" tIns="0" rIns="0" bIns="0" rtlCol="0" anchor="ctr"/>
-          <a:lstStyle/>
-          <a:p>
-            <a:pPr algn="ctr" indent="0" marL="0">
-              <a:buNone/>
-            </a:pPr>
-            <a:r>
-              <a:rPr lang="en-US" sz="2160" b="1" dirty="0">
-                <a:solidFill>
-                  <a:srgbClr val="FFFFFF"/>
-                </a:solidFill>
-                <a:latin typeface="Consolas" pitchFamily="34" charset="0"/>
-                <a:ea typeface="Consolas" pitchFamily="34" charset="-122"/>
-                <a:cs typeface="Consolas" pitchFamily="34" charset="-120"/>
-              </a:rPr>
-              <a:t>3</a:t>
-            </a:r>
-            <a:endParaRPr lang="en-US" sz="2160" dirty="0"/>
-          </a:p>
-        </p:txBody>
-      </p:sp>
-      <p:sp>
-        <p:nvSpPr>
-          <p:cNvPr id="19" name="Text 17"/>
-          <p:cNvSpPr/>
-          <p:nvPr/>
-        </p:nvSpPr>
-        <p:spPr>
-          <a:xfrm>
-            <a:off x="6647688" y="2697480"/>
-            <a:ext cx="2157984" cy="365760"/>
-          </a:xfrm>
-          <a:prstGeom prst="rect">
-            <a:avLst/>
-          </a:prstGeom>
-          <a:noFill/>
-          <a:ln/>
-        </p:spPr>
-        <p:txBody>
-          <a:bodyPr wrap="square" lIns="0" tIns="0" rIns="0" bIns="0" rtlCol="0" anchor="ctr"/>
-          <a:lstStyle/>
-          <a:p>
-            <a:pPr indent="0" marL="0">
-              <a:buNone/>
-            </a:pPr>
-            <a:r>
-              <a:rPr lang="en-US" sz="1500" b="1" dirty="0">
-                <a:solidFill>
-                  <a:srgbClr val="0F172A"/>
-                </a:solidFill>
-                <a:latin typeface="Malgun Gothic" pitchFamily="34" charset="0"/>
-                <a:ea typeface="Malgun Gothic" pitchFamily="34" charset="-122"/>
-                <a:cs typeface="Malgun Gothic" pitchFamily="34" charset="-120"/>
-              </a:rPr>
-              <a:t>도로망 수집</a:t>
-            </a:r>
-            <a:endParaRPr lang="en-US" sz="1500" dirty="0"/>
-          </a:p>
-        </p:txBody>
-      </p:sp>
-      <p:sp>
-        <p:nvSpPr>
-          <p:cNvPr id="20" name="Text 18"/>
-          <p:cNvSpPr/>
-          <p:nvPr/>
-        </p:nvSpPr>
-        <p:spPr>
-          <a:xfrm>
-            <a:off x="6647688" y="3063240"/>
-            <a:ext cx="2157984" cy="411480"/>
-          </a:xfrm>
-          <a:prstGeom prst="rect">
-            <a:avLst/>
-          </a:prstGeom>
-          <a:noFill/>
-          <a:ln/>
-        </p:spPr>
-        <p:txBody>
-          <a:bodyPr wrap="square" lIns="0" tIns="0" rIns="0" bIns="0" rtlCol="0" anchor="t"/>
-          <a:lstStyle/>
-          <a:p>
-            <a:pPr indent="0" marL="0">
-              <a:lnSpc>
-                <a:spcPct val="110000"/>
-              </a:lnSpc>
-              <a:buNone/>
-            </a:pPr>
-            <a:r>
-              <a:rPr lang="en-US" sz="1100" dirty="0">
-                <a:solidFill>
-                  <a:srgbClr val="64748B"/>
-                </a:solidFill>
-                <a:latin typeface="Malgun Gothic" pitchFamily="34" charset="0"/>
-                <a:ea typeface="Malgun Gothic" pitchFamily="34" charset="-122"/>
-                <a:cs typeface="Malgun Gothic" pitchFamily="34" charset="-120"/>
-              </a:rPr>
-              <a:t>실측 도로 · 골목 폭</a:t>
-            </a:r>
-            <a:endParaRPr lang="en-US" sz="1100" dirty="0"/>
-          </a:p>
-        </p:txBody>
-      </p:sp>
-      <p:sp>
-        <p:nvSpPr>
-          <p:cNvPr id="21" name="Text 19"/>
-          <p:cNvSpPr/>
-          <p:nvPr/>
-        </p:nvSpPr>
-        <p:spPr>
-          <a:xfrm>
-            <a:off x="9052560" y="1783080"/>
-            <a:ext cx="283464" cy="1737360"/>
-          </a:xfrm>
-          <a:prstGeom prst="rect">
-            <a:avLst/>
-          </a:prstGeom>
-          <a:noFill/>
-          <a:ln/>
-        </p:spPr>
-        <p:txBody>
-          <a:bodyPr wrap="square" lIns="0" tIns="0" rIns="0" bIns="0" rtlCol="0" anchor="ctr"/>
-          <a:lstStyle/>
-          <a:p>
-            <a:pPr algn="ctr" indent="0" marL="0">
-              <a:buNone/>
-            </a:pPr>
-            <a:r>
-              <a:rPr lang="en-US" sz="2600" b="1" dirty="0">
-                <a:solidFill>
-                  <a:srgbClr val="94A3B8"/>
-                </a:solidFill>
-                <a:latin typeface="Malgun Gothic" pitchFamily="34" charset="0"/>
-                <a:ea typeface="Malgun Gothic" pitchFamily="34" charset="-122"/>
-                <a:cs typeface="Malgun Gothic" pitchFamily="34" charset="-120"/>
-              </a:rPr>
-              <a:t>›</a:t>
-            </a:r>
-            <a:endParaRPr lang="en-US" sz="2600" dirty="0"/>
-          </a:p>
-        </p:txBody>
-      </p:sp>
-      <p:sp>
-        <p:nvSpPr>
-          <p:cNvPr id="22" name="Shape 20"/>
-          <p:cNvSpPr/>
-          <p:nvPr/>
-        </p:nvSpPr>
-        <p:spPr>
-          <a:xfrm>
-            <a:off x="9354312" y="1783080"/>
-            <a:ext cx="2615184" cy="1737360"/>
-          </a:xfrm>
-          <a:prstGeom prst="roundRect">
-            <a:avLst>
-              <a:gd name="adj" fmla="val 4737"/>
-            </a:avLst>
-          </a:prstGeom>
-          <a:solidFill>
-            <a:srgbClr val="FFFFFF"/>
-          </a:solidFill>
-          <a:ln w="12700">
-            <a:solidFill>
-              <a:srgbClr val="E2E8F0"/>
-            </a:solidFill>
-            <a:prstDash val="solid"/>
-          </a:ln>
-          <a:effectLst>
-            <a:outerShdw sx="100000" sy="100000" kx="0" ky="0" algn="bl" rotWithShape="0" blurRad="76200" dist="25400" dir="5400000">
-              <a:srgbClr val="334155">
-                <a:alpha val="12000"/>
-              </a:srgbClr>
-            </a:outerShdw>
-          </a:effectLst>
-        </p:spPr>
-      </p:sp>
-      <p:sp>
-        <p:nvSpPr>
-          <p:cNvPr id="23" name="Shape 21"/>
-          <p:cNvSpPr/>
-          <p:nvPr/>
-        </p:nvSpPr>
-        <p:spPr>
-          <a:xfrm>
-            <a:off x="9582912" y="2039112"/>
-            <a:ext cx="548640" cy="548640"/>
-          </a:xfrm>
-          <a:prstGeom prst="ellipse">
-            <a:avLst/>
-          </a:prstGeom>
-          <a:solidFill>
-            <a:srgbClr val="DC2626"/>
-          </a:solidFill>
-          <a:ln/>
-        </p:spPr>
-      </p:sp>
-      <p:sp>
-        <p:nvSpPr>
-          <p:cNvPr id="24" name="Text 22"/>
-          <p:cNvSpPr/>
-          <p:nvPr/>
-        </p:nvSpPr>
-        <p:spPr>
-          <a:xfrm>
-            <a:off x="9582912" y="2039112"/>
-            <a:ext cx="548640" cy="548640"/>
-          </a:xfrm>
-          <a:prstGeom prst="rect">
-            <a:avLst/>
-          </a:prstGeom>
-          <a:noFill/>
-          <a:ln/>
-        </p:spPr>
-        <p:txBody>
-          <a:bodyPr wrap="square" lIns="0" tIns="0" rIns="0" bIns="0" rtlCol="0" anchor="ctr"/>
-          <a:lstStyle/>
-          <a:p>
-            <a:pPr algn="ctr" indent="0" marL="0">
-              <a:buNone/>
-            </a:pPr>
-            <a:r>
-              <a:rPr lang="en-US" sz="2160" b="1" dirty="0">
-                <a:solidFill>
-                  <a:srgbClr val="FFFFFF"/>
-                </a:solidFill>
-                <a:latin typeface="Consolas" pitchFamily="34" charset="0"/>
-                <a:ea typeface="Consolas" pitchFamily="34" charset="-122"/>
-                <a:cs typeface="Consolas" pitchFamily="34" charset="-120"/>
-              </a:rPr>
-              <a:t>4</a:t>
-            </a:r>
-            <a:endParaRPr lang="en-US" sz="2160" dirty="0"/>
-          </a:p>
-        </p:txBody>
-      </p:sp>
-      <p:sp>
-        <p:nvSpPr>
-          <p:cNvPr id="25" name="Text 23"/>
-          <p:cNvSpPr/>
-          <p:nvPr/>
-        </p:nvSpPr>
-        <p:spPr>
-          <a:xfrm>
-            <a:off x="9582912" y="2697480"/>
-            <a:ext cx="2157984" cy="365760"/>
-          </a:xfrm>
-          <a:prstGeom prst="rect">
-            <a:avLst/>
-          </a:prstGeom>
-          <a:noFill/>
-          <a:ln/>
-        </p:spPr>
-        <p:txBody>
-          <a:bodyPr wrap="square" lIns="0" tIns="0" rIns="0" bIns="0" rtlCol="0" anchor="ctr"/>
-          <a:lstStyle/>
-          <a:p>
-            <a:pPr indent="0" marL="0">
-              <a:buNone/>
-            </a:pPr>
-            <a:r>
-              <a:rPr lang="en-US" sz="1500" b="1" dirty="0">
-                <a:solidFill>
-                  <a:srgbClr val="0F172A"/>
-                </a:solidFill>
-                <a:latin typeface="Malgun Gothic" pitchFamily="34" charset="0"/>
-                <a:ea typeface="Malgun Gothic" pitchFamily="34" charset="-122"/>
-                <a:cs typeface="Malgun Gothic" pitchFamily="34" charset="-120"/>
-              </a:rPr>
-              <a:t>격자화</a:t>
-            </a:r>
-            <a:endParaRPr lang="en-US" sz="1500" dirty="0"/>
-          </a:p>
-        </p:txBody>
-      </p:sp>
-      <p:sp>
-        <p:nvSpPr>
-          <p:cNvPr id="26" name="Text 24"/>
-          <p:cNvSpPr/>
-          <p:nvPr/>
-        </p:nvSpPr>
-        <p:spPr>
-          <a:xfrm>
-            <a:off x="9582912" y="3063240"/>
-            <a:ext cx="2157984" cy="411480"/>
-          </a:xfrm>
-          <a:prstGeom prst="rect">
-            <a:avLst/>
-          </a:prstGeom>
-          <a:noFill/>
-          <a:ln/>
-        </p:spPr>
-        <p:txBody>
-          <a:bodyPr wrap="square" lIns="0" tIns="0" rIns="0" bIns="0" rtlCol="0" anchor="t"/>
-          <a:lstStyle/>
-          <a:p>
-            <a:pPr indent="0" marL="0">
-              <a:lnSpc>
-                <a:spcPct val="110000"/>
-              </a:lnSpc>
-              <a:buNone/>
-            </a:pPr>
-            <a:r>
-              <a:rPr lang="en-US" sz="1100" dirty="0">
-                <a:solidFill>
-                  <a:srgbClr val="64748B"/>
-                </a:solidFill>
-                <a:latin typeface="Malgun Gothic" pitchFamily="34" charset="0"/>
-                <a:ea typeface="Malgun Gothic" pitchFamily="34" charset="-122"/>
-                <a:cs typeface="Malgun Gothic" pitchFamily="34" charset="-120"/>
-              </a:rPr>
-              <a:t>3m 격자 · 취약지 매핑</a:t>
-            </a:r>
-            <a:endParaRPr lang="en-US" sz="1100" dirty="0"/>
-          </a:p>
-        </p:txBody>
-      </p:sp>
-      <p:sp>
-        <p:nvSpPr>
-          <p:cNvPr id="27" name="Shape 25"/>
-          <p:cNvSpPr/>
-          <p:nvPr/>
-        </p:nvSpPr>
-        <p:spPr>
-          <a:xfrm>
-            <a:off x="548640" y="3886200"/>
-            <a:ext cx="5394960" cy="1920240"/>
-          </a:xfrm>
-          <a:prstGeom prst="roundRect">
-            <a:avLst>
-              <a:gd name="adj" fmla="val 3810"/>
-            </a:avLst>
-          </a:prstGeom>
-          <a:solidFill>
-            <a:srgbClr val="F8FAFC"/>
-          </a:solidFill>
-          <a:ln w="12700">
-            <a:solidFill>
-              <a:srgbClr val="E2E8F0"/>
-            </a:solidFill>
-            <a:prstDash val="solid"/>
-          </a:ln>
-        </p:spPr>
-      </p:sp>
-      <p:sp>
-        <p:nvSpPr>
-          <p:cNvPr id="28" name="Text 26"/>
-          <p:cNvSpPr/>
-          <p:nvPr/>
-        </p:nvSpPr>
-        <p:spPr>
-          <a:xfrm>
-            <a:off x="777240" y="4041648"/>
-            <a:ext cx="4572000" cy="320040"/>
-          </a:xfrm>
-          <a:prstGeom prst="rect">
-            <a:avLst/>
-          </a:prstGeom>
-          <a:noFill/>
-          <a:ln/>
-        </p:spPr>
-        <p:txBody>
-          <a:bodyPr wrap="square" lIns="0" tIns="0" rIns="0" bIns="0" rtlCol="0" anchor="ctr"/>
-          <a:lstStyle/>
-          <a:p>
-            <a:pPr indent="0" marL="0">
-              <a:buNone/>
-            </a:pPr>
-            <a:r>
-              <a:rPr lang="en-US" sz="1300" b="1" dirty="0">
-                <a:solidFill>
-                  <a:srgbClr val="DC2626"/>
-                </a:solidFill>
-                <a:latin typeface="Malgun Gothic" pitchFamily="34" charset="0"/>
-                <a:ea typeface="Malgun Gothic" pitchFamily="34" charset="-122"/>
-                <a:cs typeface="Malgun Gothic" pitchFamily="34" charset="-120"/>
-              </a:rPr>
-              <a:t>무엇을 얻나</a:t>
-            </a:r>
-            <a:endParaRPr lang="en-US" sz="1300" dirty="0"/>
-          </a:p>
-        </p:txBody>
-      </p:sp>
-      <p:sp>
-        <p:nvSpPr>
-          <p:cNvPr id="29" name="Shape 27"/>
-          <p:cNvSpPr/>
-          <p:nvPr/>
-        </p:nvSpPr>
-        <p:spPr>
-          <a:xfrm>
-            <a:off x="822960" y="4480560"/>
-            <a:ext cx="128016" cy="128016"/>
-          </a:xfrm>
-          <a:prstGeom prst="ellipse">
-            <a:avLst/>
-          </a:prstGeom>
-          <a:solidFill>
-            <a:srgbClr val="2563EB"/>
-          </a:solidFill>
-          <a:ln/>
-        </p:spPr>
-      </p:sp>
-      <p:sp>
-        <p:nvSpPr>
-          <p:cNvPr id="30" name="Text 28"/>
-          <p:cNvSpPr/>
-          <p:nvPr/>
-        </p:nvSpPr>
-        <p:spPr>
-          <a:xfrm>
-            <a:off x="1097280" y="4379976"/>
-            <a:ext cx="4663440" cy="365760"/>
-          </a:xfrm>
-          <a:prstGeom prst="rect">
-            <a:avLst/>
-          </a:prstGeom>
-          <a:noFill/>
-          <a:ln/>
-        </p:spPr>
-        <p:txBody>
-          <a:bodyPr wrap="square" lIns="0" tIns="0" rIns="0" bIns="0" rtlCol="0" anchor="ctr"/>
-          <a:lstStyle/>
-          <a:p>
-            <a:pPr indent="0" marL="0">
-              <a:buNone/>
-            </a:pPr>
-            <a:r>
-              <a:rPr lang="en-US" sz="1200" dirty="0">
-                <a:solidFill>
-                  <a:srgbClr val="334155"/>
-                </a:solidFill>
-                <a:latin typeface="Malgun Gothic" pitchFamily="34" charset="0"/>
-                <a:ea typeface="Malgun Gothic" pitchFamily="34" charset="-122"/>
-                <a:cs typeface="Malgun Gothic" pitchFamily="34" charset="-120"/>
-              </a:rPr>
-              <a:t>화재 지점을 실제 좌표·도로 위에 정렬</a:t>
-            </a:r>
-            <a:endParaRPr lang="en-US" sz="1200" dirty="0"/>
-          </a:p>
-        </p:txBody>
-      </p:sp>
-      <p:sp>
-        <p:nvSpPr>
-          <p:cNvPr id="31" name="Shape 29"/>
-          <p:cNvSpPr/>
-          <p:nvPr/>
-        </p:nvSpPr>
-        <p:spPr>
-          <a:xfrm>
-            <a:off x="822960" y="4864608"/>
-            <a:ext cx="128016" cy="128016"/>
-          </a:xfrm>
-          <a:prstGeom prst="ellipse">
-            <a:avLst/>
-          </a:prstGeom>
-          <a:solidFill>
-            <a:srgbClr val="2563EB"/>
-          </a:solidFill>
-          <a:ln/>
-        </p:spPr>
-      </p:sp>
-      <p:sp>
-        <p:nvSpPr>
-          <p:cNvPr id="32" name="Text 30"/>
-          <p:cNvSpPr/>
-          <p:nvPr/>
-        </p:nvSpPr>
-        <p:spPr>
-          <a:xfrm>
-            <a:off x="1097280" y="4764024"/>
-            <a:ext cx="4663440" cy="365760"/>
-          </a:xfrm>
-          <a:prstGeom prst="rect">
-            <a:avLst/>
-          </a:prstGeom>
-          <a:noFill/>
-          <a:ln/>
-        </p:spPr>
-        <p:txBody>
-          <a:bodyPr wrap="square" lIns="0" tIns="0" rIns="0" bIns="0" rtlCol="0" anchor="ctr"/>
-          <a:lstStyle/>
-          <a:p>
-            <a:pPr indent="0" marL="0">
-              <a:buNone/>
-            </a:pPr>
-            <a:r>
-              <a:rPr lang="en-US" sz="1200" dirty="0">
-                <a:solidFill>
-                  <a:srgbClr val="334155"/>
-                </a:solidFill>
-                <a:latin typeface="Malgun Gothic" pitchFamily="34" charset="0"/>
-                <a:ea typeface="Malgun Gothic" pitchFamily="34" charset="-122"/>
-                <a:cs typeface="Malgun Gothic" pitchFamily="34" charset="-120"/>
-              </a:rPr>
-              <a:t>소방차 진입 가능/불가 도로 구분</a:t>
-            </a:r>
-            <a:endParaRPr lang="en-US" sz="1200" dirty="0"/>
-          </a:p>
-        </p:txBody>
-      </p:sp>
-      <p:sp>
-        <p:nvSpPr>
-          <p:cNvPr id="33" name="Shape 31"/>
-          <p:cNvSpPr/>
-          <p:nvPr/>
-        </p:nvSpPr>
-        <p:spPr>
-          <a:xfrm>
-            <a:off x="822960" y="5248656"/>
-            <a:ext cx="128016" cy="128016"/>
-          </a:xfrm>
-          <a:prstGeom prst="ellipse">
-            <a:avLst/>
-          </a:prstGeom>
-          <a:solidFill>
-            <a:srgbClr val="2563EB"/>
-          </a:solidFill>
-          <a:ln/>
-        </p:spPr>
-      </p:sp>
-      <p:sp>
-        <p:nvSpPr>
-          <p:cNvPr id="34" name="Text 32"/>
-          <p:cNvSpPr/>
-          <p:nvPr/>
-        </p:nvSpPr>
-        <p:spPr>
-          <a:xfrm>
-            <a:off x="1097280" y="5148072"/>
-            <a:ext cx="4663440" cy="365760"/>
-          </a:xfrm>
-          <a:prstGeom prst="rect">
-            <a:avLst/>
-          </a:prstGeom>
-          <a:noFill/>
-          <a:ln/>
-        </p:spPr>
-        <p:txBody>
-          <a:bodyPr wrap="square" lIns="0" tIns="0" rIns="0" bIns="0" rtlCol="0" anchor="ctr"/>
-          <a:lstStyle/>
-          <a:p>
-            <a:pPr indent="0" marL="0">
-              <a:buNone/>
-            </a:pPr>
-            <a:r>
-              <a:rPr lang="en-US" sz="1200" dirty="0">
-                <a:solidFill>
-                  <a:srgbClr val="334155"/>
-                </a:solidFill>
-                <a:latin typeface="Malgun Gothic" pitchFamily="34" charset="0"/>
-                <a:ea typeface="Malgun Gothic" pitchFamily="34" charset="-122"/>
-                <a:cs typeface="Malgun Gothic" pitchFamily="34" charset="-120"/>
-              </a:rPr>
-              <a:t>취약지 분석을 위한 격자 데이터 확보</a:t>
-            </a:r>
-            <a:endParaRPr lang="en-US" sz="1200" dirty="0"/>
-          </a:p>
-        </p:txBody>
-      </p:sp>
-      <p:sp>
-        <p:nvSpPr>
-          <p:cNvPr id="35" name="Shape 33"/>
-          <p:cNvSpPr/>
-          <p:nvPr/>
-        </p:nvSpPr>
-        <p:spPr>
-          <a:xfrm>
-            <a:off x="6217920" y="3886200"/>
-            <a:ext cx="5394960" cy="1920240"/>
-          </a:xfrm>
-          <a:prstGeom prst="rect">
-            <a:avLst/>
-          </a:prstGeom>
-          <a:solidFill>
-            <a:srgbClr val="EEF2F6"/>
-          </a:solidFill>
-          <a:ln w="12700">
-            <a:solidFill>
-              <a:srgbClr val="E2E8F0"/>
-            </a:solidFill>
-            <a:prstDash val="solid"/>
-          </a:ln>
-        </p:spPr>
-      </p:sp>
-      <p:sp>
-        <p:nvSpPr>
-          <p:cNvPr id="36" name="Shape 34"/>
-          <p:cNvSpPr/>
-          <p:nvPr/>
-        </p:nvSpPr>
-        <p:spPr>
-          <a:xfrm>
-            <a:off x="6492240" y="4069080"/>
-            <a:ext cx="0" cy="1554480"/>
-          </a:xfrm>
-          <a:prstGeom prst="line">
-            <a:avLst/>
-          </a:prstGeom>
-          <a:noFill/>
-          <a:ln w="12700">
-            <a:solidFill>
-              <a:srgbClr val="CBD5E1"/>
-            </a:solidFill>
-            <a:prstDash val="solid"/>
-          </a:ln>
-        </p:spPr>
-      </p:sp>
-      <p:sp>
-        <p:nvSpPr>
-          <p:cNvPr id="37" name="Shape 35"/>
-          <p:cNvSpPr/>
-          <p:nvPr/>
-        </p:nvSpPr>
-        <p:spPr>
-          <a:xfrm>
-            <a:off x="7516368" y="4069080"/>
-            <a:ext cx="0" cy="1554480"/>
-          </a:xfrm>
-          <a:prstGeom prst="line">
-            <a:avLst/>
-          </a:prstGeom>
-          <a:noFill/>
-          <a:ln w="12700">
-            <a:solidFill>
-              <a:srgbClr val="CBD5E1"/>
-            </a:solidFill>
-            <a:prstDash val="solid"/>
-          </a:ln>
-        </p:spPr>
-      </p:sp>
-      <p:sp>
-        <p:nvSpPr>
-          <p:cNvPr id="38" name="Shape 36"/>
-          <p:cNvSpPr/>
-          <p:nvPr/>
-        </p:nvSpPr>
-        <p:spPr>
-          <a:xfrm>
-            <a:off x="8540496" y="4069080"/>
-            <a:ext cx="0" cy="1554480"/>
-          </a:xfrm>
-          <a:prstGeom prst="line">
-            <a:avLst/>
-          </a:prstGeom>
-          <a:noFill/>
-          <a:ln w="12700">
-            <a:solidFill>
-              <a:srgbClr val="CBD5E1"/>
-            </a:solidFill>
-            <a:prstDash val="solid"/>
-          </a:ln>
-        </p:spPr>
-      </p:sp>
-      <p:sp>
-        <p:nvSpPr>
-          <p:cNvPr id="39" name="Shape 37"/>
-          <p:cNvSpPr/>
-          <p:nvPr/>
-        </p:nvSpPr>
-        <p:spPr>
-          <a:xfrm>
-            <a:off x="9564624" y="4069080"/>
-            <a:ext cx="0" cy="1554480"/>
-          </a:xfrm>
-          <a:prstGeom prst="line">
-            <a:avLst/>
-          </a:prstGeom>
-          <a:noFill/>
-          <a:ln w="12700">
-            <a:solidFill>
-              <a:srgbClr val="CBD5E1"/>
-            </a:solidFill>
-            <a:prstDash val="solid"/>
-          </a:ln>
-        </p:spPr>
-      </p:sp>
-      <p:sp>
-        <p:nvSpPr>
-          <p:cNvPr id="40" name="Shape 38"/>
-          <p:cNvSpPr/>
-          <p:nvPr/>
-        </p:nvSpPr>
-        <p:spPr>
-          <a:xfrm>
-            <a:off x="10588752" y="4069080"/>
-            <a:ext cx="0" cy="1554480"/>
-          </a:xfrm>
-          <a:prstGeom prst="line">
-            <a:avLst/>
-          </a:prstGeom>
-          <a:noFill/>
-          <a:ln w="12700">
-            <a:solidFill>
-              <a:srgbClr val="CBD5E1"/>
-            </a:solidFill>
-            <a:prstDash val="solid"/>
-          </a:ln>
-        </p:spPr>
-      </p:sp>
-      <p:sp>
-        <p:nvSpPr>
-          <p:cNvPr id="41" name="Shape 39"/>
-          <p:cNvSpPr/>
-          <p:nvPr/>
-        </p:nvSpPr>
-        <p:spPr>
-          <a:xfrm>
-            <a:off x="6492240" y="4754880"/>
-            <a:ext cx="4846320" cy="146304"/>
-          </a:xfrm>
-          <a:prstGeom prst="rect">
-            <a:avLst/>
-          </a:prstGeom>
-          <a:solidFill>
-            <a:srgbClr val="2563EB"/>
-          </a:solidFill>
-          <a:ln/>
-        </p:spPr>
-      </p:sp>
-      <p:sp>
-        <p:nvSpPr>
-          <p:cNvPr id="42" name="Shape 40"/>
-          <p:cNvSpPr/>
-          <p:nvPr/>
-        </p:nvSpPr>
-        <p:spPr>
-          <a:xfrm>
-            <a:off x="8503920" y="4069080"/>
-            <a:ext cx="82296" cy="1554480"/>
-          </a:xfrm>
-          <a:prstGeom prst="rect">
-            <a:avLst/>
-          </a:prstGeom>
-          <a:solidFill>
-            <a:srgbClr val="DC2626"/>
-          </a:solidFill>
-          <a:ln/>
-        </p:spPr>
-      </p:sp>
-      <p:sp>
-        <p:nvSpPr>
-          <p:cNvPr id="43" name="Text 41"/>
-          <p:cNvSpPr/>
-          <p:nvPr/>
-        </p:nvSpPr>
-        <p:spPr>
-          <a:xfrm>
-            <a:off x="6217920" y="5495544"/>
-            <a:ext cx="5394960" cy="274320"/>
-          </a:xfrm>
-          <a:prstGeom prst="rect">
-            <a:avLst/>
-          </a:prstGeom>
-          <a:noFill/>
-          <a:ln/>
-        </p:spPr>
-        <p:txBody>
-          <a:bodyPr wrap="square" lIns="0" tIns="0" rIns="0" bIns="0" rtlCol="0" anchor="ctr"/>
-          <a:lstStyle/>
-          <a:p>
-            <a:pPr algn="ctr" indent="0" marL="0">
-              <a:buNone/>
-            </a:pPr>
-            <a:r>
-              <a:rPr lang="en-US" sz="950" dirty="0">
-                <a:solidFill>
-                  <a:srgbClr val="64748B"/>
-                </a:solidFill>
-                <a:latin typeface="Malgun Gothic" pitchFamily="34" charset="0"/>
-                <a:ea typeface="Malgun Gothic" pitchFamily="34" charset="-122"/>
-                <a:cs typeface="Malgun Gothic" pitchFamily="34" charset="-120"/>
-              </a:rPr>
-              <a:t>파랑=진입가능 · 빨강=진입불가 골목</a:t>
-            </a:r>
-            <a:endParaRPr lang="en-US" sz="950" dirty="0"/>
-          </a:p>
-        </p:txBody>
-      </p:sp>
-      <p:sp>
-        <p:nvSpPr>
-          <p:cNvPr id="44" name="Text 42"/>
-          <p:cNvSpPr/>
-          <p:nvPr/>
-        </p:nvSpPr>
-        <p:spPr>
-          <a:xfrm>
-            <a:off x="548640" y="3246120"/>
-            <a:ext cx="11064240" cy="365760"/>
-          </a:xfrm>
-          <a:prstGeom prst="rect">
-            <a:avLst/>
-          </a:prstGeom>
-          <a:noFill/>
-          <a:ln/>
-        </p:spPr>
-        <p:txBody>
-          <a:bodyPr wrap="square" lIns="0" tIns="0" rIns="0" bIns="0" rtlCol="0" anchor="ctr"/>
-          <a:lstStyle/>
-          <a:p>
-            <a:pPr indent="0" marL="0">
-              <a:buNone/>
-            </a:pPr>
-            <a:r>
-              <a:rPr lang="en-US" sz="1250" i="1" dirty="0">
-                <a:solidFill>
-                  <a:srgbClr val="64748B"/>
-                </a:solidFill>
-                <a:latin typeface="Malgun Gothic" pitchFamily="34" charset="0"/>
-                <a:ea typeface="Malgun Gothic" pitchFamily="34" charset="-122"/>
-                <a:cs typeface="Malgun Gothic" pitchFamily="34" charset="-120"/>
-              </a:rPr>
-              <a:t>주소·지점을 좌표로 바꾸고, 실제 도로망을 얹어 3m 격자로 만든다.</a:t>
+              <a:t>경남 전체 화재의 15.8% 집중 — 화재 최다 도시를 드론 배치 대상 지역으로 확정</a:t>
             </a:r>
             <a:endParaRPr lang="en-US" sz="1250" dirty="0"/>
           </a:p>
@@ -11946,7 +11046,7 @@
                 <a:ea typeface="Malgun Gothic" pitchFamily="34" charset="-122"/>
                 <a:cs typeface="Malgun Gothic" pitchFamily="34" charset="-120"/>
               </a:rPr>
-              <a:t>분석 ① — 화재가 자주 나는 지역</a:t>
+              <a:t>지도에 화재지점 표시 · 진입불가 경로는 빨간선</a:t>
             </a:r>
             <a:endParaRPr lang="en-US" sz="2800" dirty="0"/>
           </a:p>
@@ -11954,77 +11054,22 @@
       </p:sp>
       <p:sp>
         <p:nvSpPr>
-          <p:cNvPr id="4" name="Text 2"/>
-          <p:cNvSpPr/>
-          <p:nvPr/>
-        </p:nvSpPr>
-        <p:spPr>
-          <a:xfrm>
-            <a:off x="548640" y="1371600"/>
-            <a:ext cx="7315200" cy="320040"/>
-          </a:xfrm>
-          <a:prstGeom prst="rect">
-            <a:avLst/>
-          </a:prstGeom>
-          <a:noFill/>
-          <a:ln/>
-        </p:spPr>
-        <p:txBody>
-          <a:bodyPr wrap="square" lIns="0" tIns="0" rIns="0" bIns="0" rtlCol="0" anchor="ctr"/>
-          <a:lstStyle/>
-          <a:p>
-            <a:pPr indent="0" marL="0">
-              <a:buNone/>
-            </a:pPr>
-            <a:r>
-              <a:rPr lang="en-US" sz="1300" dirty="0">
-                <a:solidFill>
-                  <a:srgbClr val="64748B"/>
-                </a:solidFill>
-                <a:latin typeface="Malgun Gothic" pitchFamily="34" charset="0"/>
-                <a:ea typeface="Malgun Gothic" pitchFamily="34" charset="-122"/>
-                <a:cs typeface="Malgun Gothic" pitchFamily="34" charset="-120"/>
-              </a:rPr>
-              <a:t>최근 3년 지역별 화재 발생 건수 (예시)</a:t>
-            </a:r>
-            <a:endParaRPr lang="en-US" sz="1300" dirty="0"/>
-          </a:p>
-        </p:txBody>
-      </p:sp>
-      <p:graphicFrame>
-        <p:nvGraphicFramePr>
-          <p:cNvPr id="5" name="Chart 0" descr=""/>
-          <p:cNvGraphicFramePr/>
-          <p:nvPr/>
-        </p:nvGraphicFramePr>
-        <p:xfrm>
-          <a:off x="548640" y="1783080"/>
-          <a:ext cx="6949440" cy="3977640"/>
-        </p:xfrm>
-        <a:graphic xmlns:a="http://schemas.openxmlformats.org/drawingml/2006/main">
-          <a:graphicData uri="http://schemas.openxmlformats.org/drawingml/2006/chart">
-            <c:chart xmlns:c="http://schemas.openxmlformats.org/drawingml/2006/chart" r:id="rId1"/>
-          </a:graphicData>
-        </a:graphic>
-      </p:graphicFrame>
-      <p:sp>
-        <p:nvSpPr>
-          <p:cNvPr id="6" name="Shape 3"/>
-          <p:cNvSpPr/>
-          <p:nvPr/>
-        </p:nvSpPr>
-        <p:spPr>
-          <a:xfrm>
-            <a:off x="7818120" y="1783080"/>
-            <a:ext cx="3794760" cy="3977640"/>
+          <p:cNvPr id="4" name="Shape 2"/>
+          <p:cNvSpPr/>
+          <p:nvPr/>
+        </p:nvSpPr>
+        <p:spPr>
+          <a:xfrm>
+            <a:off x="548640" y="1645920"/>
+            <a:ext cx="7040880" cy="4160520"/>
           </a:xfrm>
           <a:prstGeom prst="roundRect">
             <a:avLst>
-              <a:gd name="adj" fmla="val 2169"/>
+              <a:gd name="adj" fmla="val 1978"/>
             </a:avLst>
           </a:prstGeom>
           <a:solidFill>
-            <a:srgbClr val="F8FAFC"/>
+            <a:srgbClr val="FFFFFF"/>
           </a:solidFill>
           <a:ln w="12700">
             <a:solidFill>
@@ -12043,14 +11088,568 @@
       </p:sp>
       <p:sp>
         <p:nvSpPr>
-          <p:cNvPr id="7" name="Text 4"/>
-          <p:cNvSpPr/>
-          <p:nvPr/>
-        </p:nvSpPr>
-        <p:spPr>
-          <a:xfrm>
-            <a:off x="8092440" y="2011680"/>
-            <a:ext cx="3291840" cy="320040"/>
+          <p:cNvPr id="5" name="Shape 3"/>
+          <p:cNvSpPr/>
+          <p:nvPr/>
+        </p:nvSpPr>
+        <p:spPr>
+          <a:xfrm>
+            <a:off x="777240" y="1874520"/>
+            <a:ext cx="6583680" cy="3383280"/>
+          </a:xfrm>
+          <a:prstGeom prst="rect">
+            <a:avLst/>
+          </a:prstGeom>
+          <a:solidFill>
+            <a:srgbClr val="EEF2F6"/>
+          </a:solidFill>
+          <a:ln w="12700">
+            <a:solidFill>
+              <a:srgbClr val="E2E8F0"/>
+            </a:solidFill>
+            <a:prstDash val="solid"/>
+          </a:ln>
+        </p:spPr>
+      </p:sp>
+      <p:sp>
+        <p:nvSpPr>
+          <p:cNvPr id="6" name="Shape 4"/>
+          <p:cNvSpPr/>
+          <p:nvPr/>
+        </p:nvSpPr>
+        <p:spPr>
+          <a:xfrm>
+            <a:off x="1143000" y="2240280"/>
+            <a:ext cx="1188720" cy="822960"/>
+          </a:xfrm>
+          <a:prstGeom prst="rect">
+            <a:avLst/>
+          </a:prstGeom>
+          <a:solidFill>
+            <a:srgbClr val="DDE3EA"/>
+          </a:solidFill>
+          <a:ln w="9525">
+            <a:solidFill>
+              <a:srgbClr val="CBD5E1"/>
+            </a:solidFill>
+            <a:prstDash val="solid"/>
+          </a:ln>
+        </p:spPr>
+      </p:sp>
+      <p:sp>
+        <p:nvSpPr>
+          <p:cNvPr id="7" name="Shape 5"/>
+          <p:cNvSpPr/>
+          <p:nvPr/>
+        </p:nvSpPr>
+        <p:spPr>
+          <a:xfrm>
+            <a:off x="2788920" y="2194560"/>
+            <a:ext cx="1280160" cy="731520"/>
+          </a:xfrm>
+          <a:prstGeom prst="rect">
+            <a:avLst/>
+          </a:prstGeom>
+          <a:solidFill>
+            <a:srgbClr val="DDE3EA"/>
+          </a:solidFill>
+          <a:ln w="9525">
+            <a:solidFill>
+              <a:srgbClr val="CBD5E1"/>
+            </a:solidFill>
+            <a:prstDash val="solid"/>
+          </a:ln>
+        </p:spPr>
+      </p:sp>
+      <p:sp>
+        <p:nvSpPr>
+          <p:cNvPr id="8" name="Shape 6"/>
+          <p:cNvSpPr/>
+          <p:nvPr/>
+        </p:nvSpPr>
+        <p:spPr>
+          <a:xfrm>
+            <a:off x="5349240" y="2286000"/>
+            <a:ext cx="1280160" cy="822960"/>
+          </a:xfrm>
+          <a:prstGeom prst="rect">
+            <a:avLst/>
+          </a:prstGeom>
+          <a:solidFill>
+            <a:srgbClr val="DDE3EA"/>
+          </a:solidFill>
+          <a:ln w="9525">
+            <a:solidFill>
+              <a:srgbClr val="CBD5E1"/>
+            </a:solidFill>
+            <a:prstDash val="solid"/>
+          </a:ln>
+        </p:spPr>
+      </p:sp>
+      <p:sp>
+        <p:nvSpPr>
+          <p:cNvPr id="9" name="Shape 7"/>
+          <p:cNvSpPr/>
+          <p:nvPr/>
+        </p:nvSpPr>
+        <p:spPr>
+          <a:xfrm>
+            <a:off x="1234440" y="3520440"/>
+            <a:ext cx="1097280" cy="914400"/>
+          </a:xfrm>
+          <a:prstGeom prst="rect">
+            <a:avLst/>
+          </a:prstGeom>
+          <a:solidFill>
+            <a:srgbClr val="DDE3EA"/>
+          </a:solidFill>
+          <a:ln w="9525">
+            <a:solidFill>
+              <a:srgbClr val="CBD5E1"/>
+            </a:solidFill>
+            <a:prstDash val="solid"/>
+          </a:ln>
+        </p:spPr>
+      </p:sp>
+      <p:sp>
+        <p:nvSpPr>
+          <p:cNvPr id="10" name="Shape 8"/>
+          <p:cNvSpPr/>
+          <p:nvPr/>
+        </p:nvSpPr>
+        <p:spPr>
+          <a:xfrm>
+            <a:off x="4069080" y="3429000"/>
+            <a:ext cx="1188720" cy="1005840"/>
+          </a:xfrm>
+          <a:prstGeom prst="rect">
+            <a:avLst/>
+          </a:prstGeom>
+          <a:solidFill>
+            <a:srgbClr val="DDE3EA"/>
+          </a:solidFill>
+          <a:ln w="9525">
+            <a:solidFill>
+              <a:srgbClr val="CBD5E1"/>
+            </a:solidFill>
+            <a:prstDash val="solid"/>
+          </a:ln>
+        </p:spPr>
+      </p:sp>
+      <p:sp>
+        <p:nvSpPr>
+          <p:cNvPr id="11" name="Shape 9"/>
+          <p:cNvSpPr/>
+          <p:nvPr/>
+        </p:nvSpPr>
+        <p:spPr>
+          <a:xfrm>
+            <a:off x="5897880" y="3611880"/>
+            <a:ext cx="1097280" cy="914400"/>
+          </a:xfrm>
+          <a:prstGeom prst="rect">
+            <a:avLst/>
+          </a:prstGeom>
+          <a:solidFill>
+            <a:srgbClr val="DDE3EA"/>
+          </a:solidFill>
+          <a:ln w="9525">
+            <a:solidFill>
+              <a:srgbClr val="CBD5E1"/>
+            </a:solidFill>
+            <a:prstDash val="solid"/>
+          </a:ln>
+        </p:spPr>
+      </p:sp>
+      <p:sp>
+        <p:nvSpPr>
+          <p:cNvPr id="12" name="Shape 10"/>
+          <p:cNvSpPr/>
+          <p:nvPr/>
+        </p:nvSpPr>
+        <p:spPr>
+          <a:xfrm>
+            <a:off x="2514600" y="4251960"/>
+            <a:ext cx="1188720" cy="640080"/>
+          </a:xfrm>
+          <a:prstGeom prst="rect">
+            <a:avLst/>
+          </a:prstGeom>
+          <a:solidFill>
+            <a:srgbClr val="DDE3EA"/>
+          </a:solidFill>
+          <a:ln w="9525">
+            <a:solidFill>
+              <a:srgbClr val="CBD5E1"/>
+            </a:solidFill>
+            <a:prstDash val="solid"/>
+          </a:ln>
+        </p:spPr>
+      </p:sp>
+      <p:sp>
+        <p:nvSpPr>
+          <p:cNvPr id="13" name="Shape 11"/>
+          <p:cNvSpPr/>
+          <p:nvPr/>
+        </p:nvSpPr>
+        <p:spPr>
+          <a:xfrm>
+            <a:off x="960120" y="3291840"/>
+            <a:ext cx="6217920" cy="0"/>
+          </a:xfrm>
+          <a:prstGeom prst="line">
+            <a:avLst/>
+          </a:prstGeom>
+          <a:noFill/>
+          <a:ln w="57150">
+            <a:solidFill>
+              <a:srgbClr val="2563EB"/>
+            </a:solidFill>
+            <a:prstDash val="solid"/>
+          </a:ln>
+        </p:spPr>
+      </p:sp>
+      <p:sp>
+        <p:nvSpPr>
+          <p:cNvPr id="14" name="Shape 12"/>
+          <p:cNvSpPr/>
+          <p:nvPr/>
+        </p:nvSpPr>
+        <p:spPr>
+          <a:xfrm>
+            <a:off x="2606040" y="2057400"/>
+            <a:ext cx="0" cy="3017520"/>
+          </a:xfrm>
+          <a:prstGeom prst="line">
+            <a:avLst/>
+          </a:prstGeom>
+          <a:noFill/>
+          <a:ln w="57150">
+            <a:solidFill>
+              <a:srgbClr val="2563EB"/>
+            </a:solidFill>
+            <a:prstDash val="solid"/>
+          </a:ln>
+        </p:spPr>
+      </p:sp>
+      <p:sp>
+        <p:nvSpPr>
+          <p:cNvPr id="15" name="Shape 13"/>
+          <p:cNvSpPr/>
+          <p:nvPr/>
+        </p:nvSpPr>
+        <p:spPr>
+          <a:xfrm>
+            <a:off x="5257800" y="3291840"/>
+            <a:ext cx="0" cy="1783080"/>
+          </a:xfrm>
+          <a:prstGeom prst="line">
+            <a:avLst/>
+          </a:prstGeom>
+          <a:noFill/>
+          <a:ln w="50800">
+            <a:solidFill>
+              <a:srgbClr val="2563EB"/>
+            </a:solidFill>
+            <a:prstDash val="solid"/>
+          </a:ln>
+        </p:spPr>
+      </p:sp>
+      <p:sp>
+        <p:nvSpPr>
+          <p:cNvPr id="16" name="Shape 14"/>
+          <p:cNvSpPr/>
+          <p:nvPr/>
+        </p:nvSpPr>
+        <p:spPr>
+          <a:xfrm>
+            <a:off x="2606040" y="3291840"/>
+            <a:ext cx="1005840" cy="-777240"/>
+          </a:xfrm>
+          <a:prstGeom prst="line">
+            <a:avLst/>
+          </a:prstGeom>
+          <a:noFill/>
+          <a:ln w="44450">
+            <a:solidFill>
+              <a:srgbClr val="DC2626"/>
+            </a:solidFill>
+            <a:prstDash val="solid"/>
+          </a:ln>
+        </p:spPr>
+      </p:sp>
+      <p:sp>
+        <p:nvSpPr>
+          <p:cNvPr id="17" name="Shape 15"/>
+          <p:cNvSpPr/>
+          <p:nvPr/>
+        </p:nvSpPr>
+        <p:spPr>
+          <a:xfrm>
+            <a:off x="5257800" y="3291840"/>
+            <a:ext cx="914400" cy="-640080"/>
+          </a:xfrm>
+          <a:prstGeom prst="line">
+            <a:avLst/>
+          </a:prstGeom>
+          <a:noFill/>
+          <a:ln w="44450">
+            <a:solidFill>
+              <a:srgbClr val="DC2626"/>
+            </a:solidFill>
+            <a:prstDash val="solid"/>
+          </a:ln>
+        </p:spPr>
+      </p:sp>
+      <p:sp>
+        <p:nvSpPr>
+          <p:cNvPr id="18" name="Shape 16"/>
+          <p:cNvSpPr/>
+          <p:nvPr/>
+        </p:nvSpPr>
+        <p:spPr>
+          <a:xfrm>
+            <a:off x="1600200" y="3291840"/>
+            <a:ext cx="0" cy="1051560"/>
+          </a:xfrm>
+          <a:prstGeom prst="line">
+            <a:avLst/>
+          </a:prstGeom>
+          <a:noFill/>
+          <a:ln w="44450">
+            <a:solidFill>
+              <a:srgbClr val="DC2626"/>
+            </a:solidFill>
+            <a:prstDash val="solid"/>
+          </a:ln>
+        </p:spPr>
+      </p:sp>
+      <p:sp>
+        <p:nvSpPr>
+          <p:cNvPr id="19" name="Shape 17"/>
+          <p:cNvSpPr/>
+          <p:nvPr/>
+        </p:nvSpPr>
+        <p:spPr>
+          <a:xfrm>
+            <a:off x="3977640" y="4526280"/>
+            <a:ext cx="1005840" cy="228600"/>
+          </a:xfrm>
+          <a:prstGeom prst="line">
+            <a:avLst/>
+          </a:prstGeom>
+          <a:noFill/>
+          <a:ln w="44450">
+            <a:solidFill>
+              <a:srgbClr val="DC2626"/>
+            </a:solidFill>
+            <a:prstDash val="solid"/>
+          </a:ln>
+        </p:spPr>
+      </p:sp>
+      <p:sp>
+        <p:nvSpPr>
+          <p:cNvPr id="20" name="Shape 18"/>
+          <p:cNvSpPr/>
+          <p:nvPr/>
+        </p:nvSpPr>
+        <p:spPr>
+          <a:xfrm>
+            <a:off x="6446520" y="3291840"/>
+            <a:ext cx="457200" cy="1051560"/>
+          </a:xfrm>
+          <a:prstGeom prst="line">
+            <a:avLst/>
+          </a:prstGeom>
+          <a:noFill/>
+          <a:ln w="44450">
+            <a:solidFill>
+              <a:srgbClr val="DC2626"/>
+            </a:solidFill>
+            <a:prstDash val="solid"/>
+          </a:ln>
+        </p:spPr>
+      </p:sp>
+      <p:sp>
+        <p:nvSpPr>
+          <p:cNvPr id="21" name="Shape 19"/>
+          <p:cNvSpPr/>
+          <p:nvPr/>
+        </p:nvSpPr>
+        <p:spPr>
+          <a:xfrm>
+            <a:off x="3483864" y="2386584"/>
+            <a:ext cx="256032" cy="256032"/>
+          </a:xfrm>
+          <a:prstGeom prst="ellipse">
+            <a:avLst/>
+          </a:prstGeom>
+          <a:solidFill>
+            <a:srgbClr val="EA580C"/>
+          </a:solidFill>
+          <a:ln w="19050">
+            <a:solidFill>
+              <a:srgbClr val="DC2626"/>
+            </a:solidFill>
+            <a:prstDash val="solid"/>
+          </a:ln>
+        </p:spPr>
+      </p:sp>
+      <p:sp>
+        <p:nvSpPr>
+          <p:cNvPr id="22" name="Shape 20"/>
+          <p:cNvSpPr/>
+          <p:nvPr/>
+        </p:nvSpPr>
+        <p:spPr>
+          <a:xfrm>
+            <a:off x="6044184" y="2523744"/>
+            <a:ext cx="256032" cy="256032"/>
+          </a:xfrm>
+          <a:prstGeom prst="ellipse">
+            <a:avLst/>
+          </a:prstGeom>
+          <a:solidFill>
+            <a:srgbClr val="EA580C"/>
+          </a:solidFill>
+          <a:ln w="19050">
+            <a:solidFill>
+              <a:srgbClr val="DC2626"/>
+            </a:solidFill>
+            <a:prstDash val="solid"/>
+          </a:ln>
+        </p:spPr>
+      </p:sp>
+      <p:sp>
+        <p:nvSpPr>
+          <p:cNvPr id="23" name="Shape 21"/>
+          <p:cNvSpPr/>
+          <p:nvPr/>
+        </p:nvSpPr>
+        <p:spPr>
+          <a:xfrm>
+            <a:off x="1472184" y="4215384"/>
+            <a:ext cx="256032" cy="256032"/>
+          </a:xfrm>
+          <a:prstGeom prst="ellipse">
+            <a:avLst/>
+          </a:prstGeom>
+          <a:solidFill>
+            <a:srgbClr val="EA580C"/>
+          </a:solidFill>
+          <a:ln w="19050">
+            <a:solidFill>
+              <a:srgbClr val="DC2626"/>
+            </a:solidFill>
+            <a:prstDash val="solid"/>
+          </a:ln>
+        </p:spPr>
+      </p:sp>
+      <p:sp>
+        <p:nvSpPr>
+          <p:cNvPr id="24" name="Shape 22"/>
+          <p:cNvSpPr/>
+          <p:nvPr/>
+        </p:nvSpPr>
+        <p:spPr>
+          <a:xfrm>
+            <a:off x="4855464" y="4626864"/>
+            <a:ext cx="256032" cy="256032"/>
+          </a:xfrm>
+          <a:prstGeom prst="ellipse">
+            <a:avLst/>
+          </a:prstGeom>
+          <a:solidFill>
+            <a:srgbClr val="EA580C"/>
+          </a:solidFill>
+          <a:ln w="19050">
+            <a:solidFill>
+              <a:srgbClr val="DC2626"/>
+            </a:solidFill>
+            <a:prstDash val="solid"/>
+          </a:ln>
+        </p:spPr>
+      </p:sp>
+      <p:sp>
+        <p:nvSpPr>
+          <p:cNvPr id="25" name="Shape 23"/>
+          <p:cNvSpPr/>
+          <p:nvPr/>
+        </p:nvSpPr>
+        <p:spPr>
+          <a:xfrm>
+            <a:off x="6775704" y="4215384"/>
+            <a:ext cx="256032" cy="256032"/>
+          </a:xfrm>
+          <a:prstGeom prst="ellipse">
+            <a:avLst/>
+          </a:prstGeom>
+          <a:solidFill>
+            <a:srgbClr val="EA580C"/>
+          </a:solidFill>
+          <a:ln w="19050">
+            <a:solidFill>
+              <a:srgbClr val="DC2626"/>
+            </a:solidFill>
+            <a:prstDash val="solid"/>
+          </a:ln>
+        </p:spPr>
+      </p:sp>
+      <p:sp>
+        <p:nvSpPr>
+          <p:cNvPr id="26" name="Shape 24"/>
+          <p:cNvSpPr/>
+          <p:nvPr/>
+        </p:nvSpPr>
+        <p:spPr>
+          <a:xfrm>
+            <a:off x="822960" y="4754880"/>
+            <a:ext cx="365760" cy="365760"/>
+          </a:xfrm>
+          <a:prstGeom prst="ellipse">
+            <a:avLst/>
+          </a:prstGeom>
+          <a:solidFill>
+            <a:srgbClr val="FFFFFF"/>
+          </a:solidFill>
+          <a:ln w="31750">
+            <a:solidFill>
+              <a:srgbClr val="2563EB"/>
+            </a:solidFill>
+            <a:prstDash val="solid"/>
+          </a:ln>
+        </p:spPr>
+      </p:sp>
+      <p:sp>
+        <p:nvSpPr>
+          <p:cNvPr id="27" name="Shape 25"/>
+          <p:cNvSpPr/>
+          <p:nvPr/>
+        </p:nvSpPr>
+        <p:spPr>
+          <a:xfrm>
+            <a:off x="905256" y="4837176"/>
+            <a:ext cx="201168" cy="201168"/>
+          </a:xfrm>
+          <a:prstGeom prst="rect">
+            <a:avLst/>
+          </a:prstGeom>
+          <a:solidFill>
+            <a:srgbClr val="2563EB"/>
+          </a:solidFill>
+          <a:ln/>
+        </p:spPr>
+      </p:sp>
+      <p:sp>
+        <p:nvSpPr>
+          <p:cNvPr id="28" name="Text 26"/>
+          <p:cNvSpPr/>
+          <p:nvPr/>
+        </p:nvSpPr>
+        <p:spPr>
+          <a:xfrm>
+            <a:off x="685800" y="5111496"/>
+            <a:ext cx="640080" cy="201168"/>
           </a:xfrm>
           <a:prstGeom prst="rect">
             <a:avLst/>
@@ -12062,54 +11661,57 @@
           <a:bodyPr wrap="square" lIns="0" tIns="0" rIns="0" bIns="0" rtlCol="0" anchor="ctr"/>
           <a:lstStyle/>
           <a:p>
-            <a:pPr indent="0" marL="0">
-              <a:buNone/>
-            </a:pPr>
-            <a:r>
-              <a:rPr lang="en-US" sz="1400" b="1" dirty="0">
-                <a:solidFill>
-                  <a:srgbClr val="DC2626"/>
+            <a:pPr algn="ctr" indent="0" marL="0">
+              <a:buNone/>
+            </a:pPr>
+            <a:r>
+              <a:rPr lang="en-US" sz="800" b="1" dirty="0">
+                <a:solidFill>
+                  <a:srgbClr val="2563EB"/>
                 </a:solidFill>
                 <a:latin typeface="Malgun Gothic" pitchFamily="34" charset="0"/>
                 <a:ea typeface="Malgun Gothic" pitchFamily="34" charset="-122"/>
                 <a:cs typeface="Malgun Gothic" pitchFamily="34" charset="-120"/>
               </a:rPr>
-              <a:t>읽는 법</a:t>
-            </a:r>
-            <a:endParaRPr lang="en-US" sz="1400" dirty="0"/>
-          </a:p>
-        </p:txBody>
-      </p:sp>
-      <p:sp>
-        <p:nvSpPr>
-          <p:cNvPr id="8" name="Shape 5"/>
-          <p:cNvSpPr/>
-          <p:nvPr/>
-        </p:nvSpPr>
-        <p:spPr>
-          <a:xfrm>
-            <a:off x="8138160" y="2542032"/>
-            <a:ext cx="137160" cy="137160"/>
-          </a:xfrm>
-          <a:prstGeom prst="ellipse">
-            <a:avLst/>
-          </a:prstGeom>
-          <a:solidFill>
-            <a:srgbClr val="DC2626"/>
-          </a:solidFill>
-          <a:ln/>
-        </p:spPr>
-      </p:sp>
-      <p:sp>
-        <p:nvSpPr>
-          <p:cNvPr id="9" name="Text 6"/>
-          <p:cNvSpPr/>
-          <p:nvPr/>
-        </p:nvSpPr>
-        <p:spPr>
-          <a:xfrm>
-            <a:off x="8412480" y="2395728"/>
-            <a:ext cx="3017520" cy="548640"/>
+              <a:t>소방서</a:t>
+            </a:r>
+            <a:endParaRPr lang="en-US" sz="800" dirty="0"/>
+          </a:p>
+        </p:txBody>
+      </p:sp>
+      <p:sp>
+        <p:nvSpPr>
+          <p:cNvPr id="29" name="Shape 27"/>
+          <p:cNvSpPr/>
+          <p:nvPr/>
+        </p:nvSpPr>
+        <p:spPr>
+          <a:xfrm>
+            <a:off x="822960" y="5513832"/>
+            <a:ext cx="365760" cy="0"/>
+          </a:xfrm>
+          <a:prstGeom prst="line">
+            <a:avLst/>
+          </a:prstGeom>
+          <a:noFill/>
+          <a:ln w="44450">
+            <a:solidFill>
+              <a:srgbClr val="DC2626"/>
+            </a:solidFill>
+            <a:prstDash val="solid"/>
+          </a:ln>
+        </p:spPr>
+      </p:sp>
+      <p:sp>
+        <p:nvSpPr>
+          <p:cNvPr id="30" name="Text 28"/>
+          <p:cNvSpPr/>
+          <p:nvPr/>
+        </p:nvSpPr>
+        <p:spPr>
+          <a:xfrm>
+            <a:off x="1261872" y="5385816"/>
+            <a:ext cx="2011680" cy="274320"/>
           </a:xfrm>
           <a:prstGeom prst="rect">
             <a:avLst/>
@@ -12122,13 +11724,10 @@
           <a:lstStyle/>
           <a:p>
             <a:pPr indent="0" marL="0">
-              <a:lnSpc>
-                <a:spcPct val="110000"/>
-              </a:lnSpc>
-              <a:buNone/>
-            </a:pPr>
-            <a:r>
-              <a:rPr lang="en-US" sz="1200" dirty="0">
+              <a:buNone/>
+            </a:pPr>
+            <a:r>
+              <a:rPr lang="en-US" sz="1000" dirty="0">
                 <a:solidFill>
                   <a:srgbClr val="334155"/>
                 </a:solidFill>
@@ -12136,42 +11735,45 @@
                 <a:ea typeface="Malgun Gothic" pitchFamily="34" charset="-122"/>
                 <a:cs typeface="Malgun Gothic" pitchFamily="34" charset="-120"/>
               </a:rPr>
-              <a:t>구도심(마산합포·진해)이 상위</a:t>
-            </a:r>
-            <a:endParaRPr lang="en-US" sz="1200" dirty="0"/>
-          </a:p>
-        </p:txBody>
-      </p:sp>
-      <p:sp>
-        <p:nvSpPr>
-          <p:cNvPr id="10" name="Shape 7"/>
-          <p:cNvSpPr/>
-          <p:nvPr/>
-        </p:nvSpPr>
-        <p:spPr>
-          <a:xfrm>
-            <a:off x="8138160" y="3108960"/>
-            <a:ext cx="137160" cy="137160"/>
-          </a:xfrm>
-          <a:prstGeom prst="ellipse">
-            <a:avLst/>
-          </a:prstGeom>
-          <a:solidFill>
-            <a:srgbClr val="DC2626"/>
-          </a:solidFill>
-          <a:ln/>
-        </p:spPr>
-      </p:sp>
-      <p:sp>
-        <p:nvSpPr>
-          <p:cNvPr id="11" name="Text 8"/>
-          <p:cNvSpPr/>
-          <p:nvPr/>
-        </p:nvSpPr>
-        <p:spPr>
-          <a:xfrm>
-            <a:off x="8412480" y="2962656"/>
-            <a:ext cx="3017520" cy="548640"/>
+              <a:t>소방차 진입불가 경로</a:t>
+            </a:r>
+            <a:endParaRPr lang="en-US" sz="1000" dirty="0"/>
+          </a:p>
+        </p:txBody>
+      </p:sp>
+      <p:sp>
+        <p:nvSpPr>
+          <p:cNvPr id="31" name="Shape 29"/>
+          <p:cNvSpPr/>
+          <p:nvPr/>
+        </p:nvSpPr>
+        <p:spPr>
+          <a:xfrm>
+            <a:off x="3291840" y="5513832"/>
+            <a:ext cx="365760" cy="0"/>
+          </a:xfrm>
+          <a:prstGeom prst="line">
+            <a:avLst/>
+          </a:prstGeom>
+          <a:noFill/>
+          <a:ln w="44450">
+            <a:solidFill>
+              <a:srgbClr val="2563EB"/>
+            </a:solidFill>
+            <a:prstDash val="solid"/>
+          </a:ln>
+        </p:spPr>
+      </p:sp>
+      <p:sp>
+        <p:nvSpPr>
+          <p:cNvPr id="32" name="Text 30"/>
+          <p:cNvSpPr/>
+          <p:nvPr/>
+        </p:nvSpPr>
+        <p:spPr>
+          <a:xfrm>
+            <a:off x="3730752" y="5385816"/>
+            <a:ext cx="1554480" cy="274320"/>
           </a:xfrm>
           <a:prstGeom prst="rect">
             <a:avLst/>
@@ -12184,13 +11786,10 @@
           <a:lstStyle/>
           <a:p>
             <a:pPr indent="0" marL="0">
-              <a:lnSpc>
-                <a:spcPct val="110000"/>
-              </a:lnSpc>
-              <a:buNone/>
-            </a:pPr>
-            <a:r>
-              <a:rPr lang="en-US" sz="1200" dirty="0">
+              <a:buNone/>
+            </a:pPr>
+            <a:r>
+              <a:rPr lang="en-US" sz="1000" dirty="0">
                 <a:solidFill>
                   <a:srgbClr val="334155"/>
                 </a:solidFill>
@@ -12198,42 +11797,47 @@
                 <a:ea typeface="Malgun Gothic" pitchFamily="34" charset="-122"/>
                 <a:cs typeface="Malgun Gothic" pitchFamily="34" charset="-120"/>
               </a:rPr>
-              <a:t>전통시장·노후주택 밀집과 겹침</a:t>
-            </a:r>
-            <a:endParaRPr lang="en-US" sz="1200" dirty="0"/>
-          </a:p>
-        </p:txBody>
-      </p:sp>
-      <p:sp>
-        <p:nvSpPr>
-          <p:cNvPr id="12" name="Shape 9"/>
-          <p:cNvSpPr/>
-          <p:nvPr/>
-        </p:nvSpPr>
-        <p:spPr>
-          <a:xfrm>
-            <a:off x="8138160" y="3675888"/>
-            <a:ext cx="137160" cy="137160"/>
+              <a:t>진입가능 도로</a:t>
+            </a:r>
+            <a:endParaRPr lang="en-US" sz="1000" dirty="0"/>
+          </a:p>
+        </p:txBody>
+      </p:sp>
+      <p:sp>
+        <p:nvSpPr>
+          <p:cNvPr id="33" name="Shape 31"/>
+          <p:cNvSpPr/>
+          <p:nvPr/>
+        </p:nvSpPr>
+        <p:spPr>
+          <a:xfrm>
+            <a:off x="5303520" y="5440680"/>
+            <a:ext cx="164592" cy="164592"/>
           </a:xfrm>
           <a:prstGeom prst="ellipse">
             <a:avLst/>
           </a:prstGeom>
           <a:solidFill>
-            <a:srgbClr val="DC2626"/>
-          </a:solidFill>
-          <a:ln/>
-        </p:spPr>
-      </p:sp>
-      <p:sp>
-        <p:nvSpPr>
-          <p:cNvPr id="13" name="Text 10"/>
-          <p:cNvSpPr/>
-          <p:nvPr/>
-        </p:nvSpPr>
-        <p:spPr>
-          <a:xfrm>
-            <a:off x="8412480" y="3529584"/>
-            <a:ext cx="3017520" cy="548640"/>
+            <a:srgbClr val="EA580C"/>
+          </a:solidFill>
+          <a:ln w="19050">
+            <a:solidFill>
+              <a:srgbClr val="DC2626"/>
+            </a:solidFill>
+            <a:prstDash val="solid"/>
+          </a:ln>
+        </p:spPr>
+      </p:sp>
+      <p:sp>
+        <p:nvSpPr>
+          <p:cNvPr id="34" name="Text 32"/>
+          <p:cNvSpPr/>
+          <p:nvPr/>
+        </p:nvSpPr>
+        <p:spPr>
+          <a:xfrm>
+            <a:off x="5532120" y="5385816"/>
+            <a:ext cx="1737360" cy="274320"/>
           </a:xfrm>
           <a:prstGeom prst="rect">
             <a:avLst/>
@@ -12246,13 +11850,10 @@
           <a:lstStyle/>
           <a:p>
             <a:pPr indent="0" marL="0">
-              <a:lnSpc>
-                <a:spcPct val="110000"/>
-              </a:lnSpc>
-              <a:buNone/>
-            </a:pPr>
-            <a:r>
-              <a:rPr lang="en-US" sz="1200" dirty="0">
+              <a:buNone/>
+            </a:pPr>
+            <a:r>
+              <a:rPr lang="en-US" sz="1000" dirty="0">
                 <a:solidFill>
                   <a:srgbClr val="334155"/>
                 </a:solidFill>
@@ -12260,34 +11861,34 @@
                 <a:ea typeface="Malgun Gothic" pitchFamily="34" charset="-122"/>
                 <a:cs typeface="Malgun Gothic" pitchFamily="34" charset="-120"/>
               </a:rPr>
-              <a:t>화재 빈도 = 위험지수의 핵심 축</a:t>
-            </a:r>
-            <a:endParaRPr lang="en-US" sz="1200" dirty="0"/>
-          </a:p>
-        </p:txBody>
-      </p:sp>
-      <p:sp>
-        <p:nvSpPr>
-          <p:cNvPr id="14" name="Shape 11"/>
-          <p:cNvSpPr/>
-          <p:nvPr/>
-        </p:nvSpPr>
-        <p:spPr>
-          <a:xfrm>
-            <a:off x="8092440" y="4343400"/>
-            <a:ext cx="3291840" cy="1188720"/>
+              <a:t>화재 발생지점</a:t>
+            </a:r>
+            <a:endParaRPr lang="en-US" sz="1000" dirty="0"/>
+          </a:p>
+        </p:txBody>
+      </p:sp>
+      <p:sp>
+        <p:nvSpPr>
+          <p:cNvPr id="35" name="Shape 33"/>
+          <p:cNvSpPr/>
+          <p:nvPr/>
+        </p:nvSpPr>
+        <p:spPr>
+          <a:xfrm>
+            <a:off x="7772400" y="1737360"/>
+            <a:ext cx="3840480" cy="932688"/>
           </a:xfrm>
           <a:prstGeom prst="roundRect">
             <a:avLst>
-              <a:gd name="adj" fmla="val 6154"/>
+              <a:gd name="adj" fmla="val 7843"/>
             </a:avLst>
           </a:prstGeom>
           <a:solidFill>
-            <a:srgbClr val="FEE2E2"/>
+            <a:srgbClr val="F8FAFC"/>
           </a:solidFill>
           <a:ln w="12700">
             <a:solidFill>
-              <a:srgbClr val="FCA5A5"/>
+              <a:srgbClr val="E2E8F0"/>
             </a:solidFill>
             <a:prstDash val="solid"/>
           </a:ln>
@@ -12295,14 +11896,34 @@
       </p:sp>
       <p:sp>
         <p:nvSpPr>
-          <p:cNvPr id="15" name="Text 12"/>
-          <p:cNvSpPr/>
-          <p:nvPr/>
-        </p:nvSpPr>
-        <p:spPr>
-          <a:xfrm>
-            <a:off x="8321040" y="4480560"/>
-            <a:ext cx="2834640" cy="320040"/>
+          <p:cNvPr id="36" name="Shape 34"/>
+          <p:cNvSpPr/>
+          <p:nvPr/>
+        </p:nvSpPr>
+        <p:spPr>
+          <a:xfrm>
+            <a:off x="7973568" y="1993392"/>
+            <a:ext cx="420624" cy="420624"/>
+          </a:xfrm>
+          <a:prstGeom prst="ellipse">
+            <a:avLst/>
+          </a:prstGeom>
+          <a:solidFill>
+            <a:srgbClr val="EA580C"/>
+          </a:solidFill>
+          <a:ln/>
+        </p:spPr>
+      </p:sp>
+      <p:sp>
+        <p:nvSpPr>
+          <p:cNvPr id="37" name="Text 35"/>
+          <p:cNvSpPr/>
+          <p:nvPr/>
+        </p:nvSpPr>
+        <p:spPr>
+          <a:xfrm>
+            <a:off x="7973568" y="1993392"/>
+            <a:ext cx="420624" cy="420624"/>
           </a:xfrm>
           <a:prstGeom prst="rect">
             <a:avLst/>
@@ -12314,34 +11935,73 @@
           <a:bodyPr wrap="square" lIns="0" tIns="0" rIns="0" bIns="0" rtlCol="0" anchor="ctr"/>
           <a:lstStyle/>
           <a:p>
+            <a:pPr algn="ctr" indent="0" marL="0">
+              <a:buNone/>
+            </a:pPr>
+            <a:r>
+              <a:rPr lang="en-US" sz="1656" b="1" dirty="0">
+                <a:solidFill>
+                  <a:srgbClr val="FFFFFF"/>
+                </a:solidFill>
+                <a:latin typeface="Consolas" pitchFamily="34" charset="0"/>
+                <a:ea typeface="Consolas" pitchFamily="34" charset="-122"/>
+                <a:cs typeface="Consolas" pitchFamily="34" charset="-120"/>
+              </a:rPr>
+              <a:t>1</a:t>
+            </a:r>
+            <a:endParaRPr lang="en-US" sz="1656" dirty="0"/>
+          </a:p>
+        </p:txBody>
+      </p:sp>
+      <p:sp>
+        <p:nvSpPr>
+          <p:cNvPr id="38" name="Text 36"/>
+          <p:cNvSpPr/>
+          <p:nvPr/>
+        </p:nvSpPr>
+        <p:spPr>
+          <a:xfrm>
+            <a:off x="8522208" y="1856232"/>
+            <a:ext cx="3017520" cy="320040"/>
+          </a:xfrm>
+          <a:prstGeom prst="rect">
+            <a:avLst/>
+          </a:prstGeom>
+          <a:noFill/>
+          <a:ln/>
+        </p:spPr>
+        <p:txBody>
+          <a:bodyPr wrap="square" lIns="0" tIns="0" rIns="0" bIns="0" rtlCol="0" anchor="ctr"/>
+          <a:lstStyle/>
+          <a:p>
             <a:pPr indent="0" marL="0">
               <a:buNone/>
             </a:pPr>
             <a:r>
-              <a:rPr lang="en-US" sz="1200" b="1" dirty="0">
-                <a:solidFill>
-                  <a:srgbClr val="DC2626"/>
+              <a:rPr lang="en-US" sz="1300" b="1" dirty="0">
+                <a:solidFill>
+                  <a:srgbClr val="EA580C"/>
                 </a:solidFill>
                 <a:latin typeface="Malgun Gothic" pitchFamily="34" charset="0"/>
                 <a:ea typeface="Malgun Gothic" pitchFamily="34" charset="-122"/>
                 <a:cs typeface="Malgun Gothic" pitchFamily="34" charset="-120"/>
               </a:rPr>
-              <a:t>상위 2개 구</a:t>
-            </a:r>
-            <a:endParaRPr lang="en-US" sz="1200" dirty="0"/>
-          </a:p>
-        </p:txBody>
-      </p:sp>
-      <p:sp>
-        <p:nvSpPr>
-          <p:cNvPr id="16" name="Text 13"/>
-          <p:cNvSpPr/>
-          <p:nvPr/>
-        </p:nvSpPr>
-        <p:spPr>
-          <a:xfrm>
-            <a:off x="8321040" y="4800600"/>
-            <a:ext cx="2926080" cy="640080"/>
+              <a:t>화재지점 표시</a:t>
+            </a:r>
+            <a:endParaRPr lang="en-US" sz="1300" dirty="0"/>
+          </a:p>
+        </p:txBody>
+      </p:sp>
+      <p:sp>
+        <p:nvSpPr>
+          <p:cNvPr id="39" name="Text 37"/>
+          <p:cNvSpPr/>
+          <p:nvPr/>
+        </p:nvSpPr>
+        <p:spPr>
+          <a:xfrm>
+            <a:off x="8522208" y="2167128"/>
+            <a:ext cx="3017520" cy="457200"/>
           </a:xfrm>
           <a:prstGeom prst="rect">
             <a:avLst/>
@@ -12355,22 +12015,523 @@
           <a:p>
             <a:pPr indent="0" marL="0">
               <a:lnSpc>
-                <a:spcPct val="110000"/>
+                <a:spcPct val="105000"/>
               </a:lnSpc>
               <a:buNone/>
             </a:pPr>
             <a:r>
-              <a:rPr lang="en-US" sz="1250" dirty="0">
-                <a:solidFill>
-                  <a:srgbClr val="0F172A"/>
+              <a:rPr lang="en-US" sz="1050" dirty="0">
+                <a:solidFill>
+                  <a:srgbClr val="334155"/>
                 </a:solidFill>
                 <a:latin typeface="Malgun Gothic" pitchFamily="34" charset="0"/>
                 <a:ea typeface="Malgun Gothic" pitchFamily="34" charset="-122"/>
                 <a:cs typeface="Malgun Gothic" pitchFamily="34" charset="-120"/>
               </a:rPr>
-              <a:t>전체 화재의 절반 이상 집중</a:t>
-            </a:r>
-            <a:endParaRPr lang="en-US" sz="1250" dirty="0"/>
+              <a:t>최근 1년 창원 화재 발생지점을 지도에 올린다</a:t>
+            </a:r>
+            <a:endParaRPr lang="en-US" sz="1050" dirty="0"/>
+          </a:p>
+        </p:txBody>
+      </p:sp>
+      <p:sp>
+        <p:nvSpPr>
+          <p:cNvPr id="40" name="Shape 38"/>
+          <p:cNvSpPr/>
+          <p:nvPr/>
+        </p:nvSpPr>
+        <p:spPr>
+          <a:xfrm>
+            <a:off x="7772400" y="2761488"/>
+            <a:ext cx="3840480" cy="932688"/>
+          </a:xfrm>
+          <a:prstGeom prst="roundRect">
+            <a:avLst>
+              <a:gd name="adj" fmla="val 7843"/>
+            </a:avLst>
+          </a:prstGeom>
+          <a:solidFill>
+            <a:srgbClr val="F8FAFC"/>
+          </a:solidFill>
+          <a:ln w="12700">
+            <a:solidFill>
+              <a:srgbClr val="E2E8F0"/>
+            </a:solidFill>
+            <a:prstDash val="solid"/>
+          </a:ln>
+        </p:spPr>
+      </p:sp>
+      <p:sp>
+        <p:nvSpPr>
+          <p:cNvPr id="41" name="Shape 39"/>
+          <p:cNvSpPr/>
+          <p:nvPr/>
+        </p:nvSpPr>
+        <p:spPr>
+          <a:xfrm>
+            <a:off x="7973568" y="3017520"/>
+            <a:ext cx="420624" cy="420624"/>
+          </a:xfrm>
+          <a:prstGeom prst="ellipse">
+            <a:avLst/>
+          </a:prstGeom>
+          <a:solidFill>
+            <a:srgbClr val="2563EB"/>
+          </a:solidFill>
+          <a:ln/>
+        </p:spPr>
+      </p:sp>
+      <p:sp>
+        <p:nvSpPr>
+          <p:cNvPr id="42" name="Text 40"/>
+          <p:cNvSpPr/>
+          <p:nvPr/>
+        </p:nvSpPr>
+        <p:spPr>
+          <a:xfrm>
+            <a:off x="7973568" y="3017520"/>
+            <a:ext cx="420624" cy="420624"/>
+          </a:xfrm>
+          <a:prstGeom prst="rect">
+            <a:avLst/>
+          </a:prstGeom>
+          <a:noFill/>
+          <a:ln/>
+        </p:spPr>
+        <p:txBody>
+          <a:bodyPr wrap="square" lIns="0" tIns="0" rIns="0" bIns="0" rtlCol="0" anchor="ctr"/>
+          <a:lstStyle/>
+          <a:p>
+            <a:pPr algn="ctr" indent="0" marL="0">
+              <a:buNone/>
+            </a:pPr>
+            <a:r>
+              <a:rPr lang="en-US" sz="1656" b="1" dirty="0">
+                <a:solidFill>
+                  <a:srgbClr val="FFFFFF"/>
+                </a:solidFill>
+                <a:latin typeface="Consolas" pitchFamily="34" charset="0"/>
+                <a:ea typeface="Consolas" pitchFamily="34" charset="-122"/>
+                <a:cs typeface="Consolas" pitchFamily="34" charset="-120"/>
+              </a:rPr>
+              <a:t>2</a:t>
+            </a:r>
+            <a:endParaRPr lang="en-US" sz="1656" dirty="0"/>
+          </a:p>
+        </p:txBody>
+      </p:sp>
+      <p:sp>
+        <p:nvSpPr>
+          <p:cNvPr id="43" name="Text 41"/>
+          <p:cNvSpPr/>
+          <p:nvPr/>
+        </p:nvSpPr>
+        <p:spPr>
+          <a:xfrm>
+            <a:off x="8522208" y="2880360"/>
+            <a:ext cx="3017520" cy="320040"/>
+          </a:xfrm>
+          <a:prstGeom prst="rect">
+            <a:avLst/>
+          </a:prstGeom>
+          <a:noFill/>
+          <a:ln/>
+        </p:spPr>
+        <p:txBody>
+          <a:bodyPr wrap="square" lIns="0" tIns="0" rIns="0" bIns="0" rtlCol="0" anchor="ctr"/>
+          <a:lstStyle/>
+          <a:p>
+            <a:pPr indent="0" marL="0">
+              <a:buNone/>
+            </a:pPr>
+            <a:r>
+              <a:rPr lang="en-US" sz="1300" b="1" dirty="0">
+                <a:solidFill>
+                  <a:srgbClr val="2563EB"/>
+                </a:solidFill>
+                <a:latin typeface="Malgun Gothic" pitchFamily="34" charset="0"/>
+                <a:ea typeface="Malgun Gothic" pitchFamily="34" charset="-122"/>
+                <a:cs typeface="Malgun Gothic" pitchFamily="34" charset="-120"/>
+              </a:rPr>
+              <a:t>경로 탐색</a:t>
+            </a:r>
+            <a:endParaRPr lang="en-US" sz="1300" dirty="0"/>
+          </a:p>
+        </p:txBody>
+      </p:sp>
+      <p:sp>
+        <p:nvSpPr>
+          <p:cNvPr id="44" name="Text 42"/>
+          <p:cNvSpPr/>
+          <p:nvPr/>
+        </p:nvSpPr>
+        <p:spPr>
+          <a:xfrm>
+            <a:off x="8522208" y="3191256"/>
+            <a:ext cx="3017520" cy="457200"/>
+          </a:xfrm>
+          <a:prstGeom prst="rect">
+            <a:avLst/>
+          </a:prstGeom>
+          <a:noFill/>
+          <a:ln/>
+        </p:spPr>
+        <p:txBody>
+          <a:bodyPr wrap="square" lIns="0" tIns="0" rIns="0" bIns="0" rtlCol="0" anchor="t"/>
+          <a:lstStyle/>
+          <a:p>
+            <a:pPr indent="0" marL="0">
+              <a:lnSpc>
+                <a:spcPct val="105000"/>
+              </a:lnSpc>
+              <a:buNone/>
+            </a:pPr>
+            <a:r>
+              <a:rPr lang="en-US" sz="1050" dirty="0">
+                <a:solidFill>
+                  <a:srgbClr val="334155"/>
+                </a:solidFill>
+                <a:latin typeface="Malgun Gothic" pitchFamily="34" charset="0"/>
+                <a:ea typeface="Malgun Gothic" pitchFamily="34" charset="-122"/>
+                <a:cs typeface="Malgun Gothic" pitchFamily="34" charset="-120"/>
+              </a:rPr>
+              <a:t>각 지점까지 소방서에서 실측 도로망으로 경로를 찾는다</a:t>
+            </a:r>
+            <a:endParaRPr lang="en-US" sz="1050" dirty="0"/>
+          </a:p>
+        </p:txBody>
+      </p:sp>
+      <p:sp>
+        <p:nvSpPr>
+          <p:cNvPr id="45" name="Shape 43"/>
+          <p:cNvSpPr/>
+          <p:nvPr/>
+        </p:nvSpPr>
+        <p:spPr>
+          <a:xfrm>
+            <a:off x="7772400" y="3785616"/>
+            <a:ext cx="3840480" cy="932688"/>
+          </a:xfrm>
+          <a:prstGeom prst="roundRect">
+            <a:avLst>
+              <a:gd name="adj" fmla="val 7843"/>
+            </a:avLst>
+          </a:prstGeom>
+          <a:solidFill>
+            <a:srgbClr val="F8FAFC"/>
+          </a:solidFill>
+          <a:ln w="12700">
+            <a:solidFill>
+              <a:srgbClr val="E2E8F0"/>
+            </a:solidFill>
+            <a:prstDash val="solid"/>
+          </a:ln>
+        </p:spPr>
+      </p:sp>
+      <p:sp>
+        <p:nvSpPr>
+          <p:cNvPr id="46" name="Shape 44"/>
+          <p:cNvSpPr/>
+          <p:nvPr/>
+        </p:nvSpPr>
+        <p:spPr>
+          <a:xfrm>
+            <a:off x="7973568" y="4041648"/>
+            <a:ext cx="420624" cy="420624"/>
+          </a:xfrm>
+          <a:prstGeom prst="ellipse">
+            <a:avLst/>
+          </a:prstGeom>
+          <a:solidFill>
+            <a:srgbClr val="DC2626"/>
+          </a:solidFill>
+          <a:ln/>
+        </p:spPr>
+      </p:sp>
+      <p:sp>
+        <p:nvSpPr>
+          <p:cNvPr id="47" name="Text 45"/>
+          <p:cNvSpPr/>
+          <p:nvPr/>
+        </p:nvSpPr>
+        <p:spPr>
+          <a:xfrm>
+            <a:off x="7973568" y="4041648"/>
+            <a:ext cx="420624" cy="420624"/>
+          </a:xfrm>
+          <a:prstGeom prst="rect">
+            <a:avLst/>
+          </a:prstGeom>
+          <a:noFill/>
+          <a:ln/>
+        </p:spPr>
+        <p:txBody>
+          <a:bodyPr wrap="square" lIns="0" tIns="0" rIns="0" bIns="0" rtlCol="0" anchor="ctr"/>
+          <a:lstStyle/>
+          <a:p>
+            <a:pPr algn="ctr" indent="0" marL="0">
+              <a:buNone/>
+            </a:pPr>
+            <a:r>
+              <a:rPr lang="en-US" sz="1656" b="1" dirty="0">
+                <a:solidFill>
+                  <a:srgbClr val="FFFFFF"/>
+                </a:solidFill>
+                <a:latin typeface="Consolas" pitchFamily="34" charset="0"/>
+                <a:ea typeface="Consolas" pitchFamily="34" charset="-122"/>
+                <a:cs typeface="Consolas" pitchFamily="34" charset="-120"/>
+              </a:rPr>
+              <a:t>3</a:t>
+            </a:r>
+            <a:endParaRPr lang="en-US" sz="1656" dirty="0"/>
+          </a:p>
+        </p:txBody>
+      </p:sp>
+      <p:sp>
+        <p:nvSpPr>
+          <p:cNvPr id="48" name="Text 46"/>
+          <p:cNvSpPr/>
+          <p:nvPr/>
+        </p:nvSpPr>
+        <p:spPr>
+          <a:xfrm>
+            <a:off x="8522208" y="3904488"/>
+            <a:ext cx="3017520" cy="320040"/>
+          </a:xfrm>
+          <a:prstGeom prst="rect">
+            <a:avLst/>
+          </a:prstGeom>
+          <a:noFill/>
+          <a:ln/>
+        </p:spPr>
+        <p:txBody>
+          <a:bodyPr wrap="square" lIns="0" tIns="0" rIns="0" bIns="0" rtlCol="0" anchor="ctr"/>
+          <a:lstStyle/>
+          <a:p>
+            <a:pPr indent="0" marL="0">
+              <a:buNone/>
+            </a:pPr>
+            <a:r>
+              <a:rPr lang="en-US" sz="1300" b="1" dirty="0">
+                <a:solidFill>
+                  <a:srgbClr val="DC2626"/>
+                </a:solidFill>
+                <a:latin typeface="Malgun Gothic" pitchFamily="34" charset="0"/>
+                <a:ea typeface="Malgun Gothic" pitchFamily="34" charset="-122"/>
+                <a:cs typeface="Malgun Gothic" pitchFamily="34" charset="-120"/>
+              </a:rPr>
+              <a:t>빨간선 = 진입불가</a:t>
+            </a:r>
+            <a:endParaRPr lang="en-US" sz="1300" dirty="0"/>
+          </a:p>
+        </p:txBody>
+      </p:sp>
+      <p:sp>
+        <p:nvSpPr>
+          <p:cNvPr id="49" name="Text 47"/>
+          <p:cNvSpPr/>
+          <p:nvPr/>
+        </p:nvSpPr>
+        <p:spPr>
+          <a:xfrm>
+            <a:off x="8522208" y="4215384"/>
+            <a:ext cx="3017520" cy="457200"/>
+          </a:xfrm>
+          <a:prstGeom prst="rect">
+            <a:avLst/>
+          </a:prstGeom>
+          <a:noFill/>
+          <a:ln/>
+        </p:spPr>
+        <p:txBody>
+          <a:bodyPr wrap="square" lIns="0" tIns="0" rIns="0" bIns="0" rtlCol="0" anchor="t"/>
+          <a:lstStyle/>
+          <a:p>
+            <a:pPr indent="0" marL="0">
+              <a:lnSpc>
+                <a:spcPct val="105000"/>
+              </a:lnSpc>
+              <a:buNone/>
+            </a:pPr>
+            <a:r>
+              <a:rPr lang="en-US" sz="1050" dirty="0">
+                <a:solidFill>
+                  <a:srgbClr val="334155"/>
+                </a:solidFill>
+                <a:latin typeface="Malgun Gothic" pitchFamily="34" charset="0"/>
+                <a:ea typeface="Malgun Gothic" pitchFamily="34" charset="-122"/>
+                <a:cs typeface="Malgun Gothic" pitchFamily="34" charset="-120"/>
+              </a:rPr>
+              <a:t>경로 중 폭 4m 미만 구간을 빨간선으로 표시한다</a:t>
+            </a:r>
+            <a:endParaRPr lang="en-US" sz="1050" dirty="0"/>
+          </a:p>
+        </p:txBody>
+      </p:sp>
+      <p:sp>
+        <p:nvSpPr>
+          <p:cNvPr id="50" name="Shape 48"/>
+          <p:cNvSpPr/>
+          <p:nvPr/>
+        </p:nvSpPr>
+        <p:spPr>
+          <a:xfrm>
+            <a:off x="7772400" y="4809744"/>
+            <a:ext cx="3840480" cy="932688"/>
+          </a:xfrm>
+          <a:prstGeom prst="roundRect">
+            <a:avLst>
+              <a:gd name="adj" fmla="val 7843"/>
+            </a:avLst>
+          </a:prstGeom>
+          <a:solidFill>
+            <a:srgbClr val="F8FAFC"/>
+          </a:solidFill>
+          <a:ln w="12700">
+            <a:solidFill>
+              <a:srgbClr val="E2E8F0"/>
+            </a:solidFill>
+            <a:prstDash val="solid"/>
+          </a:ln>
+        </p:spPr>
+      </p:sp>
+      <p:sp>
+        <p:nvSpPr>
+          <p:cNvPr id="51" name="Shape 49"/>
+          <p:cNvSpPr/>
+          <p:nvPr/>
+        </p:nvSpPr>
+        <p:spPr>
+          <a:xfrm>
+            <a:off x="7973568" y="5065776"/>
+            <a:ext cx="420624" cy="420624"/>
+          </a:xfrm>
+          <a:prstGeom prst="ellipse">
+            <a:avLst/>
+          </a:prstGeom>
+          <a:solidFill>
+            <a:srgbClr val="7C3AED"/>
+          </a:solidFill>
+          <a:ln/>
+        </p:spPr>
+      </p:sp>
+      <p:sp>
+        <p:nvSpPr>
+          <p:cNvPr id="52" name="Text 50"/>
+          <p:cNvSpPr/>
+          <p:nvPr/>
+        </p:nvSpPr>
+        <p:spPr>
+          <a:xfrm>
+            <a:off x="7973568" y="5065776"/>
+            <a:ext cx="420624" cy="420624"/>
+          </a:xfrm>
+          <a:prstGeom prst="rect">
+            <a:avLst/>
+          </a:prstGeom>
+          <a:noFill/>
+          <a:ln/>
+        </p:spPr>
+        <p:txBody>
+          <a:bodyPr wrap="square" lIns="0" tIns="0" rIns="0" bIns="0" rtlCol="0" anchor="ctr"/>
+          <a:lstStyle/>
+          <a:p>
+            <a:pPr algn="ctr" indent="0" marL="0">
+              <a:buNone/>
+            </a:pPr>
+            <a:r>
+              <a:rPr lang="en-US" sz="1656" b="1" dirty="0">
+                <a:solidFill>
+                  <a:srgbClr val="FFFFFF"/>
+                </a:solidFill>
+                <a:latin typeface="Consolas" pitchFamily="34" charset="0"/>
+                <a:ea typeface="Consolas" pitchFamily="34" charset="-122"/>
+                <a:cs typeface="Consolas" pitchFamily="34" charset="-120"/>
+              </a:rPr>
+              <a:t>4</a:t>
+            </a:r>
+            <a:endParaRPr lang="en-US" sz="1656" dirty="0"/>
+          </a:p>
+        </p:txBody>
+      </p:sp>
+      <p:sp>
+        <p:nvSpPr>
+          <p:cNvPr id="53" name="Text 51"/>
+          <p:cNvSpPr/>
+          <p:nvPr/>
+        </p:nvSpPr>
+        <p:spPr>
+          <a:xfrm>
+            <a:off x="8522208" y="4928616"/>
+            <a:ext cx="3017520" cy="320040"/>
+          </a:xfrm>
+          <a:prstGeom prst="rect">
+            <a:avLst/>
+          </a:prstGeom>
+          <a:noFill/>
+          <a:ln/>
+        </p:spPr>
+        <p:txBody>
+          <a:bodyPr wrap="square" lIns="0" tIns="0" rIns="0" bIns="0" rtlCol="0" anchor="ctr"/>
+          <a:lstStyle/>
+          <a:p>
+            <a:pPr indent="0" marL="0">
+              <a:buNone/>
+            </a:pPr>
+            <a:r>
+              <a:rPr lang="en-US" sz="1300" b="1" dirty="0">
+                <a:solidFill>
+                  <a:srgbClr val="7C3AED"/>
+                </a:solidFill>
+                <a:latin typeface="Malgun Gothic" pitchFamily="34" charset="0"/>
+                <a:ea typeface="Malgun Gothic" pitchFamily="34" charset="-122"/>
+                <a:cs typeface="Malgun Gothic" pitchFamily="34" charset="-120"/>
+              </a:rPr>
+              <a:t>드론 필요 지점</a:t>
+            </a:r>
+            <a:endParaRPr lang="en-US" sz="1300" dirty="0"/>
+          </a:p>
+        </p:txBody>
+      </p:sp>
+      <p:sp>
+        <p:nvSpPr>
+          <p:cNvPr id="54" name="Text 52"/>
+          <p:cNvSpPr/>
+          <p:nvPr/>
+        </p:nvSpPr>
+        <p:spPr>
+          <a:xfrm>
+            <a:off x="8522208" y="5239512"/>
+            <a:ext cx="3017520" cy="457200"/>
+          </a:xfrm>
+          <a:prstGeom prst="rect">
+            <a:avLst/>
+          </a:prstGeom>
+          <a:noFill/>
+          <a:ln/>
+        </p:spPr>
+        <p:txBody>
+          <a:bodyPr wrap="square" lIns="0" tIns="0" rIns="0" bIns="0" rtlCol="0" anchor="t"/>
+          <a:lstStyle/>
+          <a:p>
+            <a:pPr indent="0" marL="0">
+              <a:lnSpc>
+                <a:spcPct val="105000"/>
+              </a:lnSpc>
+              <a:buNone/>
+            </a:pPr>
+            <a:r>
+              <a:rPr lang="en-US" sz="1050" dirty="0">
+                <a:solidFill>
+                  <a:srgbClr val="334155"/>
+                </a:solidFill>
+                <a:latin typeface="Malgun Gothic" pitchFamily="34" charset="0"/>
+                <a:ea typeface="Malgun Gothic" pitchFamily="34" charset="-122"/>
+                <a:cs typeface="Malgun Gothic" pitchFamily="34" charset="-120"/>
+              </a:rPr>
+              <a:t>빨간선이 걸린 화재지점 = 드론이 가장 필요한 곳</a:t>
+            </a:r>
+            <a:endParaRPr lang="en-US" sz="1050" dirty="0"/>
           </a:p>
         </p:txBody>
       </p:sp>
@@ -12439,7 +12600,7 @@
                 <a:ea typeface="Malgun Gothic" pitchFamily="34" charset="-122"/>
                 <a:cs typeface="Malgun Gothic" pitchFamily="34" charset="-120"/>
               </a:rPr>
-              <a:t>PART 1 · STEP 03</a:t>
+              <a:t>PART 1 · STEP 04</a:t>
             </a:r>
             <a:endParaRPr lang="en-US" sz="1250" dirty="0"/>
           </a:p>
@@ -12478,7 +12639,7 @@
                 <a:ea typeface="Malgun Gothic" pitchFamily="34" charset="-122"/>
                 <a:cs typeface="Malgun Gothic" pitchFamily="34" charset="-120"/>
               </a:rPr>
-              <a:t>분석 ② — 소방차가 못 가는 좁은 골목</a:t>
+              <a:t>분석 ① — 창원 구별 화재와 피해</a:t>
             </a:r>
             <a:endParaRPr lang="en-US" sz="2800" dirty="0"/>
           </a:p>
@@ -12493,7 +12654,7 @@
         <p:spPr>
           <a:xfrm>
             <a:off x="548640" y="1371600"/>
-            <a:ext cx="8229600" cy="320040"/>
+            <a:ext cx="10058400" cy="320040"/>
           </a:xfrm>
           <a:prstGeom prst="rect">
             <a:avLst/>
@@ -12509,7 +12670,7 @@
               <a:buNone/>
             </a:pPr>
             <a:r>
-              <a:rPr lang="en-US" sz="1300" dirty="0">
+              <a:rPr lang="en-US" sz="1250" dirty="0">
                 <a:solidFill>
                   <a:srgbClr val="64748B"/>
                 </a:solidFill>
@@ -12517,9 +12678,9 @@
                 <a:ea typeface="Malgun Gothic" pitchFamily="34" charset="-122"/>
                 <a:cs typeface="Malgun Gothic" pitchFamily="34" charset="-120"/>
               </a:rPr>
-              <a:t>지역별 폭 4m 미만(소방차 진입불가) 도로 비율 (예시, %)</a:t>
-            </a:r>
-            <a:endParaRPr lang="en-US" sz="1300" dirty="0"/>
+              <a:t>소방안전 빅데이터 플랫폼 · 최근 1년 · 창원시 구별 화재 발생 건수</a:t>
+            </a:r>
+            <a:endParaRPr lang="en-US" sz="1250" dirty="0"/>
           </a:p>
         </p:txBody>
       </p:sp>
@@ -12668,7 +12829,7 @@
                 <a:ea typeface="Malgun Gothic" pitchFamily="34" charset="-122"/>
                 <a:cs typeface="Malgun Gothic" pitchFamily="34" charset="-120"/>
               </a:rPr>
-              <a:t>구도심일수록 진입불가 골목이 많다</a:t>
+              <a:t>구별 화재건수는 88~126건으로 비슷</a:t>
             </a:r>
             <a:endParaRPr lang="en-US" sz="1200" dirty="0"/>
           </a:p>
@@ -12730,7 +12891,7 @@
                 <a:ea typeface="Malgun Gothic" pitchFamily="34" charset="-122"/>
                 <a:cs typeface="Malgun Gothic" pitchFamily="34" charset="-120"/>
               </a:rPr>
-              <a:t>불은 좁은 골목을 복사열로 건너뜀</a:t>
+              <a:t>차이는 도로·노후·인명피해에서 갈린다</a:t>
             </a:r>
             <a:endParaRPr lang="en-US" sz="1200" dirty="0"/>
           </a:p>
@@ -12792,7 +12953,7 @@
                 <a:ea typeface="Malgun Gothic" pitchFamily="34" charset="-122"/>
                 <a:cs typeface="Malgun Gothic" pitchFamily="34" charset="-120"/>
               </a:rPr>
-              <a:t>진입불가 구간 = 드론이 가장 필요한 곳</a:t>
+              <a:t>마산합포구는 인명피해가 창원 최다</a:t>
             </a:r>
             <a:endParaRPr lang="en-US" sz="1200" dirty="0"/>
           </a:p>
@@ -12815,11 +12976,11 @@
             </a:avLst>
           </a:prstGeom>
           <a:solidFill>
-            <a:srgbClr val="FFEDD5"/>
+            <a:srgbClr val="FEE2E2"/>
           </a:solidFill>
           <a:ln w="12700">
             <a:solidFill>
-              <a:srgbClr val="FDBA74"/>
+              <a:srgbClr val="FCA5A5"/>
             </a:solidFill>
             <a:prstDash val="solid"/>
           </a:ln>
@@ -12852,13 +13013,13 @@
             <a:r>
               <a:rPr lang="en-US" sz="1200" b="1" dirty="0">
                 <a:solidFill>
-                  <a:srgbClr val="EA580C"/>
+                  <a:srgbClr val="DC2626"/>
                 </a:solidFill>
                 <a:latin typeface="Malgun Gothic" pitchFamily="34" charset="0"/>
                 <a:ea typeface="Malgun Gothic" pitchFamily="34" charset="-122"/>
                 <a:cs typeface="Malgun Gothic" pitchFamily="34" charset="-120"/>
               </a:rPr>
-              <a:t>마산합포구 38%</a:t>
+              <a:t>마산합포구</a:t>
             </a:r>
             <a:endParaRPr lang="en-US" sz="1200" dirty="0"/>
           </a:p>
@@ -12873,7 +13034,7 @@
         <p:spPr>
           <a:xfrm>
             <a:off x="8321040" y="4800600"/>
-            <a:ext cx="2926080" cy="640080"/>
+            <a:ext cx="2926080" cy="731520"/>
           </a:xfrm>
           <a:prstGeom prst="rect">
             <a:avLst/>
@@ -12887,12 +13048,12 @@
           <a:p>
             <a:pPr indent="0" marL="0">
               <a:lnSpc>
-                <a:spcPct val="110000"/>
+                <a:spcPct val="115000"/>
               </a:lnSpc>
               <a:buNone/>
             </a:pPr>
             <a:r>
-              <a:rPr lang="en-US" sz="1250" dirty="0">
+              <a:rPr lang="en-US" sz="1200" dirty="0">
                 <a:solidFill>
                   <a:srgbClr val="0F172A"/>
                 </a:solidFill>
@@ -12900,9 +13061,9 @@
                 <a:ea typeface="Malgun Gothic" pitchFamily="34" charset="-122"/>
                 <a:cs typeface="Malgun Gothic" pitchFamily="34" charset="-120"/>
               </a:rPr>
-              <a:t>도로 3곳 중 1곳 이상 진입 불가</a:t>
-            </a:r>
-            <a:endParaRPr lang="en-US" sz="1250" dirty="0"/>
+              <a:t>인명피해 22명(사망 5) — 원도심 위험 집중</a:t>
+            </a:r>
+            <a:endParaRPr lang="en-US" sz="1200" dirty="0"/>
           </a:p>
         </p:txBody>
       </p:sp>
@@ -12971,7 +13132,7 @@
                 <a:ea typeface="Malgun Gothic" pitchFamily="34" charset="-122"/>
                 <a:cs typeface="Malgun Gothic" pitchFamily="34" charset="-120"/>
               </a:rPr>
-              <a:t>PART 1 · STEP 03</a:t>
+              <a:t>PART 1 · STEP 04</a:t>
             </a:r>
             <a:endParaRPr lang="en-US" sz="1250" dirty="0"/>
           </a:p>
@@ -13010,7 +13171,7 @@
                 <a:ea typeface="Malgun Gothic" pitchFamily="34" charset="-122"/>
                 <a:cs typeface="Malgun Gothic" pitchFamily="34" charset="-120"/>
               </a:rPr>
-              <a:t>분석 ③ — 종합 위험 지수로 합친다</a:t>
+              <a:t>분석 ② — 종합 위험 지수로 합친다</a:t>
             </a:r>
             <a:endParaRPr lang="en-US" sz="2800" dirty="0"/>
           </a:p>
@@ -13025,7 +13186,7 @@
         <p:spPr>
           <a:xfrm>
             <a:off x="548640" y="1371600"/>
-            <a:ext cx="9144000" cy="320040"/>
+            <a:ext cx="10515600" cy="320040"/>
           </a:xfrm>
           <a:prstGeom prst="rect">
             <a:avLst/>
@@ -13041,7 +13202,7 @@
               <a:buNone/>
             </a:pPr>
             <a:r>
-              <a:rPr lang="en-US" sz="1300" dirty="0">
+              <a:rPr lang="en-US" sz="1250" dirty="0">
                 <a:solidFill>
                   <a:srgbClr val="64748B"/>
                 </a:solidFill>
@@ -13049,9 +13210,9 @@
                 <a:ea typeface="Malgun Gothic" pitchFamily="34" charset="-122"/>
                 <a:cs typeface="Malgun Gothic" pitchFamily="34" charset="-120"/>
               </a:rPr>
-              <a:t>화재빈도 · 도로협소 · 노후건물 · 고령인구를 가중 합산 (예시 점수)</a:t>
-            </a:r>
-            <a:endParaRPr lang="en-US" sz="1300" dirty="0"/>
+              <a:t>화재빈도(실측 반영) · 도로협소 · 노후건물 · 고령인구 가중 합산 (도로·노후·고령은 예시)</a:t>
+            </a:r>
+            <a:endParaRPr lang="en-US" sz="1250" dirty="0"/>
           </a:p>
         </p:txBody>
       </p:sp>
@@ -13293,7 +13454,7 @@
         <p:spPr>
           <a:xfrm>
             <a:off x="8595360" y="4114800"/>
-            <a:ext cx="2834640" cy="1280160"/>
+            <a:ext cx="2834640" cy="1371600"/>
           </a:xfrm>
           <a:prstGeom prst="rect">
             <a:avLst/>
@@ -13307,12 +13468,12 @@
           <a:p>
             <a:pPr indent="0" marL="0">
               <a:lnSpc>
-                <a:spcPct val="130000"/>
+                <a:spcPct val="125000"/>
               </a:lnSpc>
               <a:buNone/>
             </a:pPr>
             <a:r>
-              <a:rPr lang="en-US" sz="1250" dirty="0">
+              <a:rPr lang="en-US" sz="1200" dirty="0">
                 <a:solidFill>
                   <a:srgbClr val="334155"/>
                 </a:solidFill>
@@ -13320,9 +13481,9 @@
                 <a:ea typeface="Malgun Gothic" pitchFamily="34" charset="-122"/>
                 <a:cs typeface="Malgun Gothic" pitchFamily="34" charset="-120"/>
               </a:rPr>
-              <a:t>네 지표가 모두 상위 → 드론 우선 배치 대상 지역으로 도출</a:t>
-            </a:r>
-            <a:endParaRPr lang="en-US" sz="1250" dirty="0"/>
+              <a:t>의창구는 화재건수 최다지만 도로·노후가 낮아 종합은 하위 — 원도심(마산합포·진해)이 상위</a:t>
+            </a:r>
+            <a:endParaRPr lang="en-US" sz="1200" dirty="0"/>
           </a:p>
         </p:txBody>
       </p:sp>
@@ -13391,7 +13552,7 @@
                 <a:ea typeface="Malgun Gothic" pitchFamily="34" charset="-122"/>
                 <a:cs typeface="Malgun Gothic" pitchFamily="34" charset="-120"/>
               </a:rPr>
-              <a:t>PART 1 · STEP 04</a:t>
+              <a:t>PART 1 · STEP 05</a:t>
             </a:r>
             <a:endParaRPr lang="en-US" sz="1250" dirty="0"/>
           </a:p>
@@ -13430,7 +13591,7 @@
                 <a:ea typeface="Malgun Gothic" pitchFamily="34" charset="-122"/>
                 <a:cs typeface="Malgun Gothic" pitchFamily="34" charset="-120"/>
               </a:rPr>
-              <a:t>거점 소방서를 정한다</a:t>
+              <a:t>창원 안에서 거점 소방서를 정한다</a:t>
             </a:r>
             <a:endParaRPr lang="en-US" sz="2800" dirty="0"/>
           </a:p>
@@ -15750,7 +15911,7 @@
                 <a:ea typeface="Malgun Gothic" pitchFamily="34" charset="-122"/>
                 <a:cs typeface="Malgun Gothic" pitchFamily="34" charset="-120"/>
               </a:rPr>
-              <a:t>진입불가 구간 최다</a:t>
+              <a:t>진입불가 경로 최다</a:t>
             </a:r>
             <a:endParaRPr lang="en-US" sz="1300" dirty="0"/>
           </a:p>
@@ -15789,7 +15950,7 @@
                 <a:ea typeface="Malgun Gothic" pitchFamily="34" charset="-122"/>
                 <a:cs typeface="Malgun Gothic" pitchFamily="34" charset="-120"/>
               </a:rPr>
-              <a:t>좁은 골목 밀집 원도심을 상공에서 보완</a:t>
+              <a:t>빨간선 밀집 원도심 골목을 상공에서 보완</a:t>
             </a:r>
             <a:endParaRPr lang="en-US" sz="1050" dirty="0"/>
           </a:p>

</xml_diff>

<commit_message>
STEP04 map: match the HTML simulator style (beige, red-dashed, sky route, fire emoji)
Redraw the PART 1 STEP 04 inaccessible-area map to mirror the actual tool map:
- Kakao-style beige basemap with gray streets + a pale-yellow arterial (합포로)
- inaccessible alleys as RED DASHED lines (was solid)
- fire-truck route as a SKY-BLUE solid line (was generic blue road)
- fire points marked with a small 🔥 emoji + red pin; '🔥 마산어시장' label chip
- legend/steps reworded to match (빨간 점선=진입불가, 하늘색=주행경로, 🔥 화재지점)
- flip-aware line helper so diagonals don't render inverted

Co-Authored-By: Claude Opus 4.8 <noreply@anthropic.com>
Claude-Session: https://claude.ai/code/session_01TYua8MWbjkcnNvFDubmny6
</commit_message>
<xml_diff>
--- a/presentation/화재빅데이터_드론배치_분석리포트.pptx
+++ b/presentation/화재빅데이터_드론배치_분석리포트.pptx
@@ -13379,7 +13379,876 @@
             <a:avLst/>
           </a:prstGeom>
           <a:solidFill>
-            <a:srgbClr val="EEF2F6"/>
+            <a:srgbClr val="F3EFE6"/>
+          </a:solidFill>
+          <a:ln w="12700">
+            <a:solidFill>
+              <a:srgbClr val="CBD5E1"/>
+            </a:solidFill>
+            <a:prstDash val="solid"/>
+          </a:ln>
+        </p:spPr>
+      </p:sp>
+      <p:sp>
+        <p:nvSpPr>
+          <p:cNvPr id="6" name="Shape 4"/>
+          <p:cNvSpPr/>
+          <p:nvPr/>
+        </p:nvSpPr>
+        <p:spPr>
+          <a:xfrm>
+            <a:off x="960120" y="4160520"/>
+            <a:ext cx="1097280" cy="822960"/>
+          </a:xfrm>
+          <a:prstGeom prst="rect">
+            <a:avLst/>
+          </a:prstGeom>
+          <a:solidFill>
+            <a:srgbClr val="EAE4D8"/>
+          </a:solidFill>
+          <a:ln/>
+        </p:spPr>
+      </p:sp>
+      <p:sp>
+        <p:nvSpPr>
+          <p:cNvPr id="7" name="Shape 5"/>
+          <p:cNvSpPr/>
+          <p:nvPr/>
+        </p:nvSpPr>
+        <p:spPr>
+          <a:xfrm>
+            <a:off x="2331720" y="4251960"/>
+            <a:ext cx="1051560" cy="777240"/>
+          </a:xfrm>
+          <a:prstGeom prst="rect">
+            <a:avLst/>
+          </a:prstGeom>
+          <a:solidFill>
+            <a:srgbClr val="EAE4D8"/>
+          </a:solidFill>
+          <a:ln/>
+        </p:spPr>
+      </p:sp>
+      <p:sp>
+        <p:nvSpPr>
+          <p:cNvPr id="8" name="Shape 6"/>
+          <p:cNvSpPr/>
+          <p:nvPr/>
+        </p:nvSpPr>
+        <p:spPr>
+          <a:xfrm>
+            <a:off x="6126480" y="2194560"/>
+            <a:ext cx="1005840" cy="685800"/>
+          </a:xfrm>
+          <a:prstGeom prst="rect">
+            <a:avLst/>
+          </a:prstGeom>
+          <a:solidFill>
+            <a:srgbClr val="EAE4D8"/>
+          </a:solidFill>
+          <a:ln/>
+        </p:spPr>
+      </p:sp>
+      <p:sp>
+        <p:nvSpPr>
+          <p:cNvPr id="9" name="Shape 7"/>
+          <p:cNvSpPr/>
+          <p:nvPr/>
+        </p:nvSpPr>
+        <p:spPr>
+          <a:xfrm flipV="1">
+            <a:off x="777240" y="3703320"/>
+            <a:ext cx="6583680" cy="274320"/>
+          </a:xfrm>
+          <a:prstGeom prst="line">
+            <a:avLst/>
+          </a:prstGeom>
+          <a:noFill/>
+          <a:ln w="25400">
+            <a:solidFill>
+              <a:srgbClr val="D3CCBD"/>
+            </a:solidFill>
+            <a:prstDash val="solid"/>
+          </a:ln>
+        </p:spPr>
+      </p:sp>
+      <p:sp>
+        <p:nvSpPr>
+          <p:cNvPr id="10" name="Shape 8"/>
+          <p:cNvSpPr/>
+          <p:nvPr/>
+        </p:nvSpPr>
+        <p:spPr>
+          <a:xfrm>
+            <a:off x="2148840" y="1965960"/>
+            <a:ext cx="365760" cy="3291840"/>
+          </a:xfrm>
+          <a:prstGeom prst="line">
+            <a:avLst/>
+          </a:prstGeom>
+          <a:noFill/>
+          <a:ln w="25400">
+            <a:solidFill>
+              <a:srgbClr val="D3CCBD"/>
+            </a:solidFill>
+            <a:prstDash val="solid"/>
+          </a:ln>
+        </p:spPr>
+      </p:sp>
+      <p:sp>
+        <p:nvSpPr>
+          <p:cNvPr id="11" name="Shape 9"/>
+          <p:cNvSpPr/>
+          <p:nvPr/>
+        </p:nvSpPr>
+        <p:spPr>
+          <a:xfrm>
+            <a:off x="3611880" y="2057400"/>
+            <a:ext cx="365760" cy="3200400"/>
+          </a:xfrm>
+          <a:prstGeom prst="line">
+            <a:avLst/>
+          </a:prstGeom>
+          <a:noFill/>
+          <a:ln w="25400">
+            <a:solidFill>
+              <a:srgbClr val="D3CCBD"/>
+            </a:solidFill>
+            <a:prstDash val="solid"/>
+          </a:ln>
+        </p:spPr>
+      </p:sp>
+      <p:sp>
+        <p:nvSpPr>
+          <p:cNvPr id="12" name="Shape 10"/>
+          <p:cNvSpPr/>
+          <p:nvPr/>
+        </p:nvSpPr>
+        <p:spPr>
+          <a:xfrm flipV="1">
+            <a:off x="914400" y="2459736"/>
+            <a:ext cx="6263640" cy="347472"/>
+          </a:xfrm>
+          <a:prstGeom prst="line">
+            <a:avLst/>
+          </a:prstGeom>
+          <a:noFill/>
+          <a:ln w="25400">
+            <a:solidFill>
+              <a:srgbClr val="D3CCBD"/>
+            </a:solidFill>
+            <a:prstDash val="solid"/>
+          </a:ln>
+        </p:spPr>
+      </p:sp>
+      <p:sp>
+        <p:nvSpPr>
+          <p:cNvPr id="13" name="Shape 11"/>
+          <p:cNvSpPr/>
+          <p:nvPr/>
+        </p:nvSpPr>
+        <p:spPr>
+          <a:xfrm>
+            <a:off x="4617720" y="3474720"/>
+            <a:ext cx="365760" cy="1783080"/>
+          </a:xfrm>
+          <a:prstGeom prst="line">
+            <a:avLst/>
+          </a:prstGeom>
+          <a:noFill/>
+          <a:ln w="25400">
+            <a:solidFill>
+              <a:srgbClr val="D3CCBD"/>
+            </a:solidFill>
+            <a:prstDash val="solid"/>
+          </a:ln>
+        </p:spPr>
+      </p:sp>
+      <p:sp>
+        <p:nvSpPr>
+          <p:cNvPr id="14" name="Shape 12"/>
+          <p:cNvSpPr/>
+          <p:nvPr/>
+        </p:nvSpPr>
+        <p:spPr>
+          <a:xfrm flipV="1">
+            <a:off x="2606040" y="4416552"/>
+            <a:ext cx="4480560" cy="109728"/>
+          </a:xfrm>
+          <a:prstGeom prst="line">
+            <a:avLst/>
+          </a:prstGeom>
+          <a:noFill/>
+          <a:ln w="25400">
+            <a:solidFill>
+              <a:srgbClr val="D3CCBD"/>
+            </a:solidFill>
+            <a:prstDash val="solid"/>
+          </a:ln>
+        </p:spPr>
+      </p:sp>
+      <p:sp>
+        <p:nvSpPr>
+          <p:cNvPr id="15" name="Shape 13"/>
+          <p:cNvSpPr/>
+          <p:nvPr/>
+        </p:nvSpPr>
+        <p:spPr>
+          <a:xfrm>
+            <a:off x="868680" y="2441448"/>
+            <a:ext cx="6400800" cy="713232"/>
+          </a:xfrm>
+          <a:prstGeom prst="line">
+            <a:avLst/>
+          </a:prstGeom>
+          <a:noFill/>
+          <a:ln w="114300">
+            <a:solidFill>
+              <a:srgbClr val="ECDC97"/>
+            </a:solidFill>
+            <a:prstDash val="solid"/>
+          </a:ln>
+        </p:spPr>
+      </p:sp>
+      <p:sp>
+        <p:nvSpPr>
+          <p:cNvPr id="16" name="Text 14"/>
+          <p:cNvSpPr/>
+          <p:nvPr/>
+        </p:nvSpPr>
+        <p:spPr>
+          <a:xfrm>
+            <a:off x="4937760" y="2478024"/>
+            <a:ext cx="1097280" cy="237744"/>
+          </a:xfrm>
+          <a:prstGeom prst="rect">
+            <a:avLst/>
+          </a:prstGeom>
+          <a:noFill/>
+          <a:ln/>
+        </p:spPr>
+        <p:txBody>
+          <a:bodyPr wrap="square" lIns="0" tIns="0" rIns="0" bIns="0" rtlCol="0" anchor="ctr"/>
+          <a:lstStyle/>
+          <a:p>
+            <a:pPr indent="0" marL="0">
+              <a:buNone/>
+            </a:pPr>
+            <a:r>
+              <a:rPr lang="en-US" sz="900" b="1" dirty="0">
+                <a:solidFill>
+                  <a:srgbClr val="A8925A"/>
+                </a:solidFill>
+                <a:latin typeface="Malgun Gothic" pitchFamily="34" charset="0"/>
+                <a:ea typeface="Malgun Gothic" pitchFamily="34" charset="-122"/>
+                <a:cs typeface="Malgun Gothic" pitchFamily="34" charset="-120"/>
+              </a:rPr>
+              <a:t>합포로</a:t>
+            </a:r>
+            <a:endParaRPr lang="en-US" sz="900" dirty="0"/>
+          </a:p>
+        </p:txBody>
+      </p:sp>
+      <p:sp>
+        <p:nvSpPr>
+          <p:cNvPr id="17" name="Shape 15"/>
+          <p:cNvSpPr/>
+          <p:nvPr/>
+        </p:nvSpPr>
+        <p:spPr>
+          <a:xfrm>
+            <a:off x="2926080" y="2743200"/>
+            <a:ext cx="0" cy="1033272"/>
+          </a:xfrm>
+          <a:prstGeom prst="line">
+            <a:avLst/>
+          </a:prstGeom>
+          <a:noFill/>
+          <a:ln w="57150">
+            <a:solidFill>
+              <a:srgbClr val="38BDF8"/>
+            </a:solidFill>
+            <a:prstDash val="solid"/>
+          </a:ln>
+        </p:spPr>
+      </p:sp>
+      <p:sp>
+        <p:nvSpPr>
+          <p:cNvPr id="18" name="Shape 16"/>
+          <p:cNvSpPr/>
+          <p:nvPr/>
+        </p:nvSpPr>
+        <p:spPr>
+          <a:xfrm>
+            <a:off x="2926080" y="3776472"/>
+            <a:ext cx="2148840" cy="109728"/>
+          </a:xfrm>
+          <a:prstGeom prst="line">
+            <a:avLst/>
+          </a:prstGeom>
+          <a:noFill/>
+          <a:ln w="57150">
+            <a:solidFill>
+              <a:srgbClr val="38BDF8"/>
+            </a:solidFill>
+            <a:prstDash val="solid"/>
+          </a:ln>
+        </p:spPr>
+      </p:sp>
+      <p:sp>
+        <p:nvSpPr>
+          <p:cNvPr id="19" name="Shape 17"/>
+          <p:cNvSpPr/>
+          <p:nvPr/>
+        </p:nvSpPr>
+        <p:spPr>
+          <a:xfrm>
+            <a:off x="5120640" y="3886200"/>
+            <a:ext cx="0" cy="1280160"/>
+          </a:xfrm>
+          <a:prstGeom prst="line">
+            <a:avLst/>
+          </a:prstGeom>
+          <a:noFill/>
+          <a:ln w="31750">
+            <a:solidFill>
+              <a:srgbClr val="DC2626"/>
+            </a:solidFill>
+            <a:prstDash val="dash"/>
+          </a:ln>
+        </p:spPr>
+      </p:sp>
+      <p:sp>
+        <p:nvSpPr>
+          <p:cNvPr id="20" name="Shape 18"/>
+          <p:cNvSpPr/>
+          <p:nvPr/>
+        </p:nvSpPr>
+        <p:spPr>
+          <a:xfrm flipV="1">
+            <a:off x="5120640" y="3474720"/>
+            <a:ext cx="1600200" cy="411480"/>
+          </a:xfrm>
+          <a:prstGeom prst="line">
+            <a:avLst/>
+          </a:prstGeom>
+          <a:noFill/>
+          <a:ln w="31750">
+            <a:solidFill>
+              <a:srgbClr val="DC2626"/>
+            </a:solidFill>
+            <a:prstDash val="dash"/>
+          </a:ln>
+        </p:spPr>
+      </p:sp>
+      <p:sp>
+        <p:nvSpPr>
+          <p:cNvPr id="21" name="Shape 19"/>
+          <p:cNvSpPr/>
+          <p:nvPr/>
+        </p:nvSpPr>
+        <p:spPr>
+          <a:xfrm>
+            <a:off x="5989320" y="4114800"/>
+            <a:ext cx="0" cy="1051560"/>
+          </a:xfrm>
+          <a:prstGeom prst="line">
+            <a:avLst/>
+          </a:prstGeom>
+          <a:noFill/>
+          <a:ln w="31750">
+            <a:solidFill>
+              <a:srgbClr val="DC2626"/>
+            </a:solidFill>
+            <a:prstDash val="dash"/>
+          </a:ln>
+        </p:spPr>
+      </p:sp>
+      <p:sp>
+        <p:nvSpPr>
+          <p:cNvPr id="22" name="Shape 20"/>
+          <p:cNvSpPr/>
+          <p:nvPr/>
+        </p:nvSpPr>
+        <p:spPr>
+          <a:xfrm>
+            <a:off x="4343400" y="4636008"/>
+            <a:ext cx="2377440" cy="54864"/>
+          </a:xfrm>
+          <a:prstGeom prst="line">
+            <a:avLst/>
+          </a:prstGeom>
+          <a:noFill/>
+          <a:ln w="31750">
+            <a:solidFill>
+              <a:srgbClr val="DC2626"/>
+            </a:solidFill>
+            <a:prstDash val="dash"/>
+          </a:ln>
+        </p:spPr>
+      </p:sp>
+      <p:sp>
+        <p:nvSpPr>
+          <p:cNvPr id="23" name="Shape 21"/>
+          <p:cNvSpPr/>
+          <p:nvPr/>
+        </p:nvSpPr>
+        <p:spPr>
+          <a:xfrm flipV="1">
+            <a:off x="3794760" y="3886200"/>
+            <a:ext cx="1325880" cy="320040"/>
+          </a:xfrm>
+          <a:prstGeom prst="line">
+            <a:avLst/>
+          </a:prstGeom>
+          <a:noFill/>
+          <a:ln w="31750">
+            <a:solidFill>
+              <a:srgbClr val="DC2626"/>
+            </a:solidFill>
+            <a:prstDash val="dash"/>
+          </a:ln>
+        </p:spPr>
+      </p:sp>
+      <p:sp>
+        <p:nvSpPr>
+          <p:cNvPr id="24" name="Shape 22"/>
+          <p:cNvSpPr/>
+          <p:nvPr/>
+        </p:nvSpPr>
+        <p:spPr>
+          <a:xfrm>
+            <a:off x="4544568" y="3447288"/>
+            <a:ext cx="1517904" cy="310896"/>
+          </a:xfrm>
+          <a:prstGeom prst="roundRect">
+            <a:avLst>
+              <a:gd name="adj" fmla="val 17647"/>
+            </a:avLst>
+          </a:prstGeom>
+          <a:solidFill>
+            <a:srgbClr val="FFFFFF"/>
+          </a:solidFill>
+          <a:ln w="12700">
+            <a:solidFill>
+              <a:srgbClr val="CBD5E1"/>
+            </a:solidFill>
+            <a:prstDash val="solid"/>
+          </a:ln>
+        </p:spPr>
+      </p:sp>
+      <p:sp>
+        <p:nvSpPr>
+          <p:cNvPr id="25" name="Text 23"/>
+          <p:cNvSpPr/>
+          <p:nvPr/>
+        </p:nvSpPr>
+        <p:spPr>
+          <a:xfrm>
+            <a:off x="4544568" y="3447288"/>
+            <a:ext cx="1517904" cy="310896"/>
+          </a:xfrm>
+          <a:prstGeom prst="rect">
+            <a:avLst/>
+          </a:prstGeom>
+          <a:noFill/>
+          <a:ln/>
+        </p:spPr>
+        <p:txBody>
+          <a:bodyPr wrap="square" lIns="0" tIns="0" rIns="0" bIns="0" rtlCol="0" anchor="ctr"/>
+          <a:lstStyle/>
+          <a:p>
+            <a:pPr algn="ctr" indent="0" marL="0">
+              <a:buNone/>
+            </a:pPr>
+            <a:r>
+              <a:rPr lang="en-US" sz="950" b="1" dirty="0">
+                <a:solidFill>
+                  <a:srgbClr val="0F172A"/>
+                </a:solidFill>
+                <a:latin typeface="Malgun Gothic" pitchFamily="34" charset="0"/>
+                <a:ea typeface="Malgun Gothic" pitchFamily="34" charset="-122"/>
+                <a:cs typeface="Malgun Gothic" pitchFamily="34" charset="-120"/>
+              </a:rPr>
+              <a:t>🔥 마산어시장</a:t>
+            </a:r>
+            <a:endParaRPr lang="en-US" sz="950" dirty="0"/>
+          </a:p>
+        </p:txBody>
+      </p:sp>
+      <p:sp>
+        <p:nvSpPr>
+          <p:cNvPr id="26" name="Shape 24"/>
+          <p:cNvSpPr/>
+          <p:nvPr/>
+        </p:nvSpPr>
+        <p:spPr>
+          <a:xfrm>
+            <a:off x="5212080" y="3831336"/>
+            <a:ext cx="182880" cy="182880"/>
+          </a:xfrm>
+          <a:prstGeom prst="ellipse">
+            <a:avLst/>
+          </a:prstGeom>
+          <a:solidFill>
+            <a:srgbClr val="DC2626"/>
+          </a:solidFill>
+          <a:ln w="19050">
+            <a:solidFill>
+              <a:srgbClr val="FFFFFF"/>
+            </a:solidFill>
+            <a:prstDash val="solid"/>
+          </a:ln>
+        </p:spPr>
+      </p:sp>
+      <p:sp>
+        <p:nvSpPr>
+          <p:cNvPr id="27" name="Shape 25"/>
+          <p:cNvSpPr/>
+          <p:nvPr/>
+        </p:nvSpPr>
+        <p:spPr>
+          <a:xfrm>
+            <a:off x="6446520" y="4507992"/>
+            <a:ext cx="182880" cy="182880"/>
+          </a:xfrm>
+          <a:prstGeom prst="ellipse">
+            <a:avLst/>
+          </a:prstGeom>
+          <a:solidFill>
+            <a:srgbClr val="DC2626"/>
+          </a:solidFill>
+          <a:ln w="19050">
+            <a:solidFill>
+              <a:srgbClr val="FFFFFF"/>
+            </a:solidFill>
+            <a:prstDash val="solid"/>
+          </a:ln>
+        </p:spPr>
+      </p:sp>
+      <p:sp>
+        <p:nvSpPr>
+          <p:cNvPr id="28" name="Text 26"/>
+          <p:cNvSpPr/>
+          <p:nvPr/>
+        </p:nvSpPr>
+        <p:spPr>
+          <a:xfrm>
+            <a:off x="6373368" y="4160520"/>
+            <a:ext cx="329184" cy="274320"/>
+          </a:xfrm>
+          <a:prstGeom prst="rect">
+            <a:avLst/>
+          </a:prstGeom>
+          <a:noFill/>
+          <a:ln/>
+        </p:spPr>
+        <p:txBody>
+          <a:bodyPr wrap="square" lIns="0" tIns="0" rIns="0" bIns="0" rtlCol="0" anchor="ctr"/>
+          <a:lstStyle/>
+          <a:p>
+            <a:pPr algn="ctr" indent="0" marL="0">
+              <a:buNone/>
+            </a:pPr>
+            <a:r>
+              <a:rPr lang="en-US" sz="1200" dirty="0">
+                <a:solidFill>
+                  <a:srgbClr val="000000"/>
+                </a:solidFill>
+                <a:latin typeface="Malgun Gothic" pitchFamily="34" charset="0"/>
+                <a:ea typeface="Malgun Gothic" pitchFamily="34" charset="-122"/>
+                <a:cs typeface="Malgun Gothic" pitchFamily="34" charset="-120"/>
+              </a:rPr>
+              <a:t>🔥</a:t>
+            </a:r>
+            <a:endParaRPr lang="en-US" sz="1200" dirty="0"/>
+          </a:p>
+        </p:txBody>
+      </p:sp>
+      <p:sp>
+        <p:nvSpPr>
+          <p:cNvPr id="29" name="Shape 27"/>
+          <p:cNvSpPr/>
+          <p:nvPr/>
+        </p:nvSpPr>
+        <p:spPr>
+          <a:xfrm>
+            <a:off x="3794760" y="4178808"/>
+            <a:ext cx="182880" cy="182880"/>
+          </a:xfrm>
+          <a:prstGeom prst="ellipse">
+            <a:avLst/>
+          </a:prstGeom>
+          <a:solidFill>
+            <a:srgbClr val="DC2626"/>
+          </a:solidFill>
+          <a:ln w="19050">
+            <a:solidFill>
+              <a:srgbClr val="FFFFFF"/>
+            </a:solidFill>
+            <a:prstDash val="solid"/>
+          </a:ln>
+        </p:spPr>
+      </p:sp>
+      <p:sp>
+        <p:nvSpPr>
+          <p:cNvPr id="30" name="Text 28"/>
+          <p:cNvSpPr/>
+          <p:nvPr/>
+        </p:nvSpPr>
+        <p:spPr>
+          <a:xfrm>
+            <a:off x="3721608" y="3831336"/>
+            <a:ext cx="329184" cy="274320"/>
+          </a:xfrm>
+          <a:prstGeom prst="rect">
+            <a:avLst/>
+          </a:prstGeom>
+          <a:noFill/>
+          <a:ln/>
+        </p:spPr>
+        <p:txBody>
+          <a:bodyPr wrap="square" lIns="0" tIns="0" rIns="0" bIns="0" rtlCol="0" anchor="ctr"/>
+          <a:lstStyle/>
+          <a:p>
+            <a:pPr algn="ctr" indent="0" marL="0">
+              <a:buNone/>
+            </a:pPr>
+            <a:r>
+              <a:rPr lang="en-US" sz="1200" dirty="0">
+                <a:solidFill>
+                  <a:srgbClr val="000000"/>
+                </a:solidFill>
+                <a:latin typeface="Malgun Gothic" pitchFamily="34" charset="0"/>
+                <a:ea typeface="Malgun Gothic" pitchFamily="34" charset="-122"/>
+                <a:cs typeface="Malgun Gothic" pitchFamily="34" charset="-120"/>
+              </a:rPr>
+              <a:t>🔥</a:t>
+            </a:r>
+            <a:endParaRPr lang="en-US" sz="1200" dirty="0"/>
+          </a:p>
+        </p:txBody>
+      </p:sp>
+      <p:sp>
+        <p:nvSpPr>
+          <p:cNvPr id="31" name="Shape 29"/>
+          <p:cNvSpPr/>
+          <p:nvPr/>
+        </p:nvSpPr>
+        <p:spPr>
+          <a:xfrm>
+            <a:off x="822960" y="5513832"/>
+            <a:ext cx="384048" cy="0"/>
+          </a:xfrm>
+          <a:prstGeom prst="line">
+            <a:avLst/>
+          </a:prstGeom>
+          <a:noFill/>
+          <a:ln w="31750">
+            <a:solidFill>
+              <a:srgbClr val="DC2626"/>
+            </a:solidFill>
+            <a:prstDash val="dash"/>
+          </a:ln>
+        </p:spPr>
+      </p:sp>
+      <p:sp>
+        <p:nvSpPr>
+          <p:cNvPr id="32" name="Text 30"/>
+          <p:cNvSpPr/>
+          <p:nvPr/>
+        </p:nvSpPr>
+        <p:spPr>
+          <a:xfrm>
+            <a:off x="1280160" y="5385816"/>
+            <a:ext cx="1920240" cy="274320"/>
+          </a:xfrm>
+          <a:prstGeom prst="rect">
+            <a:avLst/>
+          </a:prstGeom>
+          <a:noFill/>
+          <a:ln/>
+        </p:spPr>
+        <p:txBody>
+          <a:bodyPr wrap="square" lIns="0" tIns="0" rIns="0" bIns="0" rtlCol="0" anchor="ctr"/>
+          <a:lstStyle/>
+          <a:p>
+            <a:pPr indent="0" marL="0">
+              <a:buNone/>
+            </a:pPr>
+            <a:r>
+              <a:rPr lang="en-US" sz="1000" dirty="0">
+                <a:solidFill>
+                  <a:srgbClr val="334155"/>
+                </a:solidFill>
+                <a:latin typeface="Malgun Gothic" pitchFamily="34" charset="0"/>
+                <a:ea typeface="Malgun Gothic" pitchFamily="34" charset="-122"/>
+                <a:cs typeface="Malgun Gothic" pitchFamily="34" charset="-120"/>
+              </a:rPr>
+              <a:t>소방차 진입불가 골목</a:t>
+            </a:r>
+            <a:endParaRPr lang="en-US" sz="1000" dirty="0"/>
+          </a:p>
+        </p:txBody>
+      </p:sp>
+      <p:sp>
+        <p:nvSpPr>
+          <p:cNvPr id="33" name="Shape 31"/>
+          <p:cNvSpPr/>
+          <p:nvPr/>
+        </p:nvSpPr>
+        <p:spPr>
+          <a:xfrm>
+            <a:off x="3246120" y="5513832"/>
+            <a:ext cx="384048" cy="0"/>
+          </a:xfrm>
+          <a:prstGeom prst="line">
+            <a:avLst/>
+          </a:prstGeom>
+          <a:noFill/>
+          <a:ln w="44450">
+            <a:solidFill>
+              <a:srgbClr val="38BDF8"/>
+            </a:solidFill>
+            <a:prstDash val="solid"/>
+          </a:ln>
+        </p:spPr>
+      </p:sp>
+      <p:sp>
+        <p:nvSpPr>
+          <p:cNvPr id="34" name="Text 32"/>
+          <p:cNvSpPr/>
+          <p:nvPr/>
+        </p:nvSpPr>
+        <p:spPr>
+          <a:xfrm>
+            <a:off x="3703320" y="5385816"/>
+            <a:ext cx="1554480" cy="274320"/>
+          </a:xfrm>
+          <a:prstGeom prst="rect">
+            <a:avLst/>
+          </a:prstGeom>
+          <a:noFill/>
+          <a:ln/>
+        </p:spPr>
+        <p:txBody>
+          <a:bodyPr wrap="square" lIns="0" tIns="0" rIns="0" bIns="0" rtlCol="0" anchor="ctr"/>
+          <a:lstStyle/>
+          <a:p>
+            <a:pPr indent="0" marL="0">
+              <a:buNone/>
+            </a:pPr>
+            <a:r>
+              <a:rPr lang="en-US" sz="1000" dirty="0">
+                <a:solidFill>
+                  <a:srgbClr val="334155"/>
+                </a:solidFill>
+                <a:latin typeface="Malgun Gothic" pitchFamily="34" charset="0"/>
+                <a:ea typeface="Malgun Gothic" pitchFamily="34" charset="-122"/>
+                <a:cs typeface="Malgun Gothic" pitchFamily="34" charset="-120"/>
+              </a:rPr>
+              <a:t>소방차 주행경로</a:t>
+            </a:r>
+            <a:endParaRPr lang="en-US" sz="1000" dirty="0"/>
+          </a:p>
+        </p:txBody>
+      </p:sp>
+      <p:sp>
+        <p:nvSpPr>
+          <p:cNvPr id="35" name="Text 33"/>
+          <p:cNvSpPr/>
+          <p:nvPr/>
+        </p:nvSpPr>
+        <p:spPr>
+          <a:xfrm>
+            <a:off x="5230368" y="5340096"/>
+            <a:ext cx="274320" cy="310896"/>
+          </a:xfrm>
+          <a:prstGeom prst="rect">
+            <a:avLst/>
+          </a:prstGeom>
+          <a:noFill/>
+          <a:ln/>
+        </p:spPr>
+        <p:txBody>
+          <a:bodyPr wrap="square" lIns="0" tIns="0" rIns="0" bIns="0" rtlCol="0" anchor="ctr"/>
+          <a:lstStyle/>
+          <a:p>
+            <a:pPr algn="ctr" indent="0" marL="0">
+              <a:buNone/>
+            </a:pPr>
+            <a:r>
+              <a:rPr lang="en-US" sz="1200" dirty="0">
+                <a:solidFill>
+                  <a:srgbClr val="000000"/>
+                </a:solidFill>
+                <a:latin typeface="Malgun Gothic" pitchFamily="34" charset="0"/>
+                <a:ea typeface="Malgun Gothic" pitchFamily="34" charset="-122"/>
+                <a:cs typeface="Malgun Gothic" pitchFamily="34" charset="-120"/>
+              </a:rPr>
+              <a:t>🔥</a:t>
+            </a:r>
+            <a:endParaRPr lang="en-US" sz="1200" dirty="0"/>
+          </a:p>
+        </p:txBody>
+      </p:sp>
+      <p:sp>
+        <p:nvSpPr>
+          <p:cNvPr id="36" name="Text 34"/>
+          <p:cNvSpPr/>
+          <p:nvPr/>
+        </p:nvSpPr>
+        <p:spPr>
+          <a:xfrm>
+            <a:off x="5559552" y="5385816"/>
+            <a:ext cx="1737360" cy="274320"/>
+          </a:xfrm>
+          <a:prstGeom prst="rect">
+            <a:avLst/>
+          </a:prstGeom>
+          <a:noFill/>
+          <a:ln/>
+        </p:spPr>
+        <p:txBody>
+          <a:bodyPr wrap="square" lIns="0" tIns="0" rIns="0" bIns="0" rtlCol="0" anchor="ctr"/>
+          <a:lstStyle/>
+          <a:p>
+            <a:pPr indent="0" marL="0">
+              <a:buNone/>
+            </a:pPr>
+            <a:r>
+              <a:rPr lang="en-US" sz="1000" dirty="0">
+                <a:solidFill>
+                  <a:srgbClr val="334155"/>
+                </a:solidFill>
+                <a:latin typeface="Malgun Gothic" pitchFamily="34" charset="0"/>
+                <a:ea typeface="Malgun Gothic" pitchFamily="34" charset="-122"/>
+                <a:cs typeface="Malgun Gothic" pitchFamily="34" charset="-120"/>
+              </a:rPr>
+              <a:t>화재 발생지점</a:t>
+            </a:r>
+            <a:endParaRPr lang="en-US" sz="1000" dirty="0"/>
+          </a:p>
+        </p:txBody>
+      </p:sp>
+      <p:sp>
+        <p:nvSpPr>
+          <p:cNvPr id="37" name="Shape 35"/>
+          <p:cNvSpPr/>
+          <p:nvPr/>
+        </p:nvSpPr>
+        <p:spPr>
+          <a:xfrm>
+            <a:off x="7772400" y="1737360"/>
+            <a:ext cx="3840480" cy="932688"/>
+          </a:xfrm>
+          <a:prstGeom prst="roundRect">
+            <a:avLst>
+              <a:gd name="adj" fmla="val 7843"/>
+            </a:avLst>
+          </a:prstGeom>
+          <a:solidFill>
+            <a:srgbClr val="F8FAFC"/>
           </a:solidFill>
           <a:ln w="12700">
             <a:solidFill>
@@ -13391,373 +14260,14 @@
       </p:sp>
       <p:sp>
         <p:nvSpPr>
-          <p:cNvPr id="6" name="Shape 4"/>
-          <p:cNvSpPr/>
-          <p:nvPr/>
-        </p:nvSpPr>
-        <p:spPr>
-          <a:xfrm>
-            <a:off x="1143000" y="2240280"/>
-            <a:ext cx="1188720" cy="822960"/>
-          </a:xfrm>
-          <a:prstGeom prst="rect">
-            <a:avLst/>
-          </a:prstGeom>
-          <a:solidFill>
-            <a:srgbClr val="DDE3EA"/>
-          </a:solidFill>
-          <a:ln w="9525">
-            <a:solidFill>
-              <a:srgbClr val="CBD5E1"/>
-            </a:solidFill>
-            <a:prstDash val="solid"/>
-          </a:ln>
-        </p:spPr>
-      </p:sp>
-      <p:sp>
-        <p:nvSpPr>
-          <p:cNvPr id="7" name="Shape 5"/>
-          <p:cNvSpPr/>
-          <p:nvPr/>
-        </p:nvSpPr>
-        <p:spPr>
-          <a:xfrm>
-            <a:off x="2788920" y="2194560"/>
-            <a:ext cx="1280160" cy="731520"/>
-          </a:xfrm>
-          <a:prstGeom prst="rect">
-            <a:avLst/>
-          </a:prstGeom>
-          <a:solidFill>
-            <a:srgbClr val="DDE3EA"/>
-          </a:solidFill>
-          <a:ln w="9525">
-            <a:solidFill>
-              <a:srgbClr val="CBD5E1"/>
-            </a:solidFill>
-            <a:prstDash val="solid"/>
-          </a:ln>
-        </p:spPr>
-      </p:sp>
-      <p:sp>
-        <p:nvSpPr>
-          <p:cNvPr id="8" name="Shape 6"/>
-          <p:cNvSpPr/>
-          <p:nvPr/>
-        </p:nvSpPr>
-        <p:spPr>
-          <a:xfrm>
-            <a:off x="5349240" y="2286000"/>
-            <a:ext cx="1280160" cy="822960"/>
-          </a:xfrm>
-          <a:prstGeom prst="rect">
-            <a:avLst/>
-          </a:prstGeom>
-          <a:solidFill>
-            <a:srgbClr val="DDE3EA"/>
-          </a:solidFill>
-          <a:ln w="9525">
-            <a:solidFill>
-              <a:srgbClr val="CBD5E1"/>
-            </a:solidFill>
-            <a:prstDash val="solid"/>
-          </a:ln>
-        </p:spPr>
-      </p:sp>
-      <p:sp>
-        <p:nvSpPr>
-          <p:cNvPr id="9" name="Shape 7"/>
-          <p:cNvSpPr/>
-          <p:nvPr/>
-        </p:nvSpPr>
-        <p:spPr>
-          <a:xfrm>
-            <a:off x="1234440" y="3520440"/>
-            <a:ext cx="1097280" cy="914400"/>
-          </a:xfrm>
-          <a:prstGeom prst="rect">
-            <a:avLst/>
-          </a:prstGeom>
-          <a:solidFill>
-            <a:srgbClr val="DDE3EA"/>
-          </a:solidFill>
-          <a:ln w="9525">
-            <a:solidFill>
-              <a:srgbClr val="CBD5E1"/>
-            </a:solidFill>
-            <a:prstDash val="solid"/>
-          </a:ln>
-        </p:spPr>
-      </p:sp>
-      <p:sp>
-        <p:nvSpPr>
-          <p:cNvPr id="10" name="Shape 8"/>
-          <p:cNvSpPr/>
-          <p:nvPr/>
-        </p:nvSpPr>
-        <p:spPr>
-          <a:xfrm>
-            <a:off x="4069080" y="3429000"/>
-            <a:ext cx="1188720" cy="1005840"/>
-          </a:xfrm>
-          <a:prstGeom prst="rect">
-            <a:avLst/>
-          </a:prstGeom>
-          <a:solidFill>
-            <a:srgbClr val="DDE3EA"/>
-          </a:solidFill>
-          <a:ln w="9525">
-            <a:solidFill>
-              <a:srgbClr val="CBD5E1"/>
-            </a:solidFill>
-            <a:prstDash val="solid"/>
-          </a:ln>
-        </p:spPr>
-      </p:sp>
-      <p:sp>
-        <p:nvSpPr>
-          <p:cNvPr id="11" name="Shape 9"/>
-          <p:cNvSpPr/>
-          <p:nvPr/>
-        </p:nvSpPr>
-        <p:spPr>
-          <a:xfrm>
-            <a:off x="5897880" y="3611880"/>
-            <a:ext cx="1097280" cy="914400"/>
-          </a:xfrm>
-          <a:prstGeom prst="rect">
-            <a:avLst/>
-          </a:prstGeom>
-          <a:solidFill>
-            <a:srgbClr val="DDE3EA"/>
-          </a:solidFill>
-          <a:ln w="9525">
-            <a:solidFill>
-              <a:srgbClr val="CBD5E1"/>
-            </a:solidFill>
-            <a:prstDash val="solid"/>
-          </a:ln>
-        </p:spPr>
-      </p:sp>
-      <p:sp>
-        <p:nvSpPr>
-          <p:cNvPr id="12" name="Shape 10"/>
-          <p:cNvSpPr/>
-          <p:nvPr/>
-        </p:nvSpPr>
-        <p:spPr>
-          <a:xfrm>
-            <a:off x="2514600" y="4251960"/>
-            <a:ext cx="1188720" cy="640080"/>
-          </a:xfrm>
-          <a:prstGeom prst="rect">
-            <a:avLst/>
-          </a:prstGeom>
-          <a:solidFill>
-            <a:srgbClr val="DDE3EA"/>
-          </a:solidFill>
-          <a:ln w="9525">
-            <a:solidFill>
-              <a:srgbClr val="CBD5E1"/>
-            </a:solidFill>
-            <a:prstDash val="solid"/>
-          </a:ln>
-        </p:spPr>
-      </p:sp>
-      <p:sp>
-        <p:nvSpPr>
-          <p:cNvPr id="13" name="Shape 11"/>
-          <p:cNvSpPr/>
-          <p:nvPr/>
-        </p:nvSpPr>
-        <p:spPr>
-          <a:xfrm>
-            <a:off x="960120" y="3291840"/>
-            <a:ext cx="6217920" cy="0"/>
-          </a:xfrm>
-          <a:prstGeom prst="line">
-            <a:avLst/>
-          </a:prstGeom>
-          <a:noFill/>
-          <a:ln w="57150">
-            <a:solidFill>
-              <a:srgbClr val="2563EB"/>
-            </a:solidFill>
-            <a:prstDash val="solid"/>
-          </a:ln>
-        </p:spPr>
-      </p:sp>
-      <p:sp>
-        <p:nvSpPr>
-          <p:cNvPr id="14" name="Shape 12"/>
-          <p:cNvSpPr/>
-          <p:nvPr/>
-        </p:nvSpPr>
-        <p:spPr>
-          <a:xfrm>
-            <a:off x="2606040" y="2057400"/>
-            <a:ext cx="0" cy="3017520"/>
-          </a:xfrm>
-          <a:prstGeom prst="line">
-            <a:avLst/>
-          </a:prstGeom>
-          <a:noFill/>
-          <a:ln w="57150">
-            <a:solidFill>
-              <a:srgbClr val="2563EB"/>
-            </a:solidFill>
-            <a:prstDash val="solid"/>
-          </a:ln>
-        </p:spPr>
-      </p:sp>
-      <p:sp>
-        <p:nvSpPr>
-          <p:cNvPr id="15" name="Shape 13"/>
-          <p:cNvSpPr/>
-          <p:nvPr/>
-        </p:nvSpPr>
-        <p:spPr>
-          <a:xfrm>
-            <a:off x="5257800" y="3291840"/>
-            <a:ext cx="0" cy="1783080"/>
-          </a:xfrm>
-          <a:prstGeom prst="line">
-            <a:avLst/>
-          </a:prstGeom>
-          <a:noFill/>
-          <a:ln w="50800">
-            <a:solidFill>
-              <a:srgbClr val="2563EB"/>
-            </a:solidFill>
-            <a:prstDash val="solid"/>
-          </a:ln>
-        </p:spPr>
-      </p:sp>
-      <p:sp>
-        <p:nvSpPr>
-          <p:cNvPr id="16" name="Shape 14"/>
-          <p:cNvSpPr/>
-          <p:nvPr/>
-        </p:nvSpPr>
-        <p:spPr>
-          <a:xfrm>
-            <a:off x="2606040" y="3291840"/>
-            <a:ext cx="1005840" cy="-777240"/>
-          </a:xfrm>
-          <a:prstGeom prst="line">
-            <a:avLst/>
-          </a:prstGeom>
-          <a:noFill/>
-          <a:ln w="44450">
-            <a:solidFill>
-              <a:srgbClr val="DC2626"/>
-            </a:solidFill>
-            <a:prstDash val="solid"/>
-          </a:ln>
-        </p:spPr>
-      </p:sp>
-      <p:sp>
-        <p:nvSpPr>
-          <p:cNvPr id="17" name="Shape 15"/>
-          <p:cNvSpPr/>
-          <p:nvPr/>
-        </p:nvSpPr>
-        <p:spPr>
-          <a:xfrm>
-            <a:off x="5257800" y="3291840"/>
-            <a:ext cx="914400" cy="-640080"/>
-          </a:xfrm>
-          <a:prstGeom prst="line">
-            <a:avLst/>
-          </a:prstGeom>
-          <a:noFill/>
-          <a:ln w="44450">
-            <a:solidFill>
-              <a:srgbClr val="DC2626"/>
-            </a:solidFill>
-            <a:prstDash val="solid"/>
-          </a:ln>
-        </p:spPr>
-      </p:sp>
-      <p:sp>
-        <p:nvSpPr>
-          <p:cNvPr id="18" name="Shape 16"/>
-          <p:cNvSpPr/>
-          <p:nvPr/>
-        </p:nvSpPr>
-        <p:spPr>
-          <a:xfrm>
-            <a:off x="1600200" y="3291840"/>
-            <a:ext cx="0" cy="1051560"/>
-          </a:xfrm>
-          <a:prstGeom prst="line">
-            <a:avLst/>
-          </a:prstGeom>
-          <a:noFill/>
-          <a:ln w="44450">
-            <a:solidFill>
-              <a:srgbClr val="DC2626"/>
-            </a:solidFill>
-            <a:prstDash val="solid"/>
-          </a:ln>
-        </p:spPr>
-      </p:sp>
-      <p:sp>
-        <p:nvSpPr>
-          <p:cNvPr id="19" name="Shape 17"/>
-          <p:cNvSpPr/>
-          <p:nvPr/>
-        </p:nvSpPr>
-        <p:spPr>
-          <a:xfrm>
-            <a:off x="3977640" y="4526280"/>
-            <a:ext cx="1005840" cy="228600"/>
-          </a:xfrm>
-          <a:prstGeom prst="line">
-            <a:avLst/>
-          </a:prstGeom>
-          <a:noFill/>
-          <a:ln w="44450">
-            <a:solidFill>
-              <a:srgbClr val="DC2626"/>
-            </a:solidFill>
-            <a:prstDash val="solid"/>
-          </a:ln>
-        </p:spPr>
-      </p:sp>
-      <p:sp>
-        <p:nvSpPr>
-          <p:cNvPr id="20" name="Shape 18"/>
-          <p:cNvSpPr/>
-          <p:nvPr/>
-        </p:nvSpPr>
-        <p:spPr>
-          <a:xfrm>
-            <a:off x="6446520" y="3291840"/>
-            <a:ext cx="457200" cy="1051560"/>
-          </a:xfrm>
-          <a:prstGeom prst="line">
-            <a:avLst/>
-          </a:prstGeom>
-          <a:noFill/>
-          <a:ln w="44450">
-            <a:solidFill>
-              <a:srgbClr val="DC2626"/>
-            </a:solidFill>
-            <a:prstDash val="solid"/>
-          </a:ln>
-        </p:spPr>
-      </p:sp>
-      <p:sp>
-        <p:nvSpPr>
-          <p:cNvPr id="21" name="Shape 19"/>
-          <p:cNvSpPr/>
-          <p:nvPr/>
-        </p:nvSpPr>
-        <p:spPr>
-          <a:xfrm>
-            <a:off x="3483864" y="2386584"/>
-            <a:ext cx="256032" cy="256032"/>
+          <p:cNvPr id="38" name="Shape 36"/>
+          <p:cNvSpPr/>
+          <p:nvPr/>
+        </p:nvSpPr>
+        <p:spPr>
+          <a:xfrm>
+            <a:off x="7973568" y="1993392"/>
+            <a:ext cx="420624" cy="420624"/>
           </a:xfrm>
           <a:prstGeom prst="ellipse">
             <a:avLst/>
@@ -13765,169 +14275,19 @@
           <a:solidFill>
             <a:srgbClr val="EA580C"/>
           </a:solidFill>
-          <a:ln w="19050">
-            <a:solidFill>
-              <a:srgbClr val="DC2626"/>
-            </a:solidFill>
-            <a:prstDash val="solid"/>
-          </a:ln>
-        </p:spPr>
-      </p:sp>
-      <p:sp>
-        <p:nvSpPr>
-          <p:cNvPr id="22" name="Shape 20"/>
-          <p:cNvSpPr/>
-          <p:nvPr/>
-        </p:nvSpPr>
-        <p:spPr>
-          <a:xfrm>
-            <a:off x="6044184" y="2523744"/>
-            <a:ext cx="256032" cy="256032"/>
-          </a:xfrm>
-          <a:prstGeom prst="ellipse">
-            <a:avLst/>
-          </a:prstGeom>
-          <a:solidFill>
-            <a:srgbClr val="EA580C"/>
-          </a:solidFill>
-          <a:ln w="19050">
-            <a:solidFill>
-              <a:srgbClr val="DC2626"/>
-            </a:solidFill>
-            <a:prstDash val="solid"/>
-          </a:ln>
-        </p:spPr>
-      </p:sp>
-      <p:sp>
-        <p:nvSpPr>
-          <p:cNvPr id="23" name="Shape 21"/>
-          <p:cNvSpPr/>
-          <p:nvPr/>
-        </p:nvSpPr>
-        <p:spPr>
-          <a:xfrm>
-            <a:off x="1472184" y="4215384"/>
-            <a:ext cx="256032" cy="256032"/>
-          </a:xfrm>
-          <a:prstGeom prst="ellipse">
-            <a:avLst/>
-          </a:prstGeom>
-          <a:solidFill>
-            <a:srgbClr val="EA580C"/>
-          </a:solidFill>
-          <a:ln w="19050">
-            <a:solidFill>
-              <a:srgbClr val="DC2626"/>
-            </a:solidFill>
-            <a:prstDash val="solid"/>
-          </a:ln>
-        </p:spPr>
-      </p:sp>
-      <p:sp>
-        <p:nvSpPr>
-          <p:cNvPr id="24" name="Shape 22"/>
-          <p:cNvSpPr/>
-          <p:nvPr/>
-        </p:nvSpPr>
-        <p:spPr>
-          <a:xfrm>
-            <a:off x="4855464" y="4626864"/>
-            <a:ext cx="256032" cy="256032"/>
-          </a:xfrm>
-          <a:prstGeom prst="ellipse">
-            <a:avLst/>
-          </a:prstGeom>
-          <a:solidFill>
-            <a:srgbClr val="EA580C"/>
-          </a:solidFill>
-          <a:ln w="19050">
-            <a:solidFill>
-              <a:srgbClr val="DC2626"/>
-            </a:solidFill>
-            <a:prstDash val="solid"/>
-          </a:ln>
-        </p:spPr>
-      </p:sp>
-      <p:sp>
-        <p:nvSpPr>
-          <p:cNvPr id="25" name="Shape 23"/>
-          <p:cNvSpPr/>
-          <p:nvPr/>
-        </p:nvSpPr>
-        <p:spPr>
-          <a:xfrm>
-            <a:off x="6775704" y="4215384"/>
-            <a:ext cx="256032" cy="256032"/>
-          </a:xfrm>
-          <a:prstGeom prst="ellipse">
-            <a:avLst/>
-          </a:prstGeom>
-          <a:solidFill>
-            <a:srgbClr val="EA580C"/>
-          </a:solidFill>
-          <a:ln w="19050">
-            <a:solidFill>
-              <a:srgbClr val="DC2626"/>
-            </a:solidFill>
-            <a:prstDash val="solid"/>
-          </a:ln>
-        </p:spPr>
-      </p:sp>
-      <p:sp>
-        <p:nvSpPr>
-          <p:cNvPr id="26" name="Shape 24"/>
-          <p:cNvSpPr/>
-          <p:nvPr/>
-        </p:nvSpPr>
-        <p:spPr>
-          <a:xfrm>
-            <a:off x="822960" y="4754880"/>
-            <a:ext cx="365760" cy="365760"/>
-          </a:xfrm>
-          <a:prstGeom prst="ellipse">
-            <a:avLst/>
-          </a:prstGeom>
-          <a:solidFill>
-            <a:srgbClr val="FFFFFF"/>
-          </a:solidFill>
-          <a:ln w="31750">
-            <a:solidFill>
-              <a:srgbClr val="2563EB"/>
-            </a:solidFill>
-            <a:prstDash val="solid"/>
-          </a:ln>
-        </p:spPr>
-      </p:sp>
-      <p:sp>
-        <p:nvSpPr>
-          <p:cNvPr id="27" name="Shape 25"/>
-          <p:cNvSpPr/>
-          <p:nvPr/>
-        </p:nvSpPr>
-        <p:spPr>
-          <a:xfrm>
-            <a:off x="905256" y="4837176"/>
-            <a:ext cx="201168" cy="201168"/>
-          </a:xfrm>
-          <a:prstGeom prst="rect">
-            <a:avLst/>
-          </a:prstGeom>
-          <a:solidFill>
-            <a:srgbClr val="2563EB"/>
-          </a:solidFill>
-          <a:ln/>
-        </p:spPr>
-      </p:sp>
-      <p:sp>
-        <p:nvSpPr>
-          <p:cNvPr id="28" name="Text 26"/>
-          <p:cNvSpPr/>
-          <p:nvPr/>
-        </p:nvSpPr>
-        <p:spPr>
-          <a:xfrm>
-            <a:off x="685800" y="5111496"/>
-            <a:ext cx="640080" cy="201168"/>
+          <a:ln/>
+        </p:spPr>
+      </p:sp>
+      <p:sp>
+        <p:nvSpPr>
+          <p:cNvPr id="39" name="Text 37"/>
+          <p:cNvSpPr/>
+          <p:nvPr/>
+        </p:nvSpPr>
+        <p:spPr>
+          <a:xfrm>
+            <a:off x="7973568" y="1993392"/>
+            <a:ext cx="420624" cy="420624"/>
           </a:xfrm>
           <a:prstGeom prst="rect">
             <a:avLst/>
@@ -13943,53 +14303,30 @@
               <a:buNone/>
             </a:pPr>
             <a:r>
-              <a:rPr lang="en-US" sz="800" b="1" dirty="0">
-                <a:solidFill>
-                  <a:srgbClr val="2563EB"/>
-                </a:solidFill>
-                <a:latin typeface="Malgun Gothic" pitchFamily="34" charset="0"/>
-                <a:ea typeface="Malgun Gothic" pitchFamily="34" charset="-122"/>
-                <a:cs typeface="Malgun Gothic" pitchFamily="34" charset="-120"/>
-              </a:rPr>
-              <a:t>소방서</a:t>
-            </a:r>
-            <a:endParaRPr lang="en-US" sz="800" dirty="0"/>
-          </a:p>
-        </p:txBody>
-      </p:sp>
-      <p:sp>
-        <p:nvSpPr>
-          <p:cNvPr id="29" name="Shape 27"/>
-          <p:cNvSpPr/>
-          <p:nvPr/>
-        </p:nvSpPr>
-        <p:spPr>
-          <a:xfrm>
-            <a:off x="822960" y="5513832"/>
-            <a:ext cx="365760" cy="0"/>
-          </a:xfrm>
-          <a:prstGeom prst="line">
-            <a:avLst/>
-          </a:prstGeom>
-          <a:noFill/>
-          <a:ln w="44450">
-            <a:solidFill>
-              <a:srgbClr val="DC2626"/>
-            </a:solidFill>
-            <a:prstDash val="solid"/>
-          </a:ln>
-        </p:spPr>
-      </p:sp>
-      <p:sp>
-        <p:nvSpPr>
-          <p:cNvPr id="30" name="Text 28"/>
-          <p:cNvSpPr/>
-          <p:nvPr/>
-        </p:nvSpPr>
-        <p:spPr>
-          <a:xfrm>
-            <a:off x="1261872" y="5385816"/>
-            <a:ext cx="2011680" cy="274320"/>
+              <a:rPr lang="en-US" sz="1656" b="1" dirty="0">
+                <a:solidFill>
+                  <a:srgbClr val="FFFFFF"/>
+                </a:solidFill>
+                <a:latin typeface="Consolas" pitchFamily="34" charset="0"/>
+                <a:ea typeface="Consolas" pitchFamily="34" charset="-122"/>
+                <a:cs typeface="Consolas" pitchFamily="34" charset="-120"/>
+              </a:rPr>
+              <a:t>1</a:t>
+            </a:r>
+            <a:endParaRPr lang="en-US" sz="1656" dirty="0"/>
+          </a:p>
+        </p:txBody>
+      </p:sp>
+      <p:sp>
+        <p:nvSpPr>
+          <p:cNvPr id="40" name="Text 38"/>
+          <p:cNvSpPr/>
+          <p:nvPr/>
+        </p:nvSpPr>
+        <p:spPr>
+          <a:xfrm>
+            <a:off x="8522208" y="1856232"/>
+            <a:ext cx="3017520" cy="320040"/>
           </a:xfrm>
           <a:prstGeom prst="rect">
             <a:avLst/>
@@ -14005,7 +14342,49 @@
               <a:buNone/>
             </a:pPr>
             <a:r>
-              <a:rPr lang="en-US" sz="1000" dirty="0">
+              <a:rPr lang="en-US" sz="1300" b="1" dirty="0">
+                <a:solidFill>
+                  <a:srgbClr val="EA580C"/>
+                </a:solidFill>
+                <a:latin typeface="Malgun Gothic" pitchFamily="34" charset="0"/>
+                <a:ea typeface="Malgun Gothic" pitchFamily="34" charset="-122"/>
+                <a:cs typeface="Malgun Gothic" pitchFamily="34" charset="-120"/>
+              </a:rPr>
+              <a:t>화재지점 표시</a:t>
+            </a:r>
+            <a:endParaRPr lang="en-US" sz="1300" dirty="0"/>
+          </a:p>
+        </p:txBody>
+      </p:sp>
+      <p:sp>
+        <p:nvSpPr>
+          <p:cNvPr id="41" name="Text 39"/>
+          <p:cNvSpPr/>
+          <p:nvPr/>
+        </p:nvSpPr>
+        <p:spPr>
+          <a:xfrm>
+            <a:off x="8522208" y="2167128"/>
+            <a:ext cx="3017520" cy="457200"/>
+          </a:xfrm>
+          <a:prstGeom prst="rect">
+            <a:avLst/>
+          </a:prstGeom>
+          <a:noFill/>
+          <a:ln/>
+        </p:spPr>
+        <p:txBody>
+          <a:bodyPr wrap="square" lIns="0" tIns="0" rIns="0" bIns="0" rtlCol="0" anchor="t"/>
+          <a:lstStyle/>
+          <a:p>
+            <a:pPr indent="0" marL="0">
+              <a:lnSpc>
+                <a:spcPct val="105000"/>
+              </a:lnSpc>
+              <a:buNone/>
+            </a:pPr>
+            <a:r>
+              <a:rPr lang="en-US" sz="1050" dirty="0">
                 <a:solidFill>
                   <a:srgbClr val="334155"/>
                 </a:solidFill>
@@ -14013,147 +14392,21 @@
                 <a:ea typeface="Malgun Gothic" pitchFamily="34" charset="-122"/>
                 <a:cs typeface="Malgun Gothic" pitchFamily="34" charset="-120"/>
               </a:rPr>
-              <a:t>소방차 진입불가 경로</a:t>
-            </a:r>
-            <a:endParaRPr lang="en-US" sz="1000" dirty="0"/>
-          </a:p>
-        </p:txBody>
-      </p:sp>
-      <p:sp>
-        <p:nvSpPr>
-          <p:cNvPr id="31" name="Shape 29"/>
-          <p:cNvSpPr/>
-          <p:nvPr/>
-        </p:nvSpPr>
-        <p:spPr>
-          <a:xfrm>
-            <a:off x="3291840" y="5513832"/>
-            <a:ext cx="365760" cy="0"/>
-          </a:xfrm>
-          <a:prstGeom prst="line">
-            <a:avLst/>
-          </a:prstGeom>
-          <a:noFill/>
-          <a:ln w="44450">
-            <a:solidFill>
-              <a:srgbClr val="2563EB"/>
-            </a:solidFill>
-            <a:prstDash val="solid"/>
-          </a:ln>
-        </p:spPr>
-      </p:sp>
-      <p:sp>
-        <p:nvSpPr>
-          <p:cNvPr id="32" name="Text 30"/>
-          <p:cNvSpPr/>
-          <p:nvPr/>
-        </p:nvSpPr>
-        <p:spPr>
-          <a:xfrm>
-            <a:off x="3730752" y="5385816"/>
-            <a:ext cx="1554480" cy="274320"/>
-          </a:xfrm>
-          <a:prstGeom prst="rect">
-            <a:avLst/>
-          </a:prstGeom>
-          <a:noFill/>
-          <a:ln/>
-        </p:spPr>
-        <p:txBody>
-          <a:bodyPr wrap="square" lIns="0" tIns="0" rIns="0" bIns="0" rtlCol="0" anchor="ctr"/>
-          <a:lstStyle/>
-          <a:p>
-            <a:pPr indent="0" marL="0">
-              <a:buNone/>
-            </a:pPr>
-            <a:r>
-              <a:rPr lang="en-US" sz="1000" dirty="0">
-                <a:solidFill>
-                  <a:srgbClr val="334155"/>
-                </a:solidFill>
-                <a:latin typeface="Malgun Gothic" pitchFamily="34" charset="0"/>
-                <a:ea typeface="Malgun Gothic" pitchFamily="34" charset="-122"/>
-                <a:cs typeface="Malgun Gothic" pitchFamily="34" charset="-120"/>
-              </a:rPr>
-              <a:t>진입가능 도로</a:t>
-            </a:r>
-            <a:endParaRPr lang="en-US" sz="1000" dirty="0"/>
-          </a:p>
-        </p:txBody>
-      </p:sp>
-      <p:sp>
-        <p:nvSpPr>
-          <p:cNvPr id="33" name="Shape 31"/>
-          <p:cNvSpPr/>
-          <p:nvPr/>
-        </p:nvSpPr>
-        <p:spPr>
-          <a:xfrm>
-            <a:off x="5303520" y="5440680"/>
-            <a:ext cx="164592" cy="164592"/>
-          </a:xfrm>
-          <a:prstGeom prst="ellipse">
-            <a:avLst/>
-          </a:prstGeom>
-          <a:solidFill>
-            <a:srgbClr val="EA580C"/>
-          </a:solidFill>
-          <a:ln w="19050">
-            <a:solidFill>
-              <a:srgbClr val="DC2626"/>
-            </a:solidFill>
-            <a:prstDash val="solid"/>
-          </a:ln>
-        </p:spPr>
-      </p:sp>
-      <p:sp>
-        <p:nvSpPr>
-          <p:cNvPr id="34" name="Text 32"/>
-          <p:cNvSpPr/>
-          <p:nvPr/>
-        </p:nvSpPr>
-        <p:spPr>
-          <a:xfrm>
-            <a:off x="5532120" y="5385816"/>
-            <a:ext cx="1737360" cy="274320"/>
-          </a:xfrm>
-          <a:prstGeom prst="rect">
-            <a:avLst/>
-          </a:prstGeom>
-          <a:noFill/>
-          <a:ln/>
-        </p:spPr>
-        <p:txBody>
-          <a:bodyPr wrap="square" lIns="0" tIns="0" rIns="0" bIns="0" rtlCol="0" anchor="ctr"/>
-          <a:lstStyle/>
-          <a:p>
-            <a:pPr indent="0" marL="0">
-              <a:buNone/>
-            </a:pPr>
-            <a:r>
-              <a:rPr lang="en-US" sz="1000" dirty="0">
-                <a:solidFill>
-                  <a:srgbClr val="334155"/>
-                </a:solidFill>
-                <a:latin typeface="Malgun Gothic" pitchFamily="34" charset="0"/>
-                <a:ea typeface="Malgun Gothic" pitchFamily="34" charset="-122"/>
-                <a:cs typeface="Malgun Gothic" pitchFamily="34" charset="-120"/>
-              </a:rPr>
-              <a:t>화재 발생지점</a:t>
-            </a:r>
-            <a:endParaRPr lang="en-US" sz="1000" dirty="0"/>
-          </a:p>
-        </p:txBody>
-      </p:sp>
-      <p:sp>
-        <p:nvSpPr>
-          <p:cNvPr id="35" name="Shape 33"/>
-          <p:cNvSpPr/>
-          <p:nvPr/>
-        </p:nvSpPr>
-        <p:spPr>
-          <a:xfrm>
-            <a:off x="7772400" y="1737360"/>
+              <a:t>최근 1년 창원 화재 발생지점(🔥)을 지도에 올린다</a:t>
+            </a:r>
+            <a:endParaRPr lang="en-US" sz="1050" dirty="0"/>
+          </a:p>
+        </p:txBody>
+      </p:sp>
+      <p:sp>
+        <p:nvSpPr>
+          <p:cNvPr id="42" name="Shape 40"/>
+          <p:cNvSpPr/>
+          <p:nvPr/>
+        </p:nvSpPr>
+        <p:spPr>
+          <a:xfrm>
+            <a:off x="7772400" y="2761488"/>
             <a:ext cx="3840480" cy="932688"/>
           </a:xfrm>
           <a:prstGeom prst="roundRect">
@@ -14174,33 +14427,33 @@
       </p:sp>
       <p:sp>
         <p:nvSpPr>
-          <p:cNvPr id="36" name="Shape 34"/>
-          <p:cNvSpPr/>
-          <p:nvPr/>
-        </p:nvSpPr>
-        <p:spPr>
-          <a:xfrm>
-            <a:off x="7973568" y="1993392"/>
+          <p:cNvPr id="43" name="Shape 41"/>
+          <p:cNvSpPr/>
+          <p:nvPr/>
+        </p:nvSpPr>
+        <p:spPr>
+          <a:xfrm>
+            <a:off x="7973568" y="3017520"/>
             <a:ext cx="420624" cy="420624"/>
           </a:xfrm>
           <a:prstGeom prst="ellipse">
             <a:avLst/>
           </a:prstGeom>
           <a:solidFill>
-            <a:srgbClr val="EA580C"/>
-          </a:solidFill>
-          <a:ln/>
-        </p:spPr>
-      </p:sp>
-      <p:sp>
-        <p:nvSpPr>
-          <p:cNvPr id="37" name="Text 35"/>
-          <p:cNvSpPr/>
-          <p:nvPr/>
-        </p:nvSpPr>
-        <p:spPr>
-          <a:xfrm>
-            <a:off x="7973568" y="1993392"/>
+            <a:srgbClr val="2563EB"/>
+          </a:solidFill>
+          <a:ln/>
+        </p:spPr>
+      </p:sp>
+      <p:sp>
+        <p:nvSpPr>
+          <p:cNvPr id="44" name="Text 42"/>
+          <p:cNvSpPr/>
+          <p:nvPr/>
+        </p:nvSpPr>
+        <p:spPr>
+          <a:xfrm>
+            <a:off x="7973568" y="3017520"/>
             <a:ext cx="420624" cy="420624"/>
           </a:xfrm>
           <a:prstGeom prst="rect">
@@ -14225,7 +14478,7 @@
                 <a:ea typeface="Consolas" pitchFamily="34" charset="-122"/>
                 <a:cs typeface="Consolas" pitchFamily="34" charset="-120"/>
               </a:rPr>
-              <a:t>1</a:t>
+              <a:t>2</a:t>
             </a:r>
             <a:endParaRPr lang="en-US" sz="1656" dirty="0"/>
           </a:p>
@@ -14233,13 +14486,13 @@
       </p:sp>
       <p:sp>
         <p:nvSpPr>
-          <p:cNvPr id="38" name="Text 36"/>
-          <p:cNvSpPr/>
-          <p:nvPr/>
-        </p:nvSpPr>
-        <p:spPr>
-          <a:xfrm>
-            <a:off x="8522208" y="1856232"/>
+          <p:cNvPr id="45" name="Text 43"/>
+          <p:cNvSpPr/>
+          <p:nvPr/>
+        </p:nvSpPr>
+        <p:spPr>
+          <a:xfrm>
+            <a:off x="8522208" y="2880360"/>
             <a:ext cx="3017520" cy="320040"/>
           </a:xfrm>
           <a:prstGeom prst="rect">
@@ -14258,13 +14511,13 @@
             <a:r>
               <a:rPr lang="en-US" sz="1300" b="1" dirty="0">
                 <a:solidFill>
-                  <a:srgbClr val="EA580C"/>
-                </a:solidFill>
-                <a:latin typeface="Malgun Gothic" pitchFamily="34" charset="0"/>
-                <a:ea typeface="Malgun Gothic" pitchFamily="34" charset="-122"/>
-                <a:cs typeface="Malgun Gothic" pitchFamily="34" charset="-120"/>
-              </a:rPr>
-              <a:t>화재지점 표시</a:t>
+                  <a:srgbClr val="2563EB"/>
+                </a:solidFill>
+                <a:latin typeface="Malgun Gothic" pitchFamily="34" charset="0"/>
+                <a:ea typeface="Malgun Gothic" pitchFamily="34" charset="-122"/>
+                <a:cs typeface="Malgun Gothic" pitchFamily="34" charset="-120"/>
+              </a:rPr>
+              <a:t>경로 탐색</a:t>
             </a:r>
             <a:endParaRPr lang="en-US" sz="1300" dirty="0"/>
           </a:p>
@@ -14272,13 +14525,13 @@
       </p:sp>
       <p:sp>
         <p:nvSpPr>
-          <p:cNvPr id="39" name="Text 37"/>
-          <p:cNvSpPr/>
-          <p:nvPr/>
-        </p:nvSpPr>
-        <p:spPr>
-          <a:xfrm>
-            <a:off x="8522208" y="2167128"/>
+          <p:cNvPr id="46" name="Text 44"/>
+          <p:cNvSpPr/>
+          <p:nvPr/>
+        </p:nvSpPr>
+        <p:spPr>
+          <a:xfrm>
+            <a:off x="8522208" y="3191256"/>
             <a:ext cx="3017520" cy="457200"/>
           </a:xfrm>
           <a:prstGeom prst="rect">
@@ -14306,7 +14559,7 @@
                 <a:ea typeface="Malgun Gothic" pitchFamily="34" charset="-122"/>
                 <a:cs typeface="Malgun Gothic" pitchFamily="34" charset="-120"/>
               </a:rPr>
-              <a:t>최근 1년 창원 화재 발생지점을 지도에 올린다</a:t>
+              <a:t>소방서에서 각 지점까지 하늘색 주행경로를 그린다</a:t>
             </a:r>
             <a:endParaRPr lang="en-US" sz="1050" dirty="0"/>
           </a:p>
@@ -14314,13 +14567,13 @@
       </p:sp>
       <p:sp>
         <p:nvSpPr>
-          <p:cNvPr id="40" name="Shape 38"/>
-          <p:cNvSpPr/>
-          <p:nvPr/>
-        </p:nvSpPr>
-        <p:spPr>
-          <a:xfrm>
-            <a:off x="7772400" y="2761488"/>
+          <p:cNvPr id="47" name="Shape 45"/>
+          <p:cNvSpPr/>
+          <p:nvPr/>
+        </p:nvSpPr>
+        <p:spPr>
+          <a:xfrm>
+            <a:off x="7772400" y="3785616"/>
             <a:ext cx="3840480" cy="932688"/>
           </a:xfrm>
           <a:prstGeom prst="roundRect">
@@ -14341,33 +14594,33 @@
       </p:sp>
       <p:sp>
         <p:nvSpPr>
-          <p:cNvPr id="41" name="Shape 39"/>
-          <p:cNvSpPr/>
-          <p:nvPr/>
-        </p:nvSpPr>
-        <p:spPr>
-          <a:xfrm>
-            <a:off x="7973568" y="3017520"/>
+          <p:cNvPr id="48" name="Shape 46"/>
+          <p:cNvSpPr/>
+          <p:nvPr/>
+        </p:nvSpPr>
+        <p:spPr>
+          <a:xfrm>
+            <a:off x="7973568" y="4041648"/>
             <a:ext cx="420624" cy="420624"/>
           </a:xfrm>
           <a:prstGeom prst="ellipse">
             <a:avLst/>
           </a:prstGeom>
           <a:solidFill>
-            <a:srgbClr val="2563EB"/>
-          </a:solidFill>
-          <a:ln/>
-        </p:spPr>
-      </p:sp>
-      <p:sp>
-        <p:nvSpPr>
-          <p:cNvPr id="42" name="Text 40"/>
-          <p:cNvSpPr/>
-          <p:nvPr/>
-        </p:nvSpPr>
-        <p:spPr>
-          <a:xfrm>
-            <a:off x="7973568" y="3017520"/>
+            <a:srgbClr val="DC2626"/>
+          </a:solidFill>
+          <a:ln/>
+        </p:spPr>
+      </p:sp>
+      <p:sp>
+        <p:nvSpPr>
+          <p:cNvPr id="49" name="Text 47"/>
+          <p:cNvSpPr/>
+          <p:nvPr/>
+        </p:nvSpPr>
+        <p:spPr>
+          <a:xfrm>
+            <a:off x="7973568" y="4041648"/>
             <a:ext cx="420624" cy="420624"/>
           </a:xfrm>
           <a:prstGeom prst="rect">
@@ -14392,7 +14645,7 @@
                 <a:ea typeface="Consolas" pitchFamily="34" charset="-122"/>
                 <a:cs typeface="Consolas" pitchFamily="34" charset="-120"/>
               </a:rPr>
-              <a:t>2</a:t>
+              <a:t>3</a:t>
             </a:r>
             <a:endParaRPr lang="en-US" sz="1656" dirty="0"/>
           </a:p>
@@ -14400,13 +14653,13 @@
       </p:sp>
       <p:sp>
         <p:nvSpPr>
-          <p:cNvPr id="43" name="Text 41"/>
-          <p:cNvSpPr/>
-          <p:nvPr/>
-        </p:nvSpPr>
-        <p:spPr>
-          <a:xfrm>
-            <a:off x="8522208" y="2880360"/>
+          <p:cNvPr id="50" name="Text 48"/>
+          <p:cNvSpPr/>
+          <p:nvPr/>
+        </p:nvSpPr>
+        <p:spPr>
+          <a:xfrm>
+            <a:off x="8522208" y="3904488"/>
             <a:ext cx="3017520" cy="320040"/>
           </a:xfrm>
           <a:prstGeom prst="rect">
@@ -14425,13 +14678,13 @@
             <a:r>
               <a:rPr lang="en-US" sz="1300" b="1" dirty="0">
                 <a:solidFill>
-                  <a:srgbClr val="2563EB"/>
-                </a:solidFill>
-                <a:latin typeface="Malgun Gothic" pitchFamily="34" charset="0"/>
-                <a:ea typeface="Malgun Gothic" pitchFamily="34" charset="-122"/>
-                <a:cs typeface="Malgun Gothic" pitchFamily="34" charset="-120"/>
-              </a:rPr>
-              <a:t>경로 탐색</a:t>
+                  <a:srgbClr val="DC2626"/>
+                </a:solidFill>
+                <a:latin typeface="Malgun Gothic" pitchFamily="34" charset="0"/>
+                <a:ea typeface="Malgun Gothic" pitchFamily="34" charset="-122"/>
+                <a:cs typeface="Malgun Gothic" pitchFamily="34" charset="-120"/>
+              </a:rPr>
+              <a:t>빨간 점선 = 진입불가</a:t>
             </a:r>
             <a:endParaRPr lang="en-US" sz="1300" dirty="0"/>
           </a:p>
@@ -14439,13 +14692,13 @@
       </p:sp>
       <p:sp>
         <p:nvSpPr>
-          <p:cNvPr id="44" name="Text 42"/>
-          <p:cNvSpPr/>
-          <p:nvPr/>
-        </p:nvSpPr>
-        <p:spPr>
-          <a:xfrm>
-            <a:off x="8522208" y="3191256"/>
+          <p:cNvPr id="51" name="Text 49"/>
+          <p:cNvSpPr/>
+          <p:nvPr/>
+        </p:nvSpPr>
+        <p:spPr>
+          <a:xfrm>
+            <a:off x="8522208" y="4215384"/>
             <a:ext cx="3017520" cy="457200"/>
           </a:xfrm>
           <a:prstGeom prst="rect">
@@ -14473,7 +14726,7 @@
                 <a:ea typeface="Malgun Gothic" pitchFamily="34" charset="-122"/>
                 <a:cs typeface="Malgun Gothic" pitchFamily="34" charset="-120"/>
               </a:rPr>
-              <a:t>각 지점까지 소방서에서 실측 도로망으로 경로를 찾는다</a:t>
+              <a:t>경로 중 폭 4m 미만 구간을 빨간 점선으로 표시</a:t>
             </a:r>
             <a:endParaRPr lang="en-US" sz="1050" dirty="0"/>
           </a:p>
@@ -14481,13 +14734,13 @@
       </p:sp>
       <p:sp>
         <p:nvSpPr>
-          <p:cNvPr id="45" name="Shape 43"/>
-          <p:cNvSpPr/>
-          <p:nvPr/>
-        </p:nvSpPr>
-        <p:spPr>
-          <a:xfrm>
-            <a:off x="7772400" y="3785616"/>
+          <p:cNvPr id="52" name="Shape 50"/>
+          <p:cNvSpPr/>
+          <p:nvPr/>
+        </p:nvSpPr>
+        <p:spPr>
+          <a:xfrm>
+            <a:off x="7772400" y="4809744"/>
             <a:ext cx="3840480" cy="932688"/>
           </a:xfrm>
           <a:prstGeom prst="roundRect">
@@ -14508,33 +14761,33 @@
       </p:sp>
       <p:sp>
         <p:nvSpPr>
-          <p:cNvPr id="46" name="Shape 44"/>
-          <p:cNvSpPr/>
-          <p:nvPr/>
-        </p:nvSpPr>
-        <p:spPr>
-          <a:xfrm>
-            <a:off x="7973568" y="4041648"/>
+          <p:cNvPr id="53" name="Shape 51"/>
+          <p:cNvSpPr/>
+          <p:nvPr/>
+        </p:nvSpPr>
+        <p:spPr>
+          <a:xfrm>
+            <a:off x="7973568" y="5065776"/>
             <a:ext cx="420624" cy="420624"/>
           </a:xfrm>
           <a:prstGeom prst="ellipse">
             <a:avLst/>
           </a:prstGeom>
           <a:solidFill>
-            <a:srgbClr val="DC2626"/>
-          </a:solidFill>
-          <a:ln/>
-        </p:spPr>
-      </p:sp>
-      <p:sp>
-        <p:nvSpPr>
-          <p:cNvPr id="47" name="Text 45"/>
-          <p:cNvSpPr/>
-          <p:nvPr/>
-        </p:nvSpPr>
-        <p:spPr>
-          <a:xfrm>
-            <a:off x="7973568" y="4041648"/>
+            <a:srgbClr val="7C3AED"/>
+          </a:solidFill>
+          <a:ln/>
+        </p:spPr>
+      </p:sp>
+      <p:sp>
+        <p:nvSpPr>
+          <p:cNvPr id="54" name="Text 52"/>
+          <p:cNvSpPr/>
+          <p:nvPr/>
+        </p:nvSpPr>
+        <p:spPr>
+          <a:xfrm>
+            <a:off x="7973568" y="5065776"/>
             <a:ext cx="420624" cy="420624"/>
           </a:xfrm>
           <a:prstGeom prst="rect">
@@ -14559,7 +14812,7 @@
                 <a:ea typeface="Consolas" pitchFamily="34" charset="-122"/>
                 <a:cs typeface="Consolas" pitchFamily="34" charset="-120"/>
               </a:rPr>
-              <a:t>3</a:t>
+              <a:t>4</a:t>
             </a:r>
             <a:endParaRPr lang="en-US" sz="1656" dirty="0"/>
           </a:p>
@@ -14567,13 +14820,13 @@
       </p:sp>
       <p:sp>
         <p:nvSpPr>
-          <p:cNvPr id="48" name="Text 46"/>
-          <p:cNvSpPr/>
-          <p:nvPr/>
-        </p:nvSpPr>
-        <p:spPr>
-          <a:xfrm>
-            <a:off x="8522208" y="3904488"/>
+          <p:cNvPr id="55" name="Text 53"/>
+          <p:cNvSpPr/>
+          <p:nvPr/>
+        </p:nvSpPr>
+        <p:spPr>
+          <a:xfrm>
+            <a:off x="8522208" y="4928616"/>
             <a:ext cx="3017520" cy="320040"/>
           </a:xfrm>
           <a:prstGeom prst="rect">
@@ -14592,13 +14845,13 @@
             <a:r>
               <a:rPr lang="en-US" sz="1300" b="1" dirty="0">
                 <a:solidFill>
-                  <a:srgbClr val="DC2626"/>
-                </a:solidFill>
-                <a:latin typeface="Malgun Gothic" pitchFamily="34" charset="0"/>
-                <a:ea typeface="Malgun Gothic" pitchFamily="34" charset="-122"/>
-                <a:cs typeface="Malgun Gothic" pitchFamily="34" charset="-120"/>
-              </a:rPr>
-              <a:t>빨간선 = 진입불가</a:t>
+                  <a:srgbClr val="7C3AED"/>
+                </a:solidFill>
+                <a:latin typeface="Malgun Gothic" pitchFamily="34" charset="0"/>
+                <a:ea typeface="Malgun Gothic" pitchFamily="34" charset="-122"/>
+                <a:cs typeface="Malgun Gothic" pitchFamily="34" charset="-120"/>
+              </a:rPr>
+              <a:t>드론 필요 지점</a:t>
             </a:r>
             <a:endParaRPr lang="en-US" sz="1300" dirty="0"/>
           </a:p>
@@ -14606,13 +14859,13 @@
       </p:sp>
       <p:sp>
         <p:nvSpPr>
-          <p:cNvPr id="49" name="Text 47"/>
-          <p:cNvSpPr/>
-          <p:nvPr/>
-        </p:nvSpPr>
-        <p:spPr>
-          <a:xfrm>
-            <a:off x="8522208" y="4215384"/>
+          <p:cNvPr id="56" name="Text 54"/>
+          <p:cNvSpPr/>
+          <p:nvPr/>
+        </p:nvSpPr>
+        <p:spPr>
+          <a:xfrm>
+            <a:off x="8522208" y="5239512"/>
             <a:ext cx="3017520" cy="457200"/>
           </a:xfrm>
           <a:prstGeom prst="rect">
@@ -14640,174 +14893,7 @@
                 <a:ea typeface="Malgun Gothic" pitchFamily="34" charset="-122"/>
                 <a:cs typeface="Malgun Gothic" pitchFamily="34" charset="-120"/>
               </a:rPr>
-              <a:t>경로 중 폭 4m 미만 구간을 빨간선으로 표시한다</a:t>
-            </a:r>
-            <a:endParaRPr lang="en-US" sz="1050" dirty="0"/>
-          </a:p>
-        </p:txBody>
-      </p:sp>
-      <p:sp>
-        <p:nvSpPr>
-          <p:cNvPr id="50" name="Shape 48"/>
-          <p:cNvSpPr/>
-          <p:nvPr/>
-        </p:nvSpPr>
-        <p:spPr>
-          <a:xfrm>
-            <a:off x="7772400" y="4809744"/>
-            <a:ext cx="3840480" cy="932688"/>
-          </a:xfrm>
-          <a:prstGeom prst="roundRect">
-            <a:avLst>
-              <a:gd name="adj" fmla="val 7843"/>
-            </a:avLst>
-          </a:prstGeom>
-          <a:solidFill>
-            <a:srgbClr val="F8FAFC"/>
-          </a:solidFill>
-          <a:ln w="12700">
-            <a:solidFill>
-              <a:srgbClr val="E2E8F0"/>
-            </a:solidFill>
-            <a:prstDash val="solid"/>
-          </a:ln>
-        </p:spPr>
-      </p:sp>
-      <p:sp>
-        <p:nvSpPr>
-          <p:cNvPr id="51" name="Shape 49"/>
-          <p:cNvSpPr/>
-          <p:nvPr/>
-        </p:nvSpPr>
-        <p:spPr>
-          <a:xfrm>
-            <a:off x="7973568" y="5065776"/>
-            <a:ext cx="420624" cy="420624"/>
-          </a:xfrm>
-          <a:prstGeom prst="ellipse">
-            <a:avLst/>
-          </a:prstGeom>
-          <a:solidFill>
-            <a:srgbClr val="7C3AED"/>
-          </a:solidFill>
-          <a:ln/>
-        </p:spPr>
-      </p:sp>
-      <p:sp>
-        <p:nvSpPr>
-          <p:cNvPr id="52" name="Text 50"/>
-          <p:cNvSpPr/>
-          <p:nvPr/>
-        </p:nvSpPr>
-        <p:spPr>
-          <a:xfrm>
-            <a:off x="7973568" y="5065776"/>
-            <a:ext cx="420624" cy="420624"/>
-          </a:xfrm>
-          <a:prstGeom prst="rect">
-            <a:avLst/>
-          </a:prstGeom>
-          <a:noFill/>
-          <a:ln/>
-        </p:spPr>
-        <p:txBody>
-          <a:bodyPr wrap="square" lIns="0" tIns="0" rIns="0" bIns="0" rtlCol="0" anchor="ctr"/>
-          <a:lstStyle/>
-          <a:p>
-            <a:pPr algn="ctr" indent="0" marL="0">
-              <a:buNone/>
-            </a:pPr>
-            <a:r>
-              <a:rPr lang="en-US" sz="1656" b="1" dirty="0">
-                <a:solidFill>
-                  <a:srgbClr val="FFFFFF"/>
-                </a:solidFill>
-                <a:latin typeface="Consolas" pitchFamily="34" charset="0"/>
-                <a:ea typeface="Consolas" pitchFamily="34" charset="-122"/>
-                <a:cs typeface="Consolas" pitchFamily="34" charset="-120"/>
-              </a:rPr>
-              <a:t>4</a:t>
-            </a:r>
-            <a:endParaRPr lang="en-US" sz="1656" dirty="0"/>
-          </a:p>
-        </p:txBody>
-      </p:sp>
-      <p:sp>
-        <p:nvSpPr>
-          <p:cNvPr id="53" name="Text 51"/>
-          <p:cNvSpPr/>
-          <p:nvPr/>
-        </p:nvSpPr>
-        <p:spPr>
-          <a:xfrm>
-            <a:off x="8522208" y="4928616"/>
-            <a:ext cx="3017520" cy="320040"/>
-          </a:xfrm>
-          <a:prstGeom prst="rect">
-            <a:avLst/>
-          </a:prstGeom>
-          <a:noFill/>
-          <a:ln/>
-        </p:spPr>
-        <p:txBody>
-          <a:bodyPr wrap="square" lIns="0" tIns="0" rIns="0" bIns="0" rtlCol="0" anchor="ctr"/>
-          <a:lstStyle/>
-          <a:p>
-            <a:pPr indent="0" marL="0">
-              <a:buNone/>
-            </a:pPr>
-            <a:r>
-              <a:rPr lang="en-US" sz="1300" b="1" dirty="0">
-                <a:solidFill>
-                  <a:srgbClr val="7C3AED"/>
-                </a:solidFill>
-                <a:latin typeface="Malgun Gothic" pitchFamily="34" charset="0"/>
-                <a:ea typeface="Malgun Gothic" pitchFamily="34" charset="-122"/>
-                <a:cs typeface="Malgun Gothic" pitchFamily="34" charset="-120"/>
-              </a:rPr>
-              <a:t>드론 필요 지점</a:t>
-            </a:r>
-            <a:endParaRPr lang="en-US" sz="1300" dirty="0"/>
-          </a:p>
-        </p:txBody>
-      </p:sp>
-      <p:sp>
-        <p:nvSpPr>
-          <p:cNvPr id="54" name="Text 52"/>
-          <p:cNvSpPr/>
-          <p:nvPr/>
-        </p:nvSpPr>
-        <p:spPr>
-          <a:xfrm>
-            <a:off x="8522208" y="5239512"/>
-            <a:ext cx="3017520" cy="457200"/>
-          </a:xfrm>
-          <a:prstGeom prst="rect">
-            <a:avLst/>
-          </a:prstGeom>
-          <a:noFill/>
-          <a:ln/>
-        </p:spPr>
-        <p:txBody>
-          <a:bodyPr wrap="square" lIns="0" tIns="0" rIns="0" bIns="0" rtlCol="0" anchor="t"/>
-          <a:lstStyle/>
-          <a:p>
-            <a:pPr indent="0" marL="0">
-              <a:lnSpc>
-                <a:spcPct val="105000"/>
-              </a:lnSpc>
-              <a:buNone/>
-            </a:pPr>
-            <a:r>
-              <a:rPr lang="en-US" sz="1050" dirty="0">
-                <a:solidFill>
-                  <a:srgbClr val="334155"/>
-                </a:solidFill>
-                <a:latin typeface="Malgun Gothic" pitchFamily="34" charset="0"/>
-                <a:ea typeface="Malgun Gothic" pitchFamily="34" charset="-122"/>
-                <a:cs typeface="Malgun Gothic" pitchFamily="34" charset="-120"/>
-              </a:rPr>
-              <a:t>빨간선이 걸린 화재지점 = 드론이 가장 필요한 곳</a:t>
+              <a:t>빨간 점선이 걸린 화재지점 = 드론이 가장 필요한 곳</a:t>
             </a:r>
             <a:endParaRPr lang="en-US" sz="1050" dirty="0"/>
           </a:p>

</xml_diff>

<commit_message>
Fix Korean single-char line-wrap orphans across the report deck
Korean wraps char-by-char, so slightly narrow fixed labels dropped a lone
trailing character to the next line. Hard-wrap the affected fixed-width texts
at natural points so lines break cleanly: data-source cards, Changwon
by-district read notes, STEP04 map steps, SOP-D 5 phases, UGV roles,
impact stat descriptions, and the 3-aspect impact cards.

Co-Authored-By: Claude Opus 4.8 <noreply@anthropic.com>
Claude-Session: https://claude.ai/code/session_01TYua8MWbjkcnNvFDubmny6
</commit_message>
<xml_diff>
--- a/presentation/화재빅데이터_드론배치_분석리포트.pptx
+++ b/presentation/화재빅데이터_드론배치_분석리포트.pptx
@@ -6174,7 +6174,27 @@
                 <a:ea typeface="Malgun Gothic" pitchFamily="34" charset="-122"/>
                 <a:cs typeface="Malgun Gothic" pitchFamily="34" charset="-120"/>
               </a:rPr>
-              <a:t>정찰·진압·구조 편대 전개·상승</a:t>
+              <a:t>정찰·진압·구조</a:t>
+            </a:r>
+            <a:endParaRPr lang="en-US" sz="1050" dirty="0"/>
+          </a:p>
+          <a:p>
+            <a:pPr algn="ctr" indent="0" marL="0">
+              <a:lnSpc>
+                <a:spcPct val="118000"/>
+              </a:lnSpc>
+              <a:buNone/>
+            </a:pPr>
+            <a:r>
+              <a:rPr lang="en-US" sz="1050" dirty="0">
+                <a:solidFill>
+                  <a:srgbClr val="334155"/>
+                </a:solidFill>
+                <a:latin typeface="Malgun Gothic" pitchFamily="34" charset="0"/>
+                <a:ea typeface="Malgun Gothic" pitchFamily="34" charset="-122"/>
+                <a:cs typeface="Malgun Gothic" pitchFamily="34" charset="-120"/>
+              </a:rPr>
+              <a:t>편대 전개·상승</a:t>
             </a:r>
             <a:endParaRPr lang="en-US" sz="1050" dirty="0"/>
           </a:p>
@@ -6465,7 +6485,27 @@
                 <a:ea typeface="Malgun Gothic" pitchFamily="34" charset="-122"/>
                 <a:cs typeface="Malgun Gothic" pitchFamily="34" charset="-120"/>
               </a:rPr>
-              <a:t>3D 스캐닝·열화상 화점/진입점 파악</a:t>
+              <a:t>3D 스캐닝·열화상</a:t>
+            </a:r>
+            <a:endParaRPr lang="en-US" sz="1050" dirty="0"/>
+          </a:p>
+          <a:p>
+            <a:pPr algn="ctr" indent="0" marL="0">
+              <a:lnSpc>
+                <a:spcPct val="118000"/>
+              </a:lnSpc>
+              <a:buNone/>
+            </a:pPr>
+            <a:r>
+              <a:rPr lang="en-US" sz="1050" dirty="0">
+                <a:solidFill>
+                  <a:srgbClr val="334155"/>
+                </a:solidFill>
+                <a:latin typeface="Malgun Gothic" pitchFamily="34" charset="0"/>
+                <a:ea typeface="Malgun Gothic" pitchFamily="34" charset="-122"/>
+                <a:cs typeface="Malgun Gothic" pitchFamily="34" charset="-120"/>
+              </a:rPr>
+              <a:t>화점/진입점 파악</a:t>
             </a:r>
             <a:endParaRPr lang="en-US" sz="1050" dirty="0"/>
           </a:p>
@@ -6756,7 +6796,27 @@
                 <a:ea typeface="Malgun Gothic" pitchFamily="34" charset="-122"/>
                 <a:cs typeface="Malgun Gothic" pitchFamily="34" charset="-120"/>
               </a:rPr>
-              <a:t>창문 파쇄 후 정밀 소화탄 · 대피 인도</a:t>
+              <a:t>창문 파쇄 후</a:t>
+            </a:r>
+            <a:endParaRPr lang="en-US" sz="1050" dirty="0"/>
+          </a:p>
+          <a:p>
+            <a:pPr algn="ctr" indent="0" marL="0">
+              <a:lnSpc>
+                <a:spcPct val="118000"/>
+              </a:lnSpc>
+              <a:buNone/>
+            </a:pPr>
+            <a:r>
+              <a:rPr lang="en-US" sz="1050" dirty="0">
+                <a:solidFill>
+                  <a:srgbClr val="334155"/>
+                </a:solidFill>
+                <a:latin typeface="Malgun Gothic" pitchFamily="34" charset="0"/>
+                <a:ea typeface="Malgun Gothic" pitchFamily="34" charset="-122"/>
+                <a:cs typeface="Malgun Gothic" pitchFamily="34" charset="-120"/>
+              </a:rPr>
+              <a:t>정밀 소화탄·대피 인도</a:t>
             </a:r>
             <a:endParaRPr lang="en-US" sz="1050" dirty="0"/>
           </a:p>
@@ -7047,7 +7107,27 @@
                 <a:ea typeface="Malgun Gothic" pitchFamily="34" charset="-122"/>
                 <a:cs typeface="Malgun Gothic" pitchFamily="34" charset="-120"/>
               </a:rPr>
-              <a:t>요구조자 호위 · 외벽 연소차단 · 배터리 릴레이</a:t>
+              <a:t>요구조자 호위</a:t>
+            </a:r>
+            <a:endParaRPr lang="en-US" sz="1050" dirty="0"/>
+          </a:p>
+          <a:p>
+            <a:pPr algn="ctr" indent="0" marL="0">
+              <a:lnSpc>
+                <a:spcPct val="118000"/>
+              </a:lnSpc>
+              <a:buNone/>
+            </a:pPr>
+            <a:r>
+              <a:rPr lang="en-US" sz="1050" dirty="0">
+                <a:solidFill>
+                  <a:srgbClr val="334155"/>
+                </a:solidFill>
+                <a:latin typeface="Malgun Gothic" pitchFamily="34" charset="0"/>
+                <a:ea typeface="Malgun Gothic" pitchFamily="34" charset="-122"/>
+                <a:cs typeface="Malgun Gothic" pitchFamily="34" charset="-120"/>
+              </a:rPr>
+              <a:t>외벽 연소차단·릴레이</a:t>
             </a:r>
             <a:endParaRPr lang="en-US" sz="1050" dirty="0"/>
           </a:p>
@@ -7338,7 +7418,27 @@
                 <a:ea typeface="Malgun Gothic" pitchFamily="34" charset="-122"/>
                 <a:cs typeface="Malgun Gothic" pitchFamily="34" charset="-120"/>
               </a:rPr>
-              <a:t>대피 완료 확인 · 잔불 감시 · RTH</a:t>
+              <a:t>대피 완료 확인</a:t>
+            </a:r>
+            <a:endParaRPr lang="en-US" sz="1050" dirty="0"/>
+          </a:p>
+          <a:p>
+            <a:pPr algn="ctr" indent="0" marL="0">
+              <a:lnSpc>
+                <a:spcPct val="118000"/>
+              </a:lnSpc>
+              <a:buNone/>
+            </a:pPr>
+            <a:r>
+              <a:rPr lang="en-US" sz="1050" dirty="0">
+                <a:solidFill>
+                  <a:srgbClr val="334155"/>
+                </a:solidFill>
+                <a:latin typeface="Malgun Gothic" pitchFamily="34" charset="0"/>
+                <a:ea typeface="Malgun Gothic" pitchFamily="34" charset="-122"/>
+                <a:cs typeface="Malgun Gothic" pitchFamily="34" charset="-120"/>
+              </a:rPr>
+              <a:t>잔불 감시·RTH</a:t>
             </a:r>
             <a:endParaRPr lang="en-US" sz="1050" dirty="0"/>
           </a:p>
@@ -7663,7 +7763,27 @@
                 <a:ea typeface="Malgun Gothic" pitchFamily="34" charset="-122"/>
                 <a:cs typeface="Malgun Gothic" pitchFamily="34" charset="-120"/>
               </a:rPr>
-              <a:t>장애물 극복 · 소화수 보급 · 스마트 방재 거점에서 출발·재보급</a:t>
+              <a:t>장애물 극복·소화수 보급 ·</a:t>
+            </a:r>
+            <a:endParaRPr lang="en-US" sz="1250" dirty="0"/>
+          </a:p>
+          <a:p>
+            <a:pPr indent="0" marL="0">
+              <a:lnSpc>
+                <a:spcPct val="130000"/>
+              </a:lnSpc>
+              <a:buNone/>
+            </a:pPr>
+            <a:r>
+              <a:rPr lang="en-US" sz="1250" dirty="0">
+                <a:solidFill>
+                  <a:srgbClr val="334155"/>
+                </a:solidFill>
+                <a:latin typeface="Malgun Gothic" pitchFamily="34" charset="0"/>
+                <a:ea typeface="Malgun Gothic" pitchFamily="34" charset="-122"/>
+                <a:cs typeface="Malgun Gothic" pitchFamily="34" charset="-120"/>
+              </a:rPr>
+              <a:t>스마트 방재 거점에서 출발·재보급</a:t>
             </a:r>
             <a:endParaRPr lang="en-US" sz="1250" dirty="0"/>
           </a:p>
@@ -7800,7 +7920,27 @@
                 <a:ea typeface="Malgun Gothic" pitchFamily="34" charset="-122"/>
                 <a:cs typeface="Malgun Gothic" pitchFamily="34" charset="-120"/>
               </a:rPr>
-              <a:t>상공에서 정밀 정찰·진압 — 골목 위를 그대로 넘는다</a:t>
+              <a:t>상공에서 정밀 정찰·진압 —</a:t>
+            </a:r>
+            <a:endParaRPr lang="en-US" sz="1250" dirty="0"/>
+          </a:p>
+          <a:p>
+            <a:pPr indent="0" marL="0">
+              <a:lnSpc>
+                <a:spcPct val="130000"/>
+              </a:lnSpc>
+              <a:buNone/>
+            </a:pPr>
+            <a:r>
+              <a:rPr lang="en-US" sz="1250" dirty="0">
+                <a:solidFill>
+                  <a:srgbClr val="334155"/>
+                </a:solidFill>
+                <a:latin typeface="Malgun Gothic" pitchFamily="34" charset="0"/>
+                <a:ea typeface="Malgun Gothic" pitchFamily="34" charset="-122"/>
+                <a:cs typeface="Malgun Gothic" pitchFamily="34" charset="-120"/>
+              </a:rPr>
+              <a:t>골목 위를 그대로 넘는다</a:t>
             </a:r>
             <a:endParaRPr lang="en-US" sz="1250" dirty="0"/>
           </a:p>
@@ -7937,7 +8077,27 @@
                 <a:ea typeface="Malgun Gothic" pitchFamily="34" charset="-122"/>
                 <a:cs typeface="Malgun Gothic" pitchFamily="34" charset="-120"/>
               </a:rPr>
-              <a:t>UGV는 지상 보급·거점, 드론은 공중 타격 — 상호 통신으로 한 편대처럼</a:t>
+              <a:t>UGV는 지상 보급·거점,</a:t>
+            </a:r>
+            <a:endParaRPr lang="en-US" sz="1250" dirty="0"/>
+          </a:p>
+          <a:p>
+            <a:pPr indent="0" marL="0">
+              <a:lnSpc>
+                <a:spcPct val="130000"/>
+              </a:lnSpc>
+              <a:buNone/>
+            </a:pPr>
+            <a:r>
+              <a:rPr lang="en-US" sz="1250" dirty="0">
+                <a:solidFill>
+                  <a:srgbClr val="334155"/>
+                </a:solidFill>
+                <a:latin typeface="Malgun Gothic" pitchFamily="34" charset="0"/>
+                <a:ea typeface="Malgun Gothic" pitchFamily="34" charset="-122"/>
+                <a:cs typeface="Malgun Gothic" pitchFamily="34" charset="-120"/>
+              </a:rPr>
+              <a:t>드론은 공중 타격 — 한 편대처럼</a:t>
             </a:r>
             <a:endParaRPr lang="en-US" sz="1250" dirty="0"/>
           </a:p>
@@ -9348,7 +9508,27 @@
                 <a:ea typeface="Malgun Gothic" pitchFamily="34" charset="-122"/>
                 <a:cs typeface="Malgun Gothic" pitchFamily="34" charset="-120"/>
               </a:rPr>
-              <a:t>도착 5분 → 5~10분 (건당 5,425 → 11,198천원)</a:t>
+              <a:t>도착 5분 → 5~10분</a:t>
+            </a:r>
+            <a:endParaRPr lang="en-US" sz="1050" dirty="0"/>
+          </a:p>
+          <a:p>
+            <a:pPr indent="0" marL="0">
+              <a:lnSpc>
+                <a:spcPct val="115000"/>
+              </a:lnSpc>
+              <a:buNone/>
+            </a:pPr>
+            <a:r>
+              <a:rPr lang="en-US" sz="1050" dirty="0">
+                <a:solidFill>
+                  <a:srgbClr val="334155"/>
+                </a:solidFill>
+                <a:latin typeface="Malgun Gothic" pitchFamily="34" charset="0"/>
+                <a:ea typeface="Malgun Gothic" pitchFamily="34" charset="-122"/>
+                <a:cs typeface="Malgun Gothic" pitchFamily="34" charset="-120"/>
+              </a:rPr>
+              <a:t>(건당 5,425 → 11,198천원)</a:t>
             </a:r>
             <a:endParaRPr lang="en-US" sz="1050" dirty="0"/>
           </a:p>
@@ -9522,7 +9702,27 @@
                 <a:ea typeface="Malgun Gothic" pitchFamily="34" charset="-122"/>
                 <a:cs typeface="Malgun Gothic" pitchFamily="34" charset="-120"/>
               </a:rPr>
-              <a:t>현장도착 10분 초과 시 (10분 이하 대비)</a:t>
+              <a:t>현장도착 10분 초과 시</a:t>
+            </a:r>
+            <a:endParaRPr lang="en-US" sz="1050" dirty="0"/>
+          </a:p>
+          <a:p>
+            <a:pPr indent="0" marL="0">
+              <a:lnSpc>
+                <a:spcPct val="115000"/>
+              </a:lnSpc>
+              <a:buNone/>
+            </a:pPr>
+            <a:r>
+              <a:rPr lang="en-US" sz="1050" dirty="0">
+                <a:solidFill>
+                  <a:srgbClr val="334155"/>
+                </a:solidFill>
+                <a:latin typeface="Malgun Gothic" pitchFamily="34" charset="0"/>
+                <a:ea typeface="Malgun Gothic" pitchFamily="34" charset="-122"/>
+                <a:cs typeface="Malgun Gothic" pitchFamily="34" charset="-120"/>
+              </a:rPr>
+              <a:t>(10분 이하 대비)</a:t>
             </a:r>
             <a:endParaRPr lang="en-US" sz="1050" dirty="0"/>
           </a:p>
@@ -9696,7 +9896,27 @@
                 <a:ea typeface="Malgun Gothic" pitchFamily="34" charset="-122"/>
                 <a:cs typeface="Malgun Gothic" pitchFamily="34" charset="-120"/>
               </a:rPr>
-              <a:t>5분 이내 골든타임 확보 시</a:t>
+              <a:t>5분 이내</a:t>
+            </a:r>
+            <a:endParaRPr lang="en-US" sz="1050" dirty="0"/>
+          </a:p>
+          <a:p>
+            <a:pPr indent="0" marL="0">
+              <a:lnSpc>
+                <a:spcPct val="115000"/>
+              </a:lnSpc>
+              <a:buNone/>
+            </a:pPr>
+            <a:r>
+              <a:rPr lang="en-US" sz="1050" dirty="0">
+                <a:solidFill>
+                  <a:srgbClr val="334155"/>
+                </a:solidFill>
+                <a:latin typeface="Malgun Gothic" pitchFamily="34" charset="0"/>
+                <a:ea typeface="Malgun Gothic" pitchFamily="34" charset="-122"/>
+                <a:cs typeface="Malgun Gothic" pitchFamily="34" charset="-120"/>
+              </a:rPr>
+              <a:t>골든타임 확보 시</a:t>
             </a:r>
             <a:endParaRPr lang="en-US" sz="1050" dirty="0"/>
           </a:p>
@@ -10108,7 +10328,27 @@
                 <a:ea typeface="Malgun Gothic" pitchFamily="34" charset="-122"/>
                 <a:cs typeface="Malgun Gothic" pitchFamily="34" charset="-120"/>
               </a:rPr>
-              <a:t>기계공학 제어·역학 + 국방과학 자율 군집 운용의 고가치 융합 사례</a:t>
+              <a:t>기계공학 제어·역학과</a:t>
+            </a:r>
+            <a:endParaRPr lang="en-US" sz="1150" dirty="0"/>
+          </a:p>
+          <a:p>
+            <a:pPr indent="0" marL="0">
+              <a:lnSpc>
+                <a:spcPct val="125000"/>
+              </a:lnSpc>
+              <a:buNone/>
+            </a:pPr>
+            <a:r>
+              <a:rPr lang="en-US" sz="1150" dirty="0">
+                <a:solidFill>
+                  <a:srgbClr val="94A3B8"/>
+                </a:solidFill>
+                <a:latin typeface="Malgun Gothic" pitchFamily="34" charset="0"/>
+                <a:ea typeface="Malgun Gothic" pitchFamily="34" charset="-122"/>
+                <a:cs typeface="Malgun Gothic" pitchFamily="34" charset="-120"/>
+              </a:rPr>
+              <a:t>국방과학 자율 군집 운용의 융합</a:t>
             </a:r>
             <a:endParaRPr lang="en-US" sz="1150" dirty="0"/>
           </a:p>
@@ -10285,7 +10525,27 @@
                 <a:ea typeface="Malgun Gothic" pitchFamily="34" charset="-122"/>
                 <a:cs typeface="Malgun Gothic" pitchFamily="34" charset="-120"/>
               </a:rPr>
-              <a:t>진입불가 골목도 5분 내 초동 대응 → 재산피해 약 52%↓·인명 위험 대폭 감소</a:t>
+              <a:t>진입불가 골목도 5분 내 초동 대응</a:t>
+            </a:r>
+            <a:endParaRPr lang="en-US" sz="1150" dirty="0"/>
+          </a:p>
+          <a:p>
+            <a:pPr indent="0" marL="0">
+              <a:lnSpc>
+                <a:spcPct val="125000"/>
+              </a:lnSpc>
+              <a:buNone/>
+            </a:pPr>
+            <a:r>
+              <a:rPr lang="en-US" sz="1150" dirty="0">
+                <a:solidFill>
+                  <a:srgbClr val="94A3B8"/>
+                </a:solidFill>
+                <a:latin typeface="Malgun Gothic" pitchFamily="34" charset="0"/>
+                <a:ea typeface="Malgun Gothic" pitchFamily="34" charset="-122"/>
+                <a:cs typeface="Malgun Gothic" pitchFamily="34" charset="-120"/>
+              </a:rPr>
+              <a:t>→ 재산피해 약 52%↓·인명 위험 감소</a:t>
             </a:r>
             <a:endParaRPr lang="en-US" sz="1150" dirty="0"/>
           </a:p>
@@ -10462,7 +10722,27 @@
                 <a:ea typeface="Malgun Gothic" pitchFamily="34" charset="-122"/>
                 <a:cs typeface="Malgun Gothic" pitchFamily="34" charset="-120"/>
               </a:rPr>
-              <a:t>방위산업·항공우주 인프라를 스마트시티에 결합한 지역 특화 혁신</a:t>
+              <a:t>방위산업·항공우주 인프라를</a:t>
+            </a:r>
+            <a:endParaRPr lang="en-US" sz="1150" dirty="0"/>
+          </a:p>
+          <a:p>
+            <a:pPr indent="0" marL="0">
+              <a:lnSpc>
+                <a:spcPct val="125000"/>
+              </a:lnSpc>
+              <a:buNone/>
+            </a:pPr>
+            <a:r>
+              <a:rPr lang="en-US" sz="1150" dirty="0">
+                <a:solidFill>
+                  <a:srgbClr val="94A3B8"/>
+                </a:solidFill>
+                <a:latin typeface="Malgun Gothic" pitchFamily="34" charset="0"/>
+                <a:ea typeface="Malgun Gothic" pitchFamily="34" charset="-122"/>
+                <a:cs typeface="Malgun Gothic" pitchFamily="34" charset="-120"/>
+              </a:rPr>
+              <a:t>스마트시티에 결합한 지역 특화 혁신</a:t>
             </a:r>
             <a:endParaRPr lang="en-US" sz="1150" dirty="0"/>
           </a:p>
@@ -11448,7 +11728,27 @@
                 <a:ea typeface="Malgun Gothic" pitchFamily="34" charset="-122"/>
                 <a:cs typeface="Malgun Gothic" pitchFamily="34" charset="-120"/>
               </a:rPr>
-              <a:t>최근 1년 시·군구별 화재 건수</a:t>
+              <a:t>최근 1년 시·군구별</a:t>
+            </a:r>
+            <a:endParaRPr lang="en-US" sz="1150" dirty="0"/>
+          </a:p>
+          <a:p>
+            <a:pPr indent="0" marL="0">
+              <a:lnSpc>
+                <a:spcPct val="120000"/>
+              </a:lnSpc>
+              <a:buNone/>
+            </a:pPr>
+            <a:r>
+              <a:rPr lang="en-US" sz="1150" dirty="0">
+                <a:solidFill>
+                  <a:srgbClr val="334155"/>
+                </a:solidFill>
+                <a:latin typeface="Malgun Gothic" pitchFamily="34" charset="0"/>
+                <a:ea typeface="Malgun Gothic" pitchFamily="34" charset="-122"/>
+                <a:cs typeface="Malgun Gothic" pitchFamily="34" charset="-120"/>
+              </a:rPr>
+              <a:t>화재 건수</a:t>
             </a:r>
             <a:endParaRPr lang="en-US" sz="1150" dirty="0"/>
           </a:p>
@@ -11630,7 +11930,27 @@
                 <a:ea typeface="Malgun Gothic" pitchFamily="34" charset="-122"/>
                 <a:cs typeface="Malgun Gothic" pitchFamily="34" charset="-120"/>
               </a:rPr>
-              <a:t>골목 폭 · 소방차 진입 가능성</a:t>
+              <a:t>골목 폭·소방차</a:t>
+            </a:r>
+            <a:endParaRPr lang="en-US" sz="1150" dirty="0"/>
+          </a:p>
+          <a:p>
+            <a:pPr indent="0" marL="0">
+              <a:lnSpc>
+                <a:spcPct val="120000"/>
+              </a:lnSpc>
+              <a:buNone/>
+            </a:pPr>
+            <a:r>
+              <a:rPr lang="en-US" sz="1150" dirty="0">
+                <a:solidFill>
+                  <a:srgbClr val="334155"/>
+                </a:solidFill>
+                <a:latin typeface="Malgun Gothic" pitchFamily="34" charset="0"/>
+                <a:ea typeface="Malgun Gothic" pitchFamily="34" charset="-122"/>
+                <a:cs typeface="Malgun Gothic" pitchFamily="34" charset="-120"/>
+              </a:rPr>
+              <a:t>진입 가능성</a:t>
             </a:r>
             <a:endParaRPr lang="en-US" sz="1150" dirty="0"/>
           </a:p>
@@ -11812,7 +12132,27 @@
                 <a:ea typeface="Malgun Gothic" pitchFamily="34" charset="-122"/>
                 <a:cs typeface="Malgun Gothic" pitchFamily="34" charset="-120"/>
               </a:rPr>
-              <a:t>노후 건축물 비율 → 취약 지수</a:t>
+              <a:t>노후 건축물 비율</a:t>
+            </a:r>
+            <a:endParaRPr lang="en-US" sz="1150" dirty="0"/>
+          </a:p>
+          <a:p>
+            <a:pPr indent="0" marL="0">
+              <a:lnSpc>
+                <a:spcPct val="120000"/>
+              </a:lnSpc>
+              <a:buNone/>
+            </a:pPr>
+            <a:r>
+              <a:rPr lang="en-US" sz="1150" dirty="0">
+                <a:solidFill>
+                  <a:srgbClr val="334155"/>
+                </a:solidFill>
+                <a:latin typeface="Malgun Gothic" pitchFamily="34" charset="0"/>
+                <a:ea typeface="Malgun Gothic" pitchFamily="34" charset="-122"/>
+                <a:cs typeface="Malgun Gothic" pitchFamily="34" charset="-120"/>
+              </a:rPr>
+              <a:t>→ 취약 지수</a:t>
             </a:r>
             <a:endParaRPr lang="en-US" sz="1150" dirty="0"/>
           </a:p>
@@ -11994,7 +12334,27 @@
                 <a:ea typeface="Malgun Gothic" pitchFamily="34" charset="-122"/>
                 <a:cs typeface="Malgun Gothic" pitchFamily="34" charset="-120"/>
               </a:rPr>
-              <a:t>65세+ 교통약자 밀집 지역</a:t>
+              <a:t>65세+ 교통약자</a:t>
+            </a:r>
+            <a:endParaRPr lang="en-US" sz="1150" dirty="0"/>
+          </a:p>
+          <a:p>
+            <a:pPr indent="0" marL="0">
+              <a:lnSpc>
+                <a:spcPct val="120000"/>
+              </a:lnSpc>
+              <a:buNone/>
+            </a:pPr>
+            <a:r>
+              <a:rPr lang="en-US" sz="1150" dirty="0">
+                <a:solidFill>
+                  <a:srgbClr val="334155"/>
+                </a:solidFill>
+                <a:latin typeface="Malgun Gothic" pitchFamily="34" charset="0"/>
+                <a:ea typeface="Malgun Gothic" pitchFamily="34" charset="-122"/>
+                <a:cs typeface="Malgun Gothic" pitchFamily="34" charset="-120"/>
+              </a:rPr>
+              <a:t>밀집 지역</a:t>
             </a:r>
             <a:endParaRPr lang="en-US" sz="1150" dirty="0"/>
           </a:p>
@@ -12176,7 +12536,27 @@
                 <a:ea typeface="Malgun Gothic" pitchFamily="34" charset="-122"/>
                 <a:cs typeface="Malgun Gothic" pitchFamily="34" charset="-120"/>
               </a:rPr>
-              <a:t>소화전 · 진입곤란 구간 현황</a:t>
+              <a:t>소화전·진입곤란</a:t>
+            </a:r>
+            <a:endParaRPr lang="en-US" sz="1150" dirty="0"/>
+          </a:p>
+          <a:p>
+            <a:pPr indent="0" marL="0">
+              <a:lnSpc>
+                <a:spcPct val="120000"/>
+              </a:lnSpc>
+              <a:buNone/>
+            </a:pPr>
+            <a:r>
+              <a:rPr lang="en-US" sz="1150" dirty="0">
+                <a:solidFill>
+                  <a:srgbClr val="334155"/>
+                </a:solidFill>
+                <a:latin typeface="Malgun Gothic" pitchFamily="34" charset="0"/>
+                <a:ea typeface="Malgun Gothic" pitchFamily="34" charset="-122"/>
+                <a:cs typeface="Malgun Gothic" pitchFamily="34" charset="-120"/>
+              </a:rPr>
+              <a:t>구간 현황</a:t>
             </a:r>
             <a:endParaRPr lang="en-US" sz="1150" dirty="0"/>
           </a:p>
@@ -12934,7 +13314,7 @@
         </p:nvSpPr>
         <p:spPr>
           <a:xfrm>
-            <a:off x="8138160" y="2542032"/>
+            <a:off x="8138160" y="2487168"/>
             <a:ext cx="137160" cy="137160"/>
           </a:xfrm>
           <a:prstGeom prst="ellipse">
@@ -12954,8 +13334,8 @@
         </p:nvSpPr>
         <p:spPr>
           <a:xfrm>
-            <a:off x="8412480" y="2395728"/>
-            <a:ext cx="3017520" cy="548640"/>
+            <a:off x="8412480" y="2286000"/>
+            <a:ext cx="3017520" cy="566928"/>
           </a:xfrm>
           <a:prstGeom prst="rect">
             <a:avLst/>
@@ -12982,52 +13362,10 @@
                 <a:ea typeface="Malgun Gothic" pitchFamily="34" charset="-122"/>
                 <a:cs typeface="Malgun Gothic" pitchFamily="34" charset="-120"/>
               </a:rPr>
-              <a:t>구별 화재건수는 88~126건으로 비슷</a:t>
+              <a:t>구별 화재건수는</a:t>
             </a:r>
             <a:endParaRPr lang="en-US" sz="1200" dirty="0"/>
           </a:p>
-        </p:txBody>
-      </p:sp>
-      <p:sp>
-        <p:nvSpPr>
-          <p:cNvPr id="10" name="Shape 7"/>
-          <p:cNvSpPr/>
-          <p:nvPr/>
-        </p:nvSpPr>
-        <p:spPr>
-          <a:xfrm>
-            <a:off x="8138160" y="3108960"/>
-            <a:ext cx="137160" cy="137160"/>
-          </a:xfrm>
-          <a:prstGeom prst="ellipse">
-            <a:avLst/>
-          </a:prstGeom>
-          <a:solidFill>
-            <a:srgbClr val="EA580C"/>
-          </a:solidFill>
-          <a:ln/>
-        </p:spPr>
-      </p:sp>
-      <p:sp>
-        <p:nvSpPr>
-          <p:cNvPr id="11" name="Text 8"/>
-          <p:cNvSpPr/>
-          <p:nvPr/>
-        </p:nvSpPr>
-        <p:spPr>
-          <a:xfrm>
-            <a:off x="8412480" y="2962656"/>
-            <a:ext cx="3017520" cy="548640"/>
-          </a:xfrm>
-          <a:prstGeom prst="rect">
-            <a:avLst/>
-          </a:prstGeom>
-          <a:noFill/>
-          <a:ln/>
-        </p:spPr>
-        <p:txBody>
-          <a:bodyPr wrap="square" lIns="0" tIns="0" rIns="0" bIns="0" rtlCol="0" anchor="ctr"/>
-          <a:lstStyle/>
           <a:p>
             <a:pPr indent="0" marL="0">
               <a:lnSpc>
@@ -13044,7 +13382,7 @@
                 <a:ea typeface="Malgun Gothic" pitchFamily="34" charset="-122"/>
                 <a:cs typeface="Malgun Gothic" pitchFamily="34" charset="-120"/>
               </a:rPr>
-              <a:t>차이는 도로·노후·인명피해에서 갈린다</a:t>
+              <a:t>88~126건으로 비슷</a:t>
             </a:r>
             <a:endParaRPr lang="en-US" sz="1200" dirty="0"/>
           </a:p>
@@ -13052,13 +13390,13 @@
       </p:sp>
       <p:sp>
         <p:nvSpPr>
-          <p:cNvPr id="12" name="Shape 9"/>
-          <p:cNvSpPr/>
-          <p:nvPr/>
-        </p:nvSpPr>
-        <p:spPr>
-          <a:xfrm>
-            <a:off x="8138160" y="3675888"/>
+          <p:cNvPr id="10" name="Shape 7"/>
+          <p:cNvSpPr/>
+          <p:nvPr/>
+        </p:nvSpPr>
+        <p:spPr>
+          <a:xfrm>
+            <a:off x="8138160" y="3054096"/>
             <a:ext cx="137160" cy="137160"/>
           </a:xfrm>
           <a:prstGeom prst="ellipse">
@@ -13072,14 +13410,14 @@
       </p:sp>
       <p:sp>
         <p:nvSpPr>
-          <p:cNvPr id="13" name="Text 10"/>
-          <p:cNvSpPr/>
-          <p:nvPr/>
-        </p:nvSpPr>
-        <p:spPr>
-          <a:xfrm>
-            <a:off x="8412480" y="3529584"/>
-            <a:ext cx="3017520" cy="548640"/>
+          <p:cNvPr id="11" name="Text 8"/>
+          <p:cNvSpPr/>
+          <p:nvPr/>
+        </p:nvSpPr>
+        <p:spPr>
+          <a:xfrm>
+            <a:off x="8412480" y="2852928"/>
+            <a:ext cx="3017520" cy="566928"/>
           </a:xfrm>
           <a:prstGeom prst="rect">
             <a:avLst/>
@@ -13106,7 +13444,109 @@
                 <a:ea typeface="Malgun Gothic" pitchFamily="34" charset="-122"/>
                 <a:cs typeface="Malgun Gothic" pitchFamily="34" charset="-120"/>
               </a:rPr>
-              <a:t>마산합포구는 인명피해가 창원 최다</a:t>
+              <a:t>차이는 도로·노후·</a:t>
+            </a:r>
+            <a:endParaRPr lang="en-US" sz="1200" dirty="0"/>
+          </a:p>
+          <a:p>
+            <a:pPr indent="0" marL="0">
+              <a:lnSpc>
+                <a:spcPct val="110000"/>
+              </a:lnSpc>
+              <a:buNone/>
+            </a:pPr>
+            <a:r>
+              <a:rPr lang="en-US" sz="1200" dirty="0">
+                <a:solidFill>
+                  <a:srgbClr val="334155"/>
+                </a:solidFill>
+                <a:latin typeface="Malgun Gothic" pitchFamily="34" charset="0"/>
+                <a:ea typeface="Malgun Gothic" pitchFamily="34" charset="-122"/>
+                <a:cs typeface="Malgun Gothic" pitchFamily="34" charset="-120"/>
+              </a:rPr>
+              <a:t>인명피해에서 갈린다</a:t>
+            </a:r>
+            <a:endParaRPr lang="en-US" sz="1200" dirty="0"/>
+          </a:p>
+        </p:txBody>
+      </p:sp>
+      <p:sp>
+        <p:nvSpPr>
+          <p:cNvPr id="12" name="Shape 9"/>
+          <p:cNvSpPr/>
+          <p:nvPr/>
+        </p:nvSpPr>
+        <p:spPr>
+          <a:xfrm>
+            <a:off x="8138160" y="3621024"/>
+            <a:ext cx="137160" cy="137160"/>
+          </a:xfrm>
+          <a:prstGeom prst="ellipse">
+            <a:avLst/>
+          </a:prstGeom>
+          <a:solidFill>
+            <a:srgbClr val="EA580C"/>
+          </a:solidFill>
+          <a:ln/>
+        </p:spPr>
+      </p:sp>
+      <p:sp>
+        <p:nvSpPr>
+          <p:cNvPr id="13" name="Text 10"/>
+          <p:cNvSpPr/>
+          <p:nvPr/>
+        </p:nvSpPr>
+        <p:spPr>
+          <a:xfrm>
+            <a:off x="8412480" y="3419856"/>
+            <a:ext cx="3017520" cy="566928"/>
+          </a:xfrm>
+          <a:prstGeom prst="rect">
+            <a:avLst/>
+          </a:prstGeom>
+          <a:noFill/>
+          <a:ln/>
+        </p:spPr>
+        <p:txBody>
+          <a:bodyPr wrap="square" lIns="0" tIns="0" rIns="0" bIns="0" rtlCol="0" anchor="ctr"/>
+          <a:lstStyle/>
+          <a:p>
+            <a:pPr indent="0" marL="0">
+              <a:lnSpc>
+                <a:spcPct val="110000"/>
+              </a:lnSpc>
+              <a:buNone/>
+            </a:pPr>
+            <a:r>
+              <a:rPr lang="en-US" sz="1200" dirty="0">
+                <a:solidFill>
+                  <a:srgbClr val="334155"/>
+                </a:solidFill>
+                <a:latin typeface="Malgun Gothic" pitchFamily="34" charset="0"/>
+                <a:ea typeface="Malgun Gothic" pitchFamily="34" charset="-122"/>
+                <a:cs typeface="Malgun Gothic" pitchFamily="34" charset="-120"/>
+              </a:rPr>
+              <a:t>마산합포구는</a:t>
+            </a:r>
+            <a:endParaRPr lang="en-US" sz="1200" dirty="0"/>
+          </a:p>
+          <a:p>
+            <a:pPr indent="0" marL="0">
+              <a:lnSpc>
+                <a:spcPct val="110000"/>
+              </a:lnSpc>
+              <a:buNone/>
+            </a:pPr>
+            <a:r>
+              <a:rPr lang="en-US" sz="1200" dirty="0">
+                <a:solidFill>
+                  <a:srgbClr val="334155"/>
+                </a:solidFill>
+                <a:latin typeface="Malgun Gothic" pitchFamily="34" charset="0"/>
+                <a:ea typeface="Malgun Gothic" pitchFamily="34" charset="-122"/>
+                <a:cs typeface="Malgun Gothic" pitchFamily="34" charset="-120"/>
+              </a:rPr>
+              <a:t>인명피해가 창원 최다</a:t>
             </a:r>
             <a:endParaRPr lang="en-US" sz="1200" dirty="0"/>
           </a:p>
@@ -14392,7 +14832,27 @@
                 <a:ea typeface="Malgun Gothic" pitchFamily="34" charset="-122"/>
                 <a:cs typeface="Malgun Gothic" pitchFamily="34" charset="-120"/>
               </a:rPr>
-              <a:t>최근 1년 창원 화재 발생지점(🔥)을 지도에 올린다</a:t>
+              <a:t>최근 1년 창원 화재 발생지점(🔥)을</a:t>
+            </a:r>
+            <a:endParaRPr lang="en-US" sz="1050" dirty="0"/>
+          </a:p>
+          <a:p>
+            <a:pPr indent="0" marL="0">
+              <a:lnSpc>
+                <a:spcPct val="105000"/>
+              </a:lnSpc>
+              <a:buNone/>
+            </a:pPr>
+            <a:r>
+              <a:rPr lang="en-US" sz="1050" dirty="0">
+                <a:solidFill>
+                  <a:srgbClr val="334155"/>
+                </a:solidFill>
+                <a:latin typeface="Malgun Gothic" pitchFamily="34" charset="0"/>
+                <a:ea typeface="Malgun Gothic" pitchFamily="34" charset="-122"/>
+                <a:cs typeface="Malgun Gothic" pitchFamily="34" charset="-120"/>
+              </a:rPr>
+              <a:t>지도에 올린다</a:t>
             </a:r>
             <a:endParaRPr lang="en-US" sz="1050" dirty="0"/>
           </a:p>
@@ -14559,7 +15019,27 @@
                 <a:ea typeface="Malgun Gothic" pitchFamily="34" charset="-122"/>
                 <a:cs typeface="Malgun Gothic" pitchFamily="34" charset="-120"/>
               </a:rPr>
-              <a:t>소방서에서 각 지점까지 하늘색 주행경로를 그린다</a:t>
+              <a:t>소방서에서 각 지점까지</a:t>
+            </a:r>
+            <a:endParaRPr lang="en-US" sz="1050" dirty="0"/>
+          </a:p>
+          <a:p>
+            <a:pPr indent="0" marL="0">
+              <a:lnSpc>
+                <a:spcPct val="105000"/>
+              </a:lnSpc>
+              <a:buNone/>
+            </a:pPr>
+            <a:r>
+              <a:rPr lang="en-US" sz="1050" dirty="0">
+                <a:solidFill>
+                  <a:srgbClr val="334155"/>
+                </a:solidFill>
+                <a:latin typeface="Malgun Gothic" pitchFamily="34" charset="0"/>
+                <a:ea typeface="Malgun Gothic" pitchFamily="34" charset="-122"/>
+                <a:cs typeface="Malgun Gothic" pitchFamily="34" charset="-120"/>
+              </a:rPr>
+              <a:t>하늘색 주행경로를 그린다</a:t>
             </a:r>
             <a:endParaRPr lang="en-US" sz="1050" dirty="0"/>
           </a:p>
@@ -14726,7 +15206,27 @@
                 <a:ea typeface="Malgun Gothic" pitchFamily="34" charset="-122"/>
                 <a:cs typeface="Malgun Gothic" pitchFamily="34" charset="-120"/>
               </a:rPr>
-              <a:t>경로 중 폭 4m 미만 구간을 빨간 점선으로 표시</a:t>
+              <a:t>경로 중 폭 4m 미만 구간을</a:t>
+            </a:r>
+            <a:endParaRPr lang="en-US" sz="1050" dirty="0"/>
+          </a:p>
+          <a:p>
+            <a:pPr indent="0" marL="0">
+              <a:lnSpc>
+                <a:spcPct val="105000"/>
+              </a:lnSpc>
+              <a:buNone/>
+            </a:pPr>
+            <a:r>
+              <a:rPr lang="en-US" sz="1050" dirty="0">
+                <a:solidFill>
+                  <a:srgbClr val="334155"/>
+                </a:solidFill>
+                <a:latin typeface="Malgun Gothic" pitchFamily="34" charset="0"/>
+                <a:ea typeface="Malgun Gothic" pitchFamily="34" charset="-122"/>
+                <a:cs typeface="Malgun Gothic" pitchFamily="34" charset="-120"/>
+              </a:rPr>
+              <a:t>빨간 점선으로 표시</a:t>
             </a:r>
             <a:endParaRPr lang="en-US" sz="1050" dirty="0"/>
           </a:p>
@@ -14893,7 +15393,27 @@
                 <a:ea typeface="Malgun Gothic" pitchFamily="34" charset="-122"/>
                 <a:cs typeface="Malgun Gothic" pitchFamily="34" charset="-120"/>
               </a:rPr>
-              <a:t>빨간 점선이 걸린 화재지점 = 드론이 가장 필요한 곳</a:t>
+              <a:t>빨간 점선이 걸린 화재지점 =</a:t>
+            </a:r>
+            <a:endParaRPr lang="en-US" sz="1050" dirty="0"/>
+          </a:p>
+          <a:p>
+            <a:pPr indent="0" marL="0">
+              <a:lnSpc>
+                <a:spcPct val="105000"/>
+              </a:lnSpc>
+              <a:buNone/>
+            </a:pPr>
+            <a:r>
+              <a:rPr lang="en-US" sz="1050" dirty="0">
+                <a:solidFill>
+                  <a:srgbClr val="334155"/>
+                </a:solidFill>
+                <a:latin typeface="Malgun Gothic" pitchFamily="34" charset="0"/>
+                <a:ea typeface="Malgun Gothic" pitchFamily="34" charset="-122"/>
+                <a:cs typeface="Malgun Gothic" pitchFamily="34" charset="-120"/>
+              </a:rPr>
+              <a:t>드론이 가장 필요한 곳</a:t>
             </a:r>
             <a:endParaRPr lang="en-US" sz="1050" dirty="0"/>
           </a:p>

</xml_diff>